<commit_message>
Adjust summary table divider lines
</commit_message>
<xml_diff>
--- a/output/sigma_summary_latest.pptx
+++ b/output/sigma_summary_latest.pptx
@@ -3558,9 +3558,9 @@
                       </a:solidFill>
                       <a:prstDash val="solid"/>
                     </a:lnL>
-                    <a:lnR algn="ctr" cmpd="sng" cap="flat" w="10160">
-                      <a:solidFill>
-                        <a:srgbClr val="8C8C8C">
+                    <a:lnR algn="ctr" cmpd="sng" cap="flat" w="4445">
+                      <a:solidFill>
+                        <a:srgbClr val="CCCCCC">
                           <a:alpha val="100000"/>
                         </a:srgbClr>
                       </a:solidFill>
@@ -3623,9 +3623,9 @@
                       <a:noFill/>
                       <a:prstDash val="solid"/>
                     </a:lnL>
-                    <a:lnR algn="ctr" cmpd="sng" cap="flat" w="10160">
-                      <a:solidFill>
-                        <a:srgbClr val="8C8C8C">
+                    <a:lnR algn="ctr" cmpd="sng" cap="flat" w="4445">
+                      <a:solidFill>
+                        <a:srgbClr val="CCCCCC">
                           <a:alpha val="100000"/>
                         </a:srgbClr>
                       </a:solidFill>
@@ -3684,9 +3684,9 @@
                     </a:p>
                   </a:txBody>
                   <a:tcPr anchor="ctr" marB="12700" marT="12700" marR="0" marL="0">
-                    <a:lnL algn="ctr" cmpd="sng" cap="flat" w="10160">
-                      <a:solidFill>
-                        <a:srgbClr val="8C8C8C">
+                    <a:lnL algn="ctr" cmpd="sng" cap="flat" w="4445">
+                      <a:solidFill>
+                        <a:srgbClr val="CCCCCC">
                           <a:alpha val="100000"/>
                         </a:srgbClr>
                       </a:solidFill>
@@ -3814,8 +3814,12 @@
                       <a:noFill/>
                       <a:prstDash val="solid"/>
                     </a:lnL>
-                    <a:lnR algn="ctr" cmpd="sng" cap="flat" w="0">
-                      <a:noFill/>
+                    <a:lnR algn="ctr" cmpd="sng" cap="flat" w="10160">
+                      <a:solidFill>
+                        <a:srgbClr val="8C8C8C">
+                          <a:alpha val="100000"/>
+                        </a:srgbClr>
+                      </a:solidFill>
                       <a:prstDash val="solid"/>
                     </a:lnR>
                     <a:lnT algn="ctr" cmpd="sng" cap="flat" w="15240">
@@ -3875,12 +3879,20 @@
                     </a:p>
                   </a:txBody>
                   <a:tcPr anchor="ctr" marB="12700" marT="12700" marR="0" marL="0">
-                    <a:lnL algn="ctr" cmpd="sng" cap="flat" w="0">
-                      <a:noFill/>
+                    <a:lnL algn="ctr" cmpd="sng" cap="flat" w="10160">
+                      <a:solidFill>
+                        <a:srgbClr val="8C8C8C">
+                          <a:alpha val="100000"/>
+                        </a:srgbClr>
+                      </a:solidFill>
                       <a:prstDash val="solid"/>
                     </a:lnL>
-                    <a:lnR algn="ctr" cmpd="sng" cap="flat" w="0">
-                      <a:noFill/>
+                    <a:lnR algn="ctr" cmpd="sng" cap="flat" w="10160">
+                      <a:solidFill>
+                        <a:srgbClr val="8C8C8C">
+                          <a:alpha val="100000"/>
+                        </a:srgbClr>
+                      </a:solidFill>
                       <a:prstDash val="solid"/>
                     </a:lnR>
                     <a:lnT algn="ctr" cmpd="sng" cap="flat" w="15240">
@@ -3940,8 +3952,12 @@
                     </a:p>
                   </a:txBody>
                   <a:tcPr anchor="ctr" marB="12700" marT="12700" marR="0" marL="0">
-                    <a:lnL algn="ctr" cmpd="sng" cap="flat" w="0">
-                      <a:noFill/>
+                    <a:lnL algn="ctr" cmpd="sng" cap="flat" w="10160">
+                      <a:solidFill>
+                        <a:srgbClr val="8C8C8C">
+                          <a:alpha val="100000"/>
+                        </a:srgbClr>
+                      </a:solidFill>
                       <a:prstDash val="solid"/>
                     </a:lnL>
                     <a:lnR algn="ctr" cmpd="sng" cap="flat" w="0">
@@ -4332,9 +4348,9 @@
                       <a:noFill/>
                       <a:prstDash val="solid"/>
                     </a:lnL>
-                    <a:lnR algn="ctr" cmpd="sng" cap="flat" w="10160">
-                      <a:solidFill>
-                        <a:srgbClr val="8C8C8C">
+                    <a:lnR algn="ctr" cmpd="sng" cap="flat" w="4445">
+                      <a:solidFill>
+                        <a:srgbClr val="CCCCCC">
                           <a:alpha val="100000"/>
                         </a:srgbClr>
                       </a:solidFill>
@@ -4393,9 +4409,9 @@
                     </a:p>
                   </a:txBody>
                   <a:tcPr anchor="ctr" marB="12700" marT="12700" marR="0" marL="0">
-                    <a:lnL algn="ctr" cmpd="sng" cap="flat" w="10160">
-                      <a:solidFill>
-                        <a:srgbClr val="8C8C8C">
+                    <a:lnL algn="ctr" cmpd="sng" cap="flat" w="4445">
+                      <a:solidFill>
+                        <a:srgbClr val="CCCCCC">
                           <a:alpha val="100000"/>
                         </a:srgbClr>
                       </a:solidFill>
@@ -4523,8 +4539,12 @@
                       <a:noFill/>
                       <a:prstDash val="solid"/>
                     </a:lnL>
-                    <a:lnR algn="ctr" cmpd="sng" cap="flat" w="0">
-                      <a:noFill/>
+                    <a:lnR algn="ctr" cmpd="sng" cap="flat" w="10160">
+                      <a:solidFill>
+                        <a:srgbClr val="8C8C8C">
+                          <a:alpha val="100000"/>
+                        </a:srgbClr>
+                      </a:solidFill>
                       <a:prstDash val="solid"/>
                     </a:lnR>
                     <a:lnT algn="ctr" cmpd="sng" cap="flat" w="0">
@@ -4580,12 +4600,20 @@
                     </a:p>
                   </a:txBody>
                   <a:tcPr anchor="ctr" marB="12700" marT="12700" marR="0" marL="0">
-                    <a:lnL algn="ctr" cmpd="sng" cap="flat" w="0">
-                      <a:noFill/>
+                    <a:lnL algn="ctr" cmpd="sng" cap="flat" w="10160">
+                      <a:solidFill>
+                        <a:srgbClr val="8C8C8C">
+                          <a:alpha val="100000"/>
+                        </a:srgbClr>
+                      </a:solidFill>
                       <a:prstDash val="solid"/>
                     </a:lnL>
-                    <a:lnR algn="ctr" cmpd="sng" cap="flat" w="0">
-                      <a:noFill/>
+                    <a:lnR algn="ctr" cmpd="sng" cap="flat" w="10160">
+                      <a:solidFill>
+                        <a:srgbClr val="8C8C8C">
+                          <a:alpha val="100000"/>
+                        </a:srgbClr>
+                      </a:solidFill>
                       <a:prstDash val="solid"/>
                     </a:lnR>
                     <a:lnT algn="ctr" cmpd="sng" cap="flat" w="0">
@@ -4641,8 +4669,12 @@
                     </a:p>
                   </a:txBody>
                   <a:tcPr anchor="ctr" marB="12700" marT="12700" marR="0" marL="0">
-                    <a:lnL algn="ctr" cmpd="sng" cap="flat" w="0">
-                      <a:noFill/>
+                    <a:lnL algn="ctr" cmpd="sng" cap="flat" w="10160">
+                      <a:solidFill>
+                        <a:srgbClr val="8C8C8C">
+                          <a:alpha val="100000"/>
+                        </a:srgbClr>
+                      </a:solidFill>
                       <a:prstDash val="solid"/>
                     </a:lnL>
                     <a:lnR algn="ctr" cmpd="sng" cap="flat" w="0">
@@ -5029,9 +5061,9 @@
                       <a:noFill/>
                       <a:prstDash val="solid"/>
                     </a:lnL>
-                    <a:lnR algn="ctr" cmpd="sng" cap="flat" w="10160">
-                      <a:solidFill>
-                        <a:srgbClr val="8C8C8C">
+                    <a:lnR algn="ctr" cmpd="sng" cap="flat" w="4445">
+                      <a:solidFill>
+                        <a:srgbClr val="CCCCCC">
                           <a:alpha val="100000"/>
                         </a:srgbClr>
                       </a:solidFill>
@@ -5090,9 +5122,9 @@
                     </a:p>
                   </a:txBody>
                   <a:tcPr anchor="ctr" marB="12700" marT="12700" marR="0" marL="0">
-                    <a:lnL algn="ctr" cmpd="sng" cap="flat" w="10160">
-                      <a:solidFill>
-                        <a:srgbClr val="8C8C8C">
+                    <a:lnL algn="ctr" cmpd="sng" cap="flat" w="4445">
+                      <a:solidFill>
+                        <a:srgbClr val="CCCCCC">
                           <a:alpha val="100000"/>
                         </a:srgbClr>
                       </a:solidFill>
@@ -5220,8 +5252,12 @@
                       <a:noFill/>
                       <a:prstDash val="solid"/>
                     </a:lnL>
-                    <a:lnR algn="ctr" cmpd="sng" cap="flat" w="0">
-                      <a:noFill/>
+                    <a:lnR algn="ctr" cmpd="sng" cap="flat" w="10160">
+                      <a:solidFill>
+                        <a:srgbClr val="8C8C8C">
+                          <a:alpha val="100000"/>
+                        </a:srgbClr>
+                      </a:solidFill>
                       <a:prstDash val="solid"/>
                     </a:lnR>
                     <a:lnT algn="ctr" cmpd="sng" cap="flat" w="0">
@@ -5277,12 +5313,20 @@
                     </a:p>
                   </a:txBody>
                   <a:tcPr anchor="ctr" marB="12700" marT="12700" marR="0" marL="0">
-                    <a:lnL algn="ctr" cmpd="sng" cap="flat" w="0">
-                      <a:noFill/>
+                    <a:lnL algn="ctr" cmpd="sng" cap="flat" w="10160">
+                      <a:solidFill>
+                        <a:srgbClr val="8C8C8C">
+                          <a:alpha val="100000"/>
+                        </a:srgbClr>
+                      </a:solidFill>
                       <a:prstDash val="solid"/>
                     </a:lnL>
-                    <a:lnR algn="ctr" cmpd="sng" cap="flat" w="0">
-                      <a:noFill/>
+                    <a:lnR algn="ctr" cmpd="sng" cap="flat" w="10160">
+                      <a:solidFill>
+                        <a:srgbClr val="8C8C8C">
+                          <a:alpha val="100000"/>
+                        </a:srgbClr>
+                      </a:solidFill>
                       <a:prstDash val="solid"/>
                     </a:lnR>
                     <a:lnT algn="ctr" cmpd="sng" cap="flat" w="0">
@@ -5338,8 +5382,12 @@
                     </a:p>
                   </a:txBody>
                   <a:tcPr anchor="ctr" marB="12700" marT="12700" marR="0" marL="0">
-                    <a:lnL algn="ctr" cmpd="sng" cap="flat" w="0">
-                      <a:noFill/>
+                    <a:lnL algn="ctr" cmpd="sng" cap="flat" w="10160">
+                      <a:solidFill>
+                        <a:srgbClr val="8C8C8C">
+                          <a:alpha val="100000"/>
+                        </a:srgbClr>
+                      </a:solidFill>
                       <a:prstDash val="solid"/>
                     </a:lnL>
                     <a:lnR algn="ctr" cmpd="sng" cap="flat" w="0">
@@ -5746,9 +5794,9 @@
                       <a:noFill/>
                       <a:prstDash val="solid"/>
                     </a:lnL>
-                    <a:lnR algn="ctr" cmpd="sng" cap="flat" w="10160">
-                      <a:solidFill>
-                        <a:srgbClr val="8C8C8C">
+                    <a:lnR algn="ctr" cmpd="sng" cap="flat" w="4445">
+                      <a:solidFill>
+                        <a:srgbClr val="CCCCCC">
                           <a:alpha val="100000"/>
                         </a:srgbClr>
                       </a:solidFill>
@@ -5811,9 +5859,9 @@
                     </a:p>
                   </a:txBody>
                   <a:tcPr anchor="ctr" marB="12700" marT="12700" marR="0" marL="0">
-                    <a:lnL algn="ctr" cmpd="sng" cap="flat" w="10160">
-                      <a:solidFill>
-                        <a:srgbClr val="8C8C8C">
+                    <a:lnL algn="ctr" cmpd="sng" cap="flat" w="4445">
+                      <a:solidFill>
+                        <a:srgbClr val="CCCCCC">
                           <a:alpha val="100000"/>
                         </a:srgbClr>
                       </a:solidFill>
@@ -5949,8 +5997,12 @@
                       <a:noFill/>
                       <a:prstDash val="solid"/>
                     </a:lnL>
-                    <a:lnR algn="ctr" cmpd="sng" cap="flat" w="0">
-                      <a:noFill/>
+                    <a:lnR algn="ctr" cmpd="sng" cap="flat" w="10160">
+                      <a:solidFill>
+                        <a:srgbClr val="8C8C8C">
+                          <a:alpha val="100000"/>
+                        </a:srgbClr>
+                      </a:solidFill>
                       <a:prstDash val="solid"/>
                     </a:lnR>
                     <a:lnT algn="ctr" cmpd="sng" cap="flat" w="4445">
@@ -6010,12 +6062,20 @@
                     </a:p>
                   </a:txBody>
                   <a:tcPr anchor="ctr" marB="12700" marT="12700" marR="0" marL="0">
-                    <a:lnL algn="ctr" cmpd="sng" cap="flat" w="0">
-                      <a:noFill/>
+                    <a:lnL algn="ctr" cmpd="sng" cap="flat" w="10160">
+                      <a:solidFill>
+                        <a:srgbClr val="8C8C8C">
+                          <a:alpha val="100000"/>
+                        </a:srgbClr>
+                      </a:solidFill>
                       <a:prstDash val="solid"/>
                     </a:lnL>
-                    <a:lnR algn="ctr" cmpd="sng" cap="flat" w="0">
-                      <a:noFill/>
+                    <a:lnR algn="ctr" cmpd="sng" cap="flat" w="10160">
+                      <a:solidFill>
+                        <a:srgbClr val="8C8C8C">
+                          <a:alpha val="100000"/>
+                        </a:srgbClr>
+                      </a:solidFill>
                       <a:prstDash val="solid"/>
                     </a:lnR>
                     <a:lnT algn="ctr" cmpd="sng" cap="flat" w="4445">
@@ -6075,8 +6135,12 @@
                     </a:p>
                   </a:txBody>
                   <a:tcPr anchor="ctr" marB="12700" marT="12700" marR="0" marL="0">
-                    <a:lnL algn="ctr" cmpd="sng" cap="flat" w="0">
-                      <a:noFill/>
+                    <a:lnL algn="ctr" cmpd="sng" cap="flat" w="10160">
+                      <a:solidFill>
+                        <a:srgbClr val="8C8C8C">
+                          <a:alpha val="100000"/>
+                        </a:srgbClr>
+                      </a:solidFill>
                       <a:prstDash val="solid"/>
                     </a:lnL>
                     <a:lnR algn="ctr" cmpd="sng" cap="flat" w="0">
@@ -6487,9 +6551,9 @@
                       <a:noFill/>
                       <a:prstDash val="solid"/>
                     </a:lnL>
-                    <a:lnR algn="ctr" cmpd="sng" cap="flat" w="10160">
-                      <a:solidFill>
-                        <a:srgbClr val="8C8C8C">
+                    <a:lnR algn="ctr" cmpd="sng" cap="flat" w="4445">
+                      <a:solidFill>
+                        <a:srgbClr val="CCCCCC">
                           <a:alpha val="100000"/>
                         </a:srgbClr>
                       </a:solidFill>
@@ -6552,9 +6616,9 @@
                     </a:p>
                   </a:txBody>
                   <a:tcPr anchor="ctr" marB="12700" marT="12700" marR="0" marL="0">
-                    <a:lnL algn="ctr" cmpd="sng" cap="flat" w="10160">
-                      <a:solidFill>
-                        <a:srgbClr val="8C8C8C">
+                    <a:lnL algn="ctr" cmpd="sng" cap="flat" w="4445">
+                      <a:solidFill>
+                        <a:srgbClr val="CCCCCC">
                           <a:alpha val="100000"/>
                         </a:srgbClr>
                       </a:solidFill>
@@ -6690,8 +6754,12 @@
                       <a:noFill/>
                       <a:prstDash val="solid"/>
                     </a:lnL>
-                    <a:lnR algn="ctr" cmpd="sng" cap="flat" w="0">
-                      <a:noFill/>
+                    <a:lnR algn="ctr" cmpd="sng" cap="flat" w="10160">
+                      <a:solidFill>
+                        <a:srgbClr val="8C8C8C">
+                          <a:alpha val="100000"/>
+                        </a:srgbClr>
+                      </a:solidFill>
                       <a:prstDash val="solid"/>
                     </a:lnR>
                     <a:lnT algn="ctr" cmpd="sng" cap="flat" w="4445">
@@ -6751,12 +6819,20 @@
                     </a:p>
                   </a:txBody>
                   <a:tcPr anchor="ctr" marB="12700" marT="12700" marR="0" marL="0">
-                    <a:lnL algn="ctr" cmpd="sng" cap="flat" w="0">
-                      <a:noFill/>
+                    <a:lnL algn="ctr" cmpd="sng" cap="flat" w="10160">
+                      <a:solidFill>
+                        <a:srgbClr val="8C8C8C">
+                          <a:alpha val="100000"/>
+                        </a:srgbClr>
+                      </a:solidFill>
                       <a:prstDash val="solid"/>
                     </a:lnL>
-                    <a:lnR algn="ctr" cmpd="sng" cap="flat" w="0">
-                      <a:noFill/>
+                    <a:lnR algn="ctr" cmpd="sng" cap="flat" w="10160">
+                      <a:solidFill>
+                        <a:srgbClr val="8C8C8C">
+                          <a:alpha val="100000"/>
+                        </a:srgbClr>
+                      </a:solidFill>
                       <a:prstDash val="solid"/>
                     </a:lnR>
                     <a:lnT algn="ctr" cmpd="sng" cap="flat" w="4445">
@@ -6816,8 +6892,12 @@
                     </a:p>
                   </a:txBody>
                   <a:tcPr anchor="ctr" marB="12700" marT="12700" marR="0" marL="0">
-                    <a:lnL algn="ctr" cmpd="sng" cap="flat" w="0">
-                      <a:noFill/>
+                    <a:lnL algn="ctr" cmpd="sng" cap="flat" w="10160">
+                      <a:solidFill>
+                        <a:srgbClr val="8C8C8C">
+                          <a:alpha val="100000"/>
+                        </a:srgbClr>
+                      </a:solidFill>
                       <a:prstDash val="solid"/>
                     </a:lnL>
                     <a:lnR algn="ctr" cmpd="sng" cap="flat" w="0">
@@ -7228,9 +7308,9 @@
                       <a:noFill/>
                       <a:prstDash val="solid"/>
                     </a:lnL>
-                    <a:lnR algn="ctr" cmpd="sng" cap="flat" w="10160">
-                      <a:solidFill>
-                        <a:srgbClr val="8C8C8C">
+                    <a:lnR algn="ctr" cmpd="sng" cap="flat" w="4445">
+                      <a:solidFill>
+                        <a:srgbClr val="CCCCCC">
                           <a:alpha val="100000"/>
                         </a:srgbClr>
                       </a:solidFill>
@@ -7293,9 +7373,9 @@
                     </a:p>
                   </a:txBody>
                   <a:tcPr anchor="ctr" marB="12700" marT="12700" marR="0" marL="0">
-                    <a:lnL algn="ctr" cmpd="sng" cap="flat" w="10160">
-                      <a:solidFill>
-                        <a:srgbClr val="8C8C8C">
+                    <a:lnL algn="ctr" cmpd="sng" cap="flat" w="4445">
+                      <a:solidFill>
+                        <a:srgbClr val="CCCCCC">
                           <a:alpha val="100000"/>
                         </a:srgbClr>
                       </a:solidFill>
@@ -7431,8 +7511,12 @@
                       <a:noFill/>
                       <a:prstDash val="solid"/>
                     </a:lnL>
-                    <a:lnR algn="ctr" cmpd="sng" cap="flat" w="0">
-                      <a:noFill/>
+                    <a:lnR algn="ctr" cmpd="sng" cap="flat" w="10160">
+                      <a:solidFill>
+                        <a:srgbClr val="8C8C8C">
+                          <a:alpha val="100000"/>
+                        </a:srgbClr>
+                      </a:solidFill>
                       <a:prstDash val="solid"/>
                     </a:lnR>
                     <a:lnT algn="ctr" cmpd="sng" cap="flat" w="4445">
@@ -7492,12 +7576,20 @@
                     </a:p>
                   </a:txBody>
                   <a:tcPr anchor="ctr" marB="12700" marT="12700" marR="0" marL="0">
-                    <a:lnL algn="ctr" cmpd="sng" cap="flat" w="0">
-                      <a:noFill/>
+                    <a:lnL algn="ctr" cmpd="sng" cap="flat" w="10160">
+                      <a:solidFill>
+                        <a:srgbClr val="8C8C8C">
+                          <a:alpha val="100000"/>
+                        </a:srgbClr>
+                      </a:solidFill>
                       <a:prstDash val="solid"/>
                     </a:lnL>
-                    <a:lnR algn="ctr" cmpd="sng" cap="flat" w="0">
-                      <a:noFill/>
+                    <a:lnR algn="ctr" cmpd="sng" cap="flat" w="10160">
+                      <a:solidFill>
+                        <a:srgbClr val="8C8C8C">
+                          <a:alpha val="100000"/>
+                        </a:srgbClr>
+                      </a:solidFill>
                       <a:prstDash val="solid"/>
                     </a:lnR>
                     <a:lnT algn="ctr" cmpd="sng" cap="flat" w="4445">
@@ -7557,8 +7649,12 @@
                     </a:p>
                   </a:txBody>
                   <a:tcPr anchor="ctr" marB="12700" marT="12700" marR="0" marL="0">
-                    <a:lnL algn="ctr" cmpd="sng" cap="flat" w="0">
-                      <a:noFill/>
+                    <a:lnL algn="ctr" cmpd="sng" cap="flat" w="10160">
+                      <a:solidFill>
+                        <a:srgbClr val="8C8C8C">
+                          <a:alpha val="100000"/>
+                        </a:srgbClr>
+                      </a:solidFill>
                       <a:prstDash val="solid"/>
                     </a:lnL>
                     <a:lnR algn="ctr" cmpd="sng" cap="flat" w="0">
@@ -7969,9 +8065,9 @@
                       <a:noFill/>
                       <a:prstDash val="solid"/>
                     </a:lnL>
-                    <a:lnR algn="ctr" cmpd="sng" cap="flat" w="10160">
-                      <a:solidFill>
-                        <a:srgbClr val="8C8C8C">
+                    <a:lnR algn="ctr" cmpd="sng" cap="flat" w="4445">
+                      <a:solidFill>
+                        <a:srgbClr val="CCCCCC">
                           <a:alpha val="100000"/>
                         </a:srgbClr>
                       </a:solidFill>
@@ -8034,9 +8130,9 @@
                     </a:p>
                   </a:txBody>
                   <a:tcPr anchor="ctr" marB="12700" marT="12700" marR="0" marL="0">
-                    <a:lnL algn="ctr" cmpd="sng" cap="flat" w="10160">
-                      <a:solidFill>
-                        <a:srgbClr val="8C8C8C">
+                    <a:lnL algn="ctr" cmpd="sng" cap="flat" w="4445">
+                      <a:solidFill>
+                        <a:srgbClr val="CCCCCC">
                           <a:alpha val="100000"/>
                         </a:srgbClr>
                       </a:solidFill>
@@ -8172,8 +8268,12 @@
                       <a:noFill/>
                       <a:prstDash val="solid"/>
                     </a:lnL>
-                    <a:lnR algn="ctr" cmpd="sng" cap="flat" w="0">
-                      <a:noFill/>
+                    <a:lnR algn="ctr" cmpd="sng" cap="flat" w="10160">
+                      <a:solidFill>
+                        <a:srgbClr val="8C8C8C">
+                          <a:alpha val="100000"/>
+                        </a:srgbClr>
+                      </a:solidFill>
                       <a:prstDash val="solid"/>
                     </a:lnR>
                     <a:lnT algn="ctr" cmpd="sng" cap="flat" w="4445">
@@ -8233,12 +8333,20 @@
                     </a:p>
                   </a:txBody>
                   <a:tcPr anchor="ctr" marB="12700" marT="12700" marR="0" marL="0">
-                    <a:lnL algn="ctr" cmpd="sng" cap="flat" w="0">
-                      <a:noFill/>
+                    <a:lnL algn="ctr" cmpd="sng" cap="flat" w="10160">
+                      <a:solidFill>
+                        <a:srgbClr val="8C8C8C">
+                          <a:alpha val="100000"/>
+                        </a:srgbClr>
+                      </a:solidFill>
                       <a:prstDash val="solid"/>
                     </a:lnL>
-                    <a:lnR algn="ctr" cmpd="sng" cap="flat" w="0">
-                      <a:noFill/>
+                    <a:lnR algn="ctr" cmpd="sng" cap="flat" w="10160">
+                      <a:solidFill>
+                        <a:srgbClr val="8C8C8C">
+                          <a:alpha val="100000"/>
+                        </a:srgbClr>
+                      </a:solidFill>
                       <a:prstDash val="solid"/>
                     </a:lnR>
                     <a:lnT algn="ctr" cmpd="sng" cap="flat" w="4445">
@@ -8298,8 +8406,12 @@
                     </a:p>
                   </a:txBody>
                   <a:tcPr anchor="ctr" marB="12700" marT="12700" marR="0" marL="0">
-                    <a:lnL algn="ctr" cmpd="sng" cap="flat" w="0">
-                      <a:noFill/>
+                    <a:lnL algn="ctr" cmpd="sng" cap="flat" w="10160">
+                      <a:solidFill>
+                        <a:srgbClr val="8C8C8C">
+                          <a:alpha val="100000"/>
+                        </a:srgbClr>
+                      </a:solidFill>
                       <a:prstDash val="solid"/>
                     </a:lnL>
                     <a:lnR algn="ctr" cmpd="sng" cap="flat" w="0">
@@ -8710,9 +8822,9 @@
                       <a:noFill/>
                       <a:prstDash val="solid"/>
                     </a:lnL>
-                    <a:lnR algn="ctr" cmpd="sng" cap="flat" w="10160">
-                      <a:solidFill>
-                        <a:srgbClr val="8C8C8C">
+                    <a:lnR algn="ctr" cmpd="sng" cap="flat" w="4445">
+                      <a:solidFill>
+                        <a:srgbClr val="CCCCCC">
                           <a:alpha val="100000"/>
                         </a:srgbClr>
                       </a:solidFill>
@@ -8775,9 +8887,9 @@
                     </a:p>
                   </a:txBody>
                   <a:tcPr anchor="ctr" marB="12700" marT="12700" marR="0" marL="0">
-                    <a:lnL algn="ctr" cmpd="sng" cap="flat" w="10160">
-                      <a:solidFill>
-                        <a:srgbClr val="8C8C8C">
+                    <a:lnL algn="ctr" cmpd="sng" cap="flat" w="4445">
+                      <a:solidFill>
+                        <a:srgbClr val="CCCCCC">
                           <a:alpha val="100000"/>
                         </a:srgbClr>
                       </a:solidFill>
@@ -8913,8 +9025,12 @@
                       <a:noFill/>
                       <a:prstDash val="solid"/>
                     </a:lnL>
-                    <a:lnR algn="ctr" cmpd="sng" cap="flat" w="0">
-                      <a:noFill/>
+                    <a:lnR algn="ctr" cmpd="sng" cap="flat" w="10160">
+                      <a:solidFill>
+                        <a:srgbClr val="8C8C8C">
+                          <a:alpha val="100000"/>
+                        </a:srgbClr>
+                      </a:solidFill>
                       <a:prstDash val="solid"/>
                     </a:lnR>
                     <a:lnT algn="ctr" cmpd="sng" cap="flat" w="4445">
@@ -8974,12 +9090,20 @@
                     </a:p>
                   </a:txBody>
                   <a:tcPr anchor="ctr" marB="12700" marT="12700" marR="0" marL="0">
-                    <a:lnL algn="ctr" cmpd="sng" cap="flat" w="0">
-                      <a:noFill/>
+                    <a:lnL algn="ctr" cmpd="sng" cap="flat" w="10160">
+                      <a:solidFill>
+                        <a:srgbClr val="8C8C8C">
+                          <a:alpha val="100000"/>
+                        </a:srgbClr>
+                      </a:solidFill>
                       <a:prstDash val="solid"/>
                     </a:lnL>
-                    <a:lnR algn="ctr" cmpd="sng" cap="flat" w="0">
-                      <a:noFill/>
+                    <a:lnR algn="ctr" cmpd="sng" cap="flat" w="10160">
+                      <a:solidFill>
+                        <a:srgbClr val="8C8C8C">
+                          <a:alpha val="100000"/>
+                        </a:srgbClr>
+                      </a:solidFill>
                       <a:prstDash val="solid"/>
                     </a:lnR>
                     <a:lnT algn="ctr" cmpd="sng" cap="flat" w="4445">
@@ -9039,8 +9163,12 @@
                     </a:p>
                   </a:txBody>
                   <a:tcPr anchor="ctr" marB="12700" marT="12700" marR="0" marL="0">
-                    <a:lnL algn="ctr" cmpd="sng" cap="flat" w="0">
-                      <a:noFill/>
+                    <a:lnL algn="ctr" cmpd="sng" cap="flat" w="10160">
+                      <a:solidFill>
+                        <a:srgbClr val="8C8C8C">
+                          <a:alpha val="100000"/>
+                        </a:srgbClr>
+                      </a:solidFill>
                       <a:prstDash val="solid"/>
                     </a:lnL>
                     <a:lnR algn="ctr" cmpd="sng" cap="flat" w="0">
@@ -9451,9 +9579,9 @@
                       <a:noFill/>
                       <a:prstDash val="solid"/>
                     </a:lnL>
-                    <a:lnR algn="ctr" cmpd="sng" cap="flat" w="10160">
-                      <a:solidFill>
-                        <a:srgbClr val="8C8C8C">
+                    <a:lnR algn="ctr" cmpd="sng" cap="flat" w="4445">
+                      <a:solidFill>
+                        <a:srgbClr val="CCCCCC">
                           <a:alpha val="100000"/>
                         </a:srgbClr>
                       </a:solidFill>
@@ -9516,9 +9644,9 @@
                     </a:p>
                   </a:txBody>
                   <a:tcPr anchor="ctr" marB="12700" marT="12700" marR="0" marL="0">
-                    <a:lnL algn="ctr" cmpd="sng" cap="flat" w="10160">
-                      <a:solidFill>
-                        <a:srgbClr val="8C8C8C">
+                    <a:lnL algn="ctr" cmpd="sng" cap="flat" w="4445">
+                      <a:solidFill>
+                        <a:srgbClr val="CCCCCC">
                           <a:alpha val="100000"/>
                         </a:srgbClr>
                       </a:solidFill>
@@ -9654,8 +9782,12 @@
                       <a:noFill/>
                       <a:prstDash val="solid"/>
                     </a:lnL>
-                    <a:lnR algn="ctr" cmpd="sng" cap="flat" w="0">
-                      <a:noFill/>
+                    <a:lnR algn="ctr" cmpd="sng" cap="flat" w="10160">
+                      <a:solidFill>
+                        <a:srgbClr val="8C8C8C">
+                          <a:alpha val="100000"/>
+                        </a:srgbClr>
+                      </a:solidFill>
                       <a:prstDash val="solid"/>
                     </a:lnR>
                     <a:lnT algn="ctr" cmpd="sng" cap="flat" w="4445">
@@ -9715,12 +9847,20 @@
                     </a:p>
                   </a:txBody>
                   <a:tcPr anchor="ctr" marB="12700" marT="12700" marR="0" marL="0">
-                    <a:lnL algn="ctr" cmpd="sng" cap="flat" w="0">
-                      <a:noFill/>
+                    <a:lnL algn="ctr" cmpd="sng" cap="flat" w="10160">
+                      <a:solidFill>
+                        <a:srgbClr val="8C8C8C">
+                          <a:alpha val="100000"/>
+                        </a:srgbClr>
+                      </a:solidFill>
                       <a:prstDash val="solid"/>
                     </a:lnL>
-                    <a:lnR algn="ctr" cmpd="sng" cap="flat" w="0">
-                      <a:noFill/>
+                    <a:lnR algn="ctr" cmpd="sng" cap="flat" w="10160">
+                      <a:solidFill>
+                        <a:srgbClr val="8C8C8C">
+                          <a:alpha val="100000"/>
+                        </a:srgbClr>
+                      </a:solidFill>
                       <a:prstDash val="solid"/>
                     </a:lnR>
                     <a:lnT algn="ctr" cmpd="sng" cap="flat" w="4445">
@@ -9780,8 +9920,12 @@
                     </a:p>
                   </a:txBody>
                   <a:tcPr anchor="ctr" marB="12700" marT="12700" marR="0" marL="0">
-                    <a:lnL algn="ctr" cmpd="sng" cap="flat" w="0">
-                      <a:noFill/>
+                    <a:lnL algn="ctr" cmpd="sng" cap="flat" w="10160">
+                      <a:solidFill>
+                        <a:srgbClr val="8C8C8C">
+                          <a:alpha val="100000"/>
+                        </a:srgbClr>
+                      </a:solidFill>
                       <a:prstDash val="solid"/>
                     </a:lnL>
                     <a:lnR algn="ctr" cmpd="sng" cap="flat" w="0">
@@ -10192,9 +10336,9 @@
                       <a:noFill/>
                       <a:prstDash val="solid"/>
                     </a:lnL>
-                    <a:lnR algn="ctr" cmpd="sng" cap="flat" w="10160">
-                      <a:solidFill>
-                        <a:srgbClr val="8C8C8C">
+                    <a:lnR algn="ctr" cmpd="sng" cap="flat" w="4445">
+                      <a:solidFill>
+                        <a:srgbClr val="CCCCCC">
                           <a:alpha val="100000"/>
                         </a:srgbClr>
                       </a:solidFill>
@@ -10257,9 +10401,9 @@
                     </a:p>
                   </a:txBody>
                   <a:tcPr anchor="ctr" marB="12700" marT="12700" marR="0" marL="0">
-                    <a:lnL algn="ctr" cmpd="sng" cap="flat" w="10160">
-                      <a:solidFill>
-                        <a:srgbClr val="8C8C8C">
+                    <a:lnL algn="ctr" cmpd="sng" cap="flat" w="4445">
+                      <a:solidFill>
+                        <a:srgbClr val="CCCCCC">
                           <a:alpha val="100000"/>
                         </a:srgbClr>
                       </a:solidFill>
@@ -10395,8 +10539,12 @@
                       <a:noFill/>
                       <a:prstDash val="solid"/>
                     </a:lnL>
-                    <a:lnR algn="ctr" cmpd="sng" cap="flat" w="0">
-                      <a:noFill/>
+                    <a:lnR algn="ctr" cmpd="sng" cap="flat" w="10160">
+                      <a:solidFill>
+                        <a:srgbClr val="8C8C8C">
+                          <a:alpha val="100000"/>
+                        </a:srgbClr>
+                      </a:solidFill>
                       <a:prstDash val="solid"/>
                     </a:lnR>
                     <a:lnT algn="ctr" cmpd="sng" cap="flat" w="4445">
@@ -10456,12 +10604,20 @@
                     </a:p>
                   </a:txBody>
                   <a:tcPr anchor="ctr" marB="12700" marT="12700" marR="0" marL="0">
-                    <a:lnL algn="ctr" cmpd="sng" cap="flat" w="0">
-                      <a:noFill/>
+                    <a:lnL algn="ctr" cmpd="sng" cap="flat" w="10160">
+                      <a:solidFill>
+                        <a:srgbClr val="8C8C8C">
+                          <a:alpha val="100000"/>
+                        </a:srgbClr>
+                      </a:solidFill>
                       <a:prstDash val="solid"/>
                     </a:lnL>
-                    <a:lnR algn="ctr" cmpd="sng" cap="flat" w="0">
-                      <a:noFill/>
+                    <a:lnR algn="ctr" cmpd="sng" cap="flat" w="10160">
+                      <a:solidFill>
+                        <a:srgbClr val="8C8C8C">
+                          <a:alpha val="100000"/>
+                        </a:srgbClr>
+                      </a:solidFill>
                       <a:prstDash val="solid"/>
                     </a:lnR>
                     <a:lnT algn="ctr" cmpd="sng" cap="flat" w="4445">
@@ -10521,8 +10677,12 @@
                     </a:p>
                   </a:txBody>
                   <a:tcPr anchor="ctr" marB="12700" marT="12700" marR="0" marL="0">
-                    <a:lnL algn="ctr" cmpd="sng" cap="flat" w="0">
-                      <a:noFill/>
+                    <a:lnL algn="ctr" cmpd="sng" cap="flat" w="10160">
+                      <a:solidFill>
+                        <a:srgbClr val="8C8C8C">
+                          <a:alpha val="100000"/>
+                        </a:srgbClr>
+                      </a:solidFill>
                       <a:prstDash val="solid"/>
                     </a:lnL>
                     <a:lnR algn="ctr" cmpd="sng" cap="flat" w="0">
@@ -10933,9 +11093,9 @@
                       <a:noFill/>
                       <a:prstDash val="solid"/>
                     </a:lnL>
-                    <a:lnR algn="ctr" cmpd="sng" cap="flat" w="10160">
-                      <a:solidFill>
-                        <a:srgbClr val="8C8C8C">
+                    <a:lnR algn="ctr" cmpd="sng" cap="flat" w="4445">
+                      <a:solidFill>
+                        <a:srgbClr val="CCCCCC">
                           <a:alpha val="100000"/>
                         </a:srgbClr>
                       </a:solidFill>
@@ -10998,9 +11158,9 @@
                     </a:p>
                   </a:txBody>
                   <a:tcPr anchor="ctr" marB="12700" marT="12700" marR="0" marL="0">
-                    <a:lnL algn="ctr" cmpd="sng" cap="flat" w="10160">
-                      <a:solidFill>
-                        <a:srgbClr val="8C8C8C">
+                    <a:lnL algn="ctr" cmpd="sng" cap="flat" w="4445">
+                      <a:solidFill>
+                        <a:srgbClr val="CCCCCC">
                           <a:alpha val="100000"/>
                         </a:srgbClr>
                       </a:solidFill>
@@ -11136,8 +11296,12 @@
                       <a:noFill/>
                       <a:prstDash val="solid"/>
                     </a:lnL>
-                    <a:lnR algn="ctr" cmpd="sng" cap="flat" w="0">
-                      <a:noFill/>
+                    <a:lnR algn="ctr" cmpd="sng" cap="flat" w="10160">
+                      <a:solidFill>
+                        <a:srgbClr val="8C8C8C">
+                          <a:alpha val="100000"/>
+                        </a:srgbClr>
+                      </a:solidFill>
                       <a:prstDash val="solid"/>
                     </a:lnR>
                     <a:lnT algn="ctr" cmpd="sng" cap="flat" w="4445">
@@ -11197,12 +11361,20 @@
                     </a:p>
                   </a:txBody>
                   <a:tcPr anchor="ctr" marB="12700" marT="12700" marR="0" marL="0">
-                    <a:lnL algn="ctr" cmpd="sng" cap="flat" w="0">
-                      <a:noFill/>
+                    <a:lnL algn="ctr" cmpd="sng" cap="flat" w="10160">
+                      <a:solidFill>
+                        <a:srgbClr val="8C8C8C">
+                          <a:alpha val="100000"/>
+                        </a:srgbClr>
+                      </a:solidFill>
                       <a:prstDash val="solid"/>
                     </a:lnL>
-                    <a:lnR algn="ctr" cmpd="sng" cap="flat" w="0">
-                      <a:noFill/>
+                    <a:lnR algn="ctr" cmpd="sng" cap="flat" w="10160">
+                      <a:solidFill>
+                        <a:srgbClr val="8C8C8C">
+                          <a:alpha val="100000"/>
+                        </a:srgbClr>
+                      </a:solidFill>
                       <a:prstDash val="solid"/>
                     </a:lnR>
                     <a:lnT algn="ctr" cmpd="sng" cap="flat" w="4445">
@@ -11262,8 +11434,12 @@
                     </a:p>
                   </a:txBody>
                   <a:tcPr anchor="ctr" marB="12700" marT="12700" marR="0" marL="0">
-                    <a:lnL algn="ctr" cmpd="sng" cap="flat" w="0">
-                      <a:noFill/>
+                    <a:lnL algn="ctr" cmpd="sng" cap="flat" w="10160">
+                      <a:solidFill>
+                        <a:srgbClr val="8C8C8C">
+                          <a:alpha val="100000"/>
+                        </a:srgbClr>
+                      </a:solidFill>
                       <a:prstDash val="solid"/>
                     </a:lnL>
                     <a:lnR algn="ctr" cmpd="sng" cap="flat" w="0">
@@ -11674,9 +11850,9 @@
                       <a:noFill/>
                       <a:prstDash val="solid"/>
                     </a:lnL>
-                    <a:lnR algn="ctr" cmpd="sng" cap="flat" w="10160">
-                      <a:solidFill>
-                        <a:srgbClr val="8C8C8C">
+                    <a:lnR algn="ctr" cmpd="sng" cap="flat" w="4445">
+                      <a:solidFill>
+                        <a:srgbClr val="CCCCCC">
                           <a:alpha val="100000"/>
                         </a:srgbClr>
                       </a:solidFill>
@@ -11739,9 +11915,9 @@
                     </a:p>
                   </a:txBody>
                   <a:tcPr anchor="ctr" marB="12700" marT="12700" marR="0" marL="0">
-                    <a:lnL algn="ctr" cmpd="sng" cap="flat" w="10160">
-                      <a:solidFill>
-                        <a:srgbClr val="8C8C8C">
+                    <a:lnL algn="ctr" cmpd="sng" cap="flat" w="4445">
+                      <a:solidFill>
+                        <a:srgbClr val="CCCCCC">
                           <a:alpha val="100000"/>
                         </a:srgbClr>
                       </a:solidFill>
@@ -11877,8 +12053,12 @@
                       <a:noFill/>
                       <a:prstDash val="solid"/>
                     </a:lnL>
-                    <a:lnR algn="ctr" cmpd="sng" cap="flat" w="0">
-                      <a:noFill/>
+                    <a:lnR algn="ctr" cmpd="sng" cap="flat" w="10160">
+                      <a:solidFill>
+                        <a:srgbClr val="8C8C8C">
+                          <a:alpha val="100000"/>
+                        </a:srgbClr>
+                      </a:solidFill>
                       <a:prstDash val="solid"/>
                     </a:lnR>
                     <a:lnT algn="ctr" cmpd="sng" cap="flat" w="4445">
@@ -11938,12 +12118,20 @@
                     </a:p>
                   </a:txBody>
                   <a:tcPr anchor="ctr" marB="12700" marT="12700" marR="0" marL="0">
-                    <a:lnL algn="ctr" cmpd="sng" cap="flat" w="0">
-                      <a:noFill/>
+                    <a:lnL algn="ctr" cmpd="sng" cap="flat" w="10160">
+                      <a:solidFill>
+                        <a:srgbClr val="8C8C8C">
+                          <a:alpha val="100000"/>
+                        </a:srgbClr>
+                      </a:solidFill>
                       <a:prstDash val="solid"/>
                     </a:lnL>
-                    <a:lnR algn="ctr" cmpd="sng" cap="flat" w="0">
-                      <a:noFill/>
+                    <a:lnR algn="ctr" cmpd="sng" cap="flat" w="10160">
+                      <a:solidFill>
+                        <a:srgbClr val="8C8C8C">
+                          <a:alpha val="100000"/>
+                        </a:srgbClr>
+                      </a:solidFill>
                       <a:prstDash val="solid"/>
                     </a:lnR>
                     <a:lnT algn="ctr" cmpd="sng" cap="flat" w="4445">
@@ -12003,8 +12191,12 @@
                     </a:p>
                   </a:txBody>
                   <a:tcPr anchor="ctr" marB="12700" marT="12700" marR="0" marL="0">
-                    <a:lnL algn="ctr" cmpd="sng" cap="flat" w="0">
-                      <a:noFill/>
+                    <a:lnL algn="ctr" cmpd="sng" cap="flat" w="10160">
+                      <a:solidFill>
+                        <a:srgbClr val="8C8C8C">
+                          <a:alpha val="100000"/>
+                        </a:srgbClr>
+                      </a:solidFill>
                       <a:prstDash val="solid"/>
                     </a:lnL>
                     <a:lnR algn="ctr" cmpd="sng" cap="flat" w="0">
@@ -12415,9 +12607,9 @@
                       <a:noFill/>
                       <a:prstDash val="solid"/>
                     </a:lnL>
-                    <a:lnR algn="ctr" cmpd="sng" cap="flat" w="10160">
-                      <a:solidFill>
-                        <a:srgbClr val="8C8C8C">
+                    <a:lnR algn="ctr" cmpd="sng" cap="flat" w="4445">
+                      <a:solidFill>
+                        <a:srgbClr val="CCCCCC">
                           <a:alpha val="100000"/>
                         </a:srgbClr>
                       </a:solidFill>
@@ -12480,9 +12672,9 @@
                     </a:p>
                   </a:txBody>
                   <a:tcPr anchor="ctr" marB="12700" marT="12700" marR="0" marL="0">
-                    <a:lnL algn="ctr" cmpd="sng" cap="flat" w="10160">
-                      <a:solidFill>
-                        <a:srgbClr val="8C8C8C">
+                    <a:lnL algn="ctr" cmpd="sng" cap="flat" w="4445">
+                      <a:solidFill>
+                        <a:srgbClr val="CCCCCC">
                           <a:alpha val="100000"/>
                         </a:srgbClr>
                       </a:solidFill>
@@ -12618,8 +12810,12 @@
                       <a:noFill/>
                       <a:prstDash val="solid"/>
                     </a:lnL>
-                    <a:lnR algn="ctr" cmpd="sng" cap="flat" w="0">
-                      <a:noFill/>
+                    <a:lnR algn="ctr" cmpd="sng" cap="flat" w="10160">
+                      <a:solidFill>
+                        <a:srgbClr val="8C8C8C">
+                          <a:alpha val="100000"/>
+                        </a:srgbClr>
+                      </a:solidFill>
                       <a:prstDash val="solid"/>
                     </a:lnR>
                     <a:lnT algn="ctr" cmpd="sng" cap="flat" w="4445">
@@ -12679,12 +12875,20 @@
                     </a:p>
                   </a:txBody>
                   <a:tcPr anchor="ctr" marB="12700" marT="12700" marR="0" marL="0">
-                    <a:lnL algn="ctr" cmpd="sng" cap="flat" w="0">
-                      <a:noFill/>
+                    <a:lnL algn="ctr" cmpd="sng" cap="flat" w="10160">
+                      <a:solidFill>
+                        <a:srgbClr val="8C8C8C">
+                          <a:alpha val="100000"/>
+                        </a:srgbClr>
+                      </a:solidFill>
                       <a:prstDash val="solid"/>
                     </a:lnL>
-                    <a:lnR algn="ctr" cmpd="sng" cap="flat" w="0">
-                      <a:noFill/>
+                    <a:lnR algn="ctr" cmpd="sng" cap="flat" w="10160">
+                      <a:solidFill>
+                        <a:srgbClr val="8C8C8C">
+                          <a:alpha val="100000"/>
+                        </a:srgbClr>
+                      </a:solidFill>
                       <a:prstDash val="solid"/>
                     </a:lnR>
                     <a:lnT algn="ctr" cmpd="sng" cap="flat" w="4445">
@@ -12744,8 +12948,12 @@
                     </a:p>
                   </a:txBody>
                   <a:tcPr anchor="ctr" marB="12700" marT="12700" marR="0" marL="0">
-                    <a:lnL algn="ctr" cmpd="sng" cap="flat" w="0">
-                      <a:noFill/>
+                    <a:lnL algn="ctr" cmpd="sng" cap="flat" w="10160">
+                      <a:solidFill>
+                        <a:srgbClr val="8C8C8C">
+                          <a:alpha val="100000"/>
+                        </a:srgbClr>
+                      </a:solidFill>
                       <a:prstDash val="solid"/>
                     </a:lnL>
                     <a:lnR algn="ctr" cmpd="sng" cap="flat" w="0">
@@ -13156,9 +13364,9 @@
                       <a:noFill/>
                       <a:prstDash val="solid"/>
                     </a:lnL>
-                    <a:lnR algn="ctr" cmpd="sng" cap="flat" w="10160">
-                      <a:solidFill>
-                        <a:srgbClr val="8C8C8C">
+                    <a:lnR algn="ctr" cmpd="sng" cap="flat" w="4445">
+                      <a:solidFill>
+                        <a:srgbClr val="CCCCCC">
                           <a:alpha val="100000"/>
                         </a:srgbClr>
                       </a:solidFill>
@@ -13221,9 +13429,9 @@
                     </a:p>
                   </a:txBody>
                   <a:tcPr anchor="ctr" marB="12700" marT="12700" marR="0" marL="0">
-                    <a:lnL algn="ctr" cmpd="sng" cap="flat" w="10160">
-                      <a:solidFill>
-                        <a:srgbClr val="8C8C8C">
+                    <a:lnL algn="ctr" cmpd="sng" cap="flat" w="4445">
+                      <a:solidFill>
+                        <a:srgbClr val="CCCCCC">
                           <a:alpha val="100000"/>
                         </a:srgbClr>
                       </a:solidFill>
@@ -13359,8 +13567,12 @@
                       <a:noFill/>
                       <a:prstDash val="solid"/>
                     </a:lnL>
-                    <a:lnR algn="ctr" cmpd="sng" cap="flat" w="0">
-                      <a:noFill/>
+                    <a:lnR algn="ctr" cmpd="sng" cap="flat" w="10160">
+                      <a:solidFill>
+                        <a:srgbClr val="8C8C8C">
+                          <a:alpha val="100000"/>
+                        </a:srgbClr>
+                      </a:solidFill>
                       <a:prstDash val="solid"/>
                     </a:lnR>
                     <a:lnT algn="ctr" cmpd="sng" cap="flat" w="4445">
@@ -13420,12 +13632,20 @@
                     </a:p>
                   </a:txBody>
                   <a:tcPr anchor="ctr" marB="12700" marT="12700" marR="0" marL="0">
-                    <a:lnL algn="ctr" cmpd="sng" cap="flat" w="0">
-                      <a:noFill/>
+                    <a:lnL algn="ctr" cmpd="sng" cap="flat" w="10160">
+                      <a:solidFill>
+                        <a:srgbClr val="8C8C8C">
+                          <a:alpha val="100000"/>
+                        </a:srgbClr>
+                      </a:solidFill>
                       <a:prstDash val="solid"/>
                     </a:lnL>
-                    <a:lnR algn="ctr" cmpd="sng" cap="flat" w="0">
-                      <a:noFill/>
+                    <a:lnR algn="ctr" cmpd="sng" cap="flat" w="10160">
+                      <a:solidFill>
+                        <a:srgbClr val="8C8C8C">
+                          <a:alpha val="100000"/>
+                        </a:srgbClr>
+                      </a:solidFill>
                       <a:prstDash val="solid"/>
                     </a:lnR>
                     <a:lnT algn="ctr" cmpd="sng" cap="flat" w="4445">
@@ -13485,8 +13705,12 @@
                     </a:p>
                   </a:txBody>
                   <a:tcPr anchor="ctr" marB="12700" marT="12700" marR="0" marL="0">
-                    <a:lnL algn="ctr" cmpd="sng" cap="flat" w="0">
-                      <a:noFill/>
+                    <a:lnL algn="ctr" cmpd="sng" cap="flat" w="10160">
+                      <a:solidFill>
+                        <a:srgbClr val="8C8C8C">
+                          <a:alpha val="100000"/>
+                        </a:srgbClr>
+                      </a:solidFill>
                       <a:prstDash val="solid"/>
                     </a:lnL>
                     <a:lnR algn="ctr" cmpd="sng" cap="flat" w="0">

</xml_diff>

<commit_message>
Swap summary note and trend columns
</commit_message>
<xml_diff>
--- a/output/sigma_summary_latest.pptx
+++ b/output/sigma_summary_latest.pptx
@@ -3248,8 +3248,8 @@
                 <a:gridCol w="594360"/>
                 <a:gridCol w="594360"/>
                 <a:gridCol w="640080"/>
+                <a:gridCol w="2231136"/>
                 <a:gridCol w="3474720"/>
-                <a:gridCol w="2231136"/>
               </a:tblGrid>
               <a:tr h="210312">
                 <a:tc gridSpan="3">
@@ -3874,7 +3874,7 @@
                           <a:ea typeface="Arial"/>
                           <a:sym typeface="Arial"/>
                         </a:rPr>
-                        <a:t>TREND</a:t>
+                        <a:t>비고</a:t>
                       </a:r>
                     </a:p>
                   </a:txBody>
@@ -3947,7 +3947,7 @@
                           <a:ea typeface="Arial"/>
                           <a:sym typeface="Arial"/>
                         </a:rPr>
-                        <a:t>비고</a:t>
+                        <a:t>TREND</a:t>
                       </a:r>
                     </a:p>
                   </a:txBody>

</xml_diff>

<commit_message>
Add goobae slide generation
</commit_message>
<xml_diff>
--- a/output/sigma_summary_latest.pptx
+++ b/output/sigma_summary_latest.pptx
@@ -11,6 +11,7 @@
     <p:sldId id="259" r:id="rId10"/>
     <p:sldId id="260" r:id="rId11"/>
     <p:sldId id="261" r:id="rId12"/>
+    <p:sldId id="262" r:id="rId13"/>
   </p:sldIdLst>
   <p:sldSz cx="12191695" cy="6858000" type="screen4x3"/>
   <p:notesSz cx="6858000" cy="9144000"/>
@@ -13887,6 +13888,3091 @@
                 <a:ea typeface="Arial"/>
                 <a:sym typeface="Arial"/>
               </a:rPr>
+              <a:t> GOOBAE: WL trend by REF/TARGET</a:t>
+            </a:r>
+          </a:p>
+          <a:p>
+            <a:pPr algn="l" marL="0" marR="0">
+              <a:lnSpc>
+                <a:spcPct val="100000"/>
+              </a:lnSpc>
+              <a:spcBef>
+                <a:spcPts val="0"/>
+              </a:spcBef>
+              <a:spcAft>
+                <a:spcPts val="0"/>
+              </a:spcAft>
+              <a:buNone/>
+            </a:pPr>
+            <a:r>
+              <a:rPr cap="none" sz="1100" i="0" b="1" u="none" strike="noStrike">
+                <a:solidFill>
+                  <a:srgbClr val="333333">
+                    <a:alpha val="100000"/>
+                  </a:srgbClr>
+                </a:solidFill>
+                <a:latin typeface="Arial"/>
+                <a:cs typeface="Arial"/>
+                <a:ea typeface="Arial"/>
+                <a:sym typeface="Arial"/>
+              </a:rPr>
+              <a:t>■</a:t>
+            </a:r>
+            <a:r>
+              <a:rPr cap="none" sz="1100" i="0" b="0" u="none" strike="noStrike">
+                <a:solidFill>
+                  <a:srgbClr val="333333">
+                    <a:alpha val="100000"/>
+                  </a:srgbClr>
+                </a:solidFill>
+                <a:latin typeface="Arial"/>
+                <a:cs typeface="Arial"/>
+                <a:ea typeface="Arial"/>
+                <a:sym typeface="Arial"/>
+              </a:rPr>
+              <a:t> REF: A / TARGET: B</a:t>
+            </a:r>
+          </a:p>
+          <a:p>
+            <a:pPr algn="l" marL="0" marR="0">
+              <a:lnSpc>
+                <a:spcPct val="100000"/>
+              </a:lnSpc>
+              <a:spcBef>
+                <a:spcPts val="0"/>
+              </a:spcBef>
+              <a:spcAft>
+                <a:spcPts val="0"/>
+              </a:spcAft>
+              <a:buNone/>
+            </a:pPr>
+            <a:r>
+              <a:rPr cap="none" sz="1100" i="0" b="1" u="none" strike="noStrike">
+                <a:solidFill>
+                  <a:srgbClr val="333333">
+                    <a:alpha val="100000"/>
+                  </a:srgbClr>
+                </a:solidFill>
+                <a:latin typeface="Arial"/>
+                <a:cs typeface="Arial"/>
+                <a:ea typeface="Arial"/>
+                <a:sym typeface="Arial"/>
+              </a:rPr>
+              <a:t>■</a:t>
+            </a:r>
+            <a:r>
+              <a:rPr cap="none" sz="1100" i="0" b="0" u="none" strike="noStrike">
+                <a:solidFill>
+                  <a:srgbClr val="333333">
+                    <a:alpha val="100000"/>
+                  </a:srgbClr>
+                </a:solidFill>
+                <a:latin typeface="Arial"/>
+                <a:cs typeface="Arial"/>
+                <a:ea typeface="Arial"/>
+                <a:sym typeface="Arial"/>
+              </a:rPr>
+              <a:t> Showing GOOBAE 1-3 of 3</a:t>
+            </a:r>
+          </a:p>
+        </p:txBody>
+      </p:sp>
+      <p:graphicFrame>
+        <p:nvGraphicFramePr>
+          <p:cNvPr id="4" name=""/>
+          <p:cNvGraphicFramePr>
+            <a:graphicFrameLocks noGrp="true"/>
+          </p:cNvGraphicFramePr>
+          <p:nvPr/>
+        </p:nvGraphicFramePr>
+        <p:xfrm rot="0">
+          <a:off x="292608" y="1536192"/>
+          <a:ext cx="11603736" cy="4864608"/>
+        </p:xfrm>
+        <a:graphic>
+          <a:graphicData uri="http://schemas.openxmlformats.org/drawingml/2006/table">
+            <a:tbl>
+              <a:tblPr/>
+              <a:tblGrid>
+                <a:gridCol w="966978"/>
+                <a:gridCol w="966978"/>
+                <a:gridCol w="966978"/>
+                <a:gridCol w="966978"/>
+                <a:gridCol w="966978"/>
+                <a:gridCol w="966978"/>
+                <a:gridCol w="966978"/>
+                <a:gridCol w="966978"/>
+                <a:gridCol w="966978"/>
+                <a:gridCol w="966978"/>
+                <a:gridCol w="966978"/>
+                <a:gridCol w="966978"/>
+              </a:tblGrid>
+              <a:tr h="292608">
+                <a:tc gridSpan="2">
+                  <a:txBody>
+                    <a:bodyPr/>
+                    <a:lstStyle/>
+                    <a:p>
+                      <a:pPr algn="ctr" marL="0" marR="0">
+                        <a:lnSpc>
+                          <a:spcPct val="10000"/>
+                        </a:lnSpc>
+                        <a:spcBef>
+                          <a:spcPts val="0"/>
+                        </a:spcBef>
+                        <a:spcAft>
+                          <a:spcPts val="0"/>
+                        </a:spcAft>
+                        <a:buNone/>
+                      </a:pPr>
+                      <a:r>
+                        <a:rPr cap="none" sz="850" i="0" b="1" u="none" strike="noStrike">
+                          <a:solidFill>
+                            <a:srgbClr val="333333">
+                              <a:alpha val="100000"/>
+                            </a:srgbClr>
+                          </a:solidFill>
+                          <a:latin typeface="Arial"/>
+                          <a:cs typeface="Arial"/>
+                          <a:ea typeface="Arial"/>
+                          <a:sym typeface="Arial"/>
+                        </a:rPr>
+                        <a:t>WLS</a:t>
+                      </a:r>
+                    </a:p>
+                  </a:txBody>
+                  <a:tcPr anchor="ctr" marB="0" marT="0" marR="0" marL="0">
+                    <a:lnL algn="ctr" cmpd="sng" cap="flat" w="6350">
+                      <a:solidFill>
+                        <a:srgbClr val="D9D9D9">
+                          <a:alpha val="100000"/>
+                        </a:srgbClr>
+                      </a:solidFill>
+                      <a:prstDash val="solid"/>
+                    </a:lnL>
+                    <a:lnR algn="ctr" cmpd="sng" cap="flat" w="6350">
+                      <a:solidFill>
+                        <a:srgbClr val="D9D9D9">
+                          <a:alpha val="100000"/>
+                        </a:srgbClr>
+                      </a:solidFill>
+                      <a:prstDash val="solid"/>
+                    </a:lnR>
+                    <a:lnT algn="ctr" cmpd="sng" cap="flat" w="6350">
+                      <a:solidFill>
+                        <a:srgbClr val="D9D9D9">
+                          <a:alpha val="100000"/>
+                        </a:srgbClr>
+                      </a:solidFill>
+                      <a:prstDash val="solid"/>
+                    </a:lnT>
+                    <a:lnB algn="ctr" cmpd="sng" cap="flat" w="6350">
+                      <a:solidFill>
+                        <a:srgbClr val="D9D9D9">
+                          <a:alpha val="100000"/>
+                        </a:srgbClr>
+                      </a:solidFill>
+                      <a:prstDash val="solid"/>
+                    </a:lnB>
+                    <a:solidFill>
+                      <a:srgbClr val="E0E0E0">
+                        <a:alpha val="100000"/>
+                      </a:srgbClr>
+                    </a:solidFill>
+                  </a:tcPr>
+                </a:tc>
+                <a:tc hMerge="true">
+                  <a:txBody>
+                    <a:bodyPr/>
+                    <a:lstStyle/>
+                    <a:p>
+                      <a:pPr algn="ctr" marL="0" marR="0">
+                        <a:lnSpc>
+                          <a:spcPct val="10000"/>
+                        </a:lnSpc>
+                        <a:spcBef>
+                          <a:spcPts val="0"/>
+                        </a:spcBef>
+                        <a:spcAft>
+                          <a:spcPts val="0"/>
+                        </a:spcAft>
+                        <a:buNone/>
+                      </a:pPr>
+                      <a:r>
+                        <a:rPr cap="none" sz="850" i="0" b="1" u="none" strike="noStrike">
+                          <a:solidFill>
+                            <a:srgbClr val="333333">
+                              <a:alpha val="100000"/>
+                            </a:srgbClr>
+                          </a:solidFill>
+                          <a:latin typeface="Arial"/>
+                          <a:cs typeface="Arial"/>
+                          <a:ea typeface="Arial"/>
+                          <a:sym typeface="Arial"/>
+                        </a:rPr>
+                        <a:t>WLS</a:t>
+                      </a:r>
+                    </a:p>
+                  </a:txBody>
+                  <a:tcPr anchor="ctr" marB="0" marT="0" marR="0" marL="0">
+                    <a:lnL algn="ctr" cmpd="sng" cap="flat" w="6350">
+                      <a:solidFill>
+                        <a:srgbClr val="D9D9D9">
+                          <a:alpha val="100000"/>
+                        </a:srgbClr>
+                      </a:solidFill>
+                      <a:prstDash val="solid"/>
+                    </a:lnL>
+                    <a:lnR algn="ctr" cmpd="sng" cap="flat" w="6350">
+                      <a:solidFill>
+                        <a:srgbClr val="D9D9D9">
+                          <a:alpha val="100000"/>
+                        </a:srgbClr>
+                      </a:solidFill>
+                      <a:prstDash val="solid"/>
+                    </a:lnR>
+                    <a:lnT algn="ctr" cmpd="sng" cap="flat" w="6350">
+                      <a:solidFill>
+                        <a:srgbClr val="D9D9D9">
+                          <a:alpha val="100000"/>
+                        </a:srgbClr>
+                      </a:solidFill>
+                      <a:prstDash val="solid"/>
+                    </a:lnT>
+                    <a:lnB algn="ctr" cmpd="sng" cap="flat" w="6350">
+                      <a:solidFill>
+                        <a:srgbClr val="D9D9D9">
+                          <a:alpha val="100000"/>
+                        </a:srgbClr>
+                      </a:solidFill>
+                      <a:prstDash val="solid"/>
+                    </a:lnB>
+                    <a:solidFill>
+                      <a:srgbClr val="E0E0E0">
+                        <a:alpha val="100000"/>
+                      </a:srgbClr>
+                    </a:solidFill>
+                  </a:tcPr>
+                </a:tc>
+                <a:tc>
+                  <a:txBody>
+                    <a:bodyPr/>
+                    <a:lstStyle/>
+                    <a:p>
+                      <a:pPr algn="ctr" marL="0" marR="0">
+                        <a:lnSpc>
+                          <a:spcPct val="10000"/>
+                        </a:lnSpc>
+                        <a:spcBef>
+                          <a:spcPts val="0"/>
+                        </a:spcBef>
+                        <a:spcAft>
+                          <a:spcPts val="0"/>
+                        </a:spcAft>
+                        <a:buNone/>
+                      </a:pPr>
+                      <a:r>
+                        <a:rPr cap="none" sz="850" i="0" b="1" u="none" strike="noStrike">
+                          <a:solidFill>
+                            <a:srgbClr val="333333">
+                              <a:alpha val="100000"/>
+                            </a:srgbClr>
+                          </a:solidFill>
+                          <a:latin typeface="Arial"/>
+                          <a:cs typeface="Arial"/>
+                          <a:ea typeface="Arial"/>
+                          <a:sym typeface="Arial"/>
+                        </a:rPr>
+                        <a:t>WTC</a:t>
+                      </a:r>
+                    </a:p>
+                  </a:txBody>
+                  <a:tcPr anchor="ctr" marB="0" marT="0" marR="0" marL="0">
+                    <a:lnL algn="ctr" cmpd="sng" cap="flat" w="6350">
+                      <a:solidFill>
+                        <a:srgbClr val="D9D9D9">
+                          <a:alpha val="100000"/>
+                        </a:srgbClr>
+                      </a:solidFill>
+                      <a:prstDash val="solid"/>
+                    </a:lnL>
+                    <a:lnR algn="ctr" cmpd="sng" cap="flat" w="6350">
+                      <a:solidFill>
+                        <a:srgbClr val="D9D9D9">
+                          <a:alpha val="100000"/>
+                        </a:srgbClr>
+                      </a:solidFill>
+                      <a:prstDash val="solid"/>
+                    </a:lnR>
+                    <a:lnT algn="ctr" cmpd="sng" cap="flat" w="6350">
+                      <a:solidFill>
+                        <a:srgbClr val="D9D9D9">
+                          <a:alpha val="100000"/>
+                        </a:srgbClr>
+                      </a:solidFill>
+                      <a:prstDash val="solid"/>
+                    </a:lnT>
+                    <a:lnB algn="ctr" cmpd="sng" cap="flat" w="6350">
+                      <a:solidFill>
+                        <a:srgbClr val="D9D9D9">
+                          <a:alpha val="100000"/>
+                        </a:srgbClr>
+                      </a:solidFill>
+                      <a:prstDash val="solid"/>
+                    </a:lnB>
+                    <a:solidFill>
+                      <a:srgbClr val="E0E0E0">
+                        <a:alpha val="100000"/>
+                      </a:srgbClr>
+                    </a:solidFill>
+                  </a:tcPr>
+                </a:tc>
+                <a:tc gridSpan="9">
+                  <a:txBody>
+                    <a:bodyPr/>
+                    <a:lstStyle/>
+                    <a:p>
+                      <a:pPr algn="ctr" marL="0" marR="0">
+                        <a:lnSpc>
+                          <a:spcPct val="10000"/>
+                        </a:lnSpc>
+                        <a:spcBef>
+                          <a:spcPts val="0"/>
+                        </a:spcBef>
+                        <a:spcAft>
+                          <a:spcPts val="0"/>
+                        </a:spcAft>
+                        <a:buNone/>
+                      </a:pPr>
+                      <a:r>
+                        <a:rPr cap="none" sz="850" i="0" b="1" u="none" strike="noStrike">
+                          <a:solidFill>
+                            <a:srgbClr val="333333">
+                              <a:alpha val="100000"/>
+                            </a:srgbClr>
+                          </a:solidFill>
+                          <a:latin typeface="Arial"/>
+                          <a:cs typeface="Arial"/>
+                          <a:ea typeface="Arial"/>
+                          <a:sym typeface="Arial"/>
+                        </a:rPr>
+                        <a:t> </a:t>
+                      </a:r>
+                    </a:p>
+                  </a:txBody>
+                  <a:tcPr anchor="ctr" marB="0" marT="0" marR="0" marL="0">
+                    <a:lnL algn="ctr" cmpd="sng" cap="flat" w="6350">
+                      <a:solidFill>
+                        <a:srgbClr val="D9D9D9">
+                          <a:alpha val="100000"/>
+                        </a:srgbClr>
+                      </a:solidFill>
+                      <a:prstDash val="solid"/>
+                    </a:lnL>
+                    <a:lnR algn="ctr" cmpd="sng" cap="flat" w="6350">
+                      <a:solidFill>
+                        <a:srgbClr val="D9D9D9">
+                          <a:alpha val="100000"/>
+                        </a:srgbClr>
+                      </a:solidFill>
+                      <a:prstDash val="solid"/>
+                    </a:lnR>
+                    <a:lnT algn="ctr" cmpd="sng" cap="flat" w="6350">
+                      <a:solidFill>
+                        <a:srgbClr val="D9D9D9">
+                          <a:alpha val="100000"/>
+                        </a:srgbClr>
+                      </a:solidFill>
+                      <a:prstDash val="solid"/>
+                    </a:lnT>
+                    <a:lnB algn="ctr" cmpd="sng" cap="flat" w="6350">
+                      <a:solidFill>
+                        <a:srgbClr val="D9D9D9">
+                          <a:alpha val="100000"/>
+                        </a:srgbClr>
+                      </a:solidFill>
+                      <a:prstDash val="solid"/>
+                    </a:lnB>
+                    <a:solidFill>
+                      <a:srgbClr val="E0E0E0">
+                        <a:alpha val="100000"/>
+                      </a:srgbClr>
+                    </a:solidFill>
+                  </a:tcPr>
+                </a:tc>
+                <a:tc hMerge="true">
+                  <a:txBody>
+                    <a:bodyPr/>
+                    <a:lstStyle/>
+                    <a:p>
+                      <a:pPr algn="ctr" marL="0" marR="0">
+                        <a:lnSpc>
+                          <a:spcPct val="10000"/>
+                        </a:lnSpc>
+                        <a:spcBef>
+                          <a:spcPts val="0"/>
+                        </a:spcBef>
+                        <a:spcAft>
+                          <a:spcPts val="0"/>
+                        </a:spcAft>
+                        <a:buNone/>
+                      </a:pPr>
+                      <a:r>
+                        <a:rPr cap="none" sz="850" i="0" b="1" u="none" strike="noStrike">
+                          <a:solidFill>
+                            <a:srgbClr val="333333">
+                              <a:alpha val="100000"/>
+                            </a:srgbClr>
+                          </a:solidFill>
+                          <a:latin typeface="Arial"/>
+                          <a:cs typeface="Arial"/>
+                          <a:ea typeface="Arial"/>
+                          <a:sym typeface="Arial"/>
+                        </a:rPr>
+                        <a:t> </a:t>
+                      </a:r>
+                    </a:p>
+                  </a:txBody>
+                  <a:tcPr anchor="ctr" marB="0" marT="0" marR="0" marL="0">
+                    <a:lnL algn="ctr" cmpd="sng" cap="flat" w="6350">
+                      <a:solidFill>
+                        <a:srgbClr val="D9D9D9">
+                          <a:alpha val="100000"/>
+                        </a:srgbClr>
+                      </a:solidFill>
+                      <a:prstDash val="solid"/>
+                    </a:lnL>
+                    <a:lnR algn="ctr" cmpd="sng" cap="flat" w="6350">
+                      <a:solidFill>
+                        <a:srgbClr val="D9D9D9">
+                          <a:alpha val="100000"/>
+                        </a:srgbClr>
+                      </a:solidFill>
+                      <a:prstDash val="solid"/>
+                    </a:lnR>
+                    <a:lnT algn="ctr" cmpd="sng" cap="flat" w="6350">
+                      <a:solidFill>
+                        <a:srgbClr val="D9D9D9">
+                          <a:alpha val="100000"/>
+                        </a:srgbClr>
+                      </a:solidFill>
+                      <a:prstDash val="solid"/>
+                    </a:lnT>
+                    <a:lnB algn="ctr" cmpd="sng" cap="flat" w="6350">
+                      <a:solidFill>
+                        <a:srgbClr val="D9D9D9">
+                          <a:alpha val="100000"/>
+                        </a:srgbClr>
+                      </a:solidFill>
+                      <a:prstDash val="solid"/>
+                    </a:lnB>
+                    <a:solidFill>
+                      <a:srgbClr val="E0E0E0">
+                        <a:alpha val="100000"/>
+                      </a:srgbClr>
+                    </a:solidFill>
+                  </a:tcPr>
+                </a:tc>
+                <a:tc hMerge="true">
+                  <a:txBody>
+                    <a:bodyPr/>
+                    <a:lstStyle/>
+                    <a:p>
+                      <a:pPr algn="ctr" marL="0" marR="0">
+                        <a:lnSpc>
+                          <a:spcPct val="10000"/>
+                        </a:lnSpc>
+                        <a:spcBef>
+                          <a:spcPts val="0"/>
+                        </a:spcBef>
+                        <a:spcAft>
+                          <a:spcPts val="0"/>
+                        </a:spcAft>
+                        <a:buNone/>
+                      </a:pPr>
+                      <a:r>
+                        <a:rPr cap="none" sz="850" i="0" b="1" u="none" strike="noStrike">
+                          <a:solidFill>
+                            <a:srgbClr val="333333">
+                              <a:alpha val="100000"/>
+                            </a:srgbClr>
+                          </a:solidFill>
+                          <a:latin typeface="Arial"/>
+                          <a:cs typeface="Arial"/>
+                          <a:ea typeface="Arial"/>
+                          <a:sym typeface="Arial"/>
+                        </a:rPr>
+                        <a:t> </a:t>
+                      </a:r>
+                    </a:p>
+                  </a:txBody>
+                  <a:tcPr anchor="ctr" marB="0" marT="0" marR="0" marL="0">
+                    <a:lnL algn="ctr" cmpd="sng" cap="flat" w="6350">
+                      <a:solidFill>
+                        <a:srgbClr val="D9D9D9">
+                          <a:alpha val="100000"/>
+                        </a:srgbClr>
+                      </a:solidFill>
+                      <a:prstDash val="solid"/>
+                    </a:lnL>
+                    <a:lnR algn="ctr" cmpd="sng" cap="flat" w="6350">
+                      <a:solidFill>
+                        <a:srgbClr val="D9D9D9">
+                          <a:alpha val="100000"/>
+                        </a:srgbClr>
+                      </a:solidFill>
+                      <a:prstDash val="solid"/>
+                    </a:lnR>
+                    <a:lnT algn="ctr" cmpd="sng" cap="flat" w="6350">
+                      <a:solidFill>
+                        <a:srgbClr val="D9D9D9">
+                          <a:alpha val="100000"/>
+                        </a:srgbClr>
+                      </a:solidFill>
+                      <a:prstDash val="solid"/>
+                    </a:lnT>
+                    <a:lnB algn="ctr" cmpd="sng" cap="flat" w="6350">
+                      <a:solidFill>
+                        <a:srgbClr val="D9D9D9">
+                          <a:alpha val="100000"/>
+                        </a:srgbClr>
+                      </a:solidFill>
+                      <a:prstDash val="solid"/>
+                    </a:lnB>
+                    <a:solidFill>
+                      <a:srgbClr val="E0E0E0">
+                        <a:alpha val="100000"/>
+                      </a:srgbClr>
+                    </a:solidFill>
+                  </a:tcPr>
+                </a:tc>
+                <a:tc hMerge="true">
+                  <a:txBody>
+                    <a:bodyPr/>
+                    <a:lstStyle/>
+                    <a:p>
+                      <a:pPr algn="ctr" marL="0" marR="0">
+                        <a:lnSpc>
+                          <a:spcPct val="10000"/>
+                        </a:lnSpc>
+                        <a:spcBef>
+                          <a:spcPts val="0"/>
+                        </a:spcBef>
+                        <a:spcAft>
+                          <a:spcPts val="0"/>
+                        </a:spcAft>
+                        <a:buNone/>
+                      </a:pPr>
+                      <a:r>
+                        <a:rPr cap="none" sz="850" i="0" b="1" u="none" strike="noStrike">
+                          <a:solidFill>
+                            <a:srgbClr val="333333">
+                              <a:alpha val="100000"/>
+                            </a:srgbClr>
+                          </a:solidFill>
+                          <a:latin typeface="Arial"/>
+                          <a:cs typeface="Arial"/>
+                          <a:ea typeface="Arial"/>
+                          <a:sym typeface="Arial"/>
+                        </a:rPr>
+                        <a:t> </a:t>
+                      </a:r>
+                    </a:p>
+                  </a:txBody>
+                  <a:tcPr anchor="ctr" marB="0" marT="0" marR="0" marL="0">
+                    <a:lnL algn="ctr" cmpd="sng" cap="flat" w="6350">
+                      <a:solidFill>
+                        <a:srgbClr val="D9D9D9">
+                          <a:alpha val="100000"/>
+                        </a:srgbClr>
+                      </a:solidFill>
+                      <a:prstDash val="solid"/>
+                    </a:lnL>
+                    <a:lnR algn="ctr" cmpd="sng" cap="flat" w="6350">
+                      <a:solidFill>
+                        <a:srgbClr val="D9D9D9">
+                          <a:alpha val="100000"/>
+                        </a:srgbClr>
+                      </a:solidFill>
+                      <a:prstDash val="solid"/>
+                    </a:lnR>
+                    <a:lnT algn="ctr" cmpd="sng" cap="flat" w="6350">
+                      <a:solidFill>
+                        <a:srgbClr val="D9D9D9">
+                          <a:alpha val="100000"/>
+                        </a:srgbClr>
+                      </a:solidFill>
+                      <a:prstDash val="solid"/>
+                    </a:lnT>
+                    <a:lnB algn="ctr" cmpd="sng" cap="flat" w="6350">
+                      <a:solidFill>
+                        <a:srgbClr val="D9D9D9">
+                          <a:alpha val="100000"/>
+                        </a:srgbClr>
+                      </a:solidFill>
+                      <a:prstDash val="solid"/>
+                    </a:lnB>
+                    <a:solidFill>
+                      <a:srgbClr val="E0E0E0">
+                        <a:alpha val="100000"/>
+                      </a:srgbClr>
+                    </a:solidFill>
+                  </a:tcPr>
+                </a:tc>
+                <a:tc hMerge="true">
+                  <a:txBody>
+                    <a:bodyPr/>
+                    <a:lstStyle/>
+                    <a:p>
+                      <a:pPr algn="ctr" marL="0" marR="0">
+                        <a:lnSpc>
+                          <a:spcPct val="10000"/>
+                        </a:lnSpc>
+                        <a:spcBef>
+                          <a:spcPts val="0"/>
+                        </a:spcBef>
+                        <a:spcAft>
+                          <a:spcPts val="0"/>
+                        </a:spcAft>
+                        <a:buNone/>
+                      </a:pPr>
+                      <a:r>
+                        <a:rPr cap="none" sz="850" i="0" b="1" u="none" strike="noStrike">
+                          <a:solidFill>
+                            <a:srgbClr val="333333">
+                              <a:alpha val="100000"/>
+                            </a:srgbClr>
+                          </a:solidFill>
+                          <a:latin typeface="Arial"/>
+                          <a:cs typeface="Arial"/>
+                          <a:ea typeface="Arial"/>
+                          <a:sym typeface="Arial"/>
+                        </a:rPr>
+                        <a:t> </a:t>
+                      </a:r>
+                    </a:p>
+                  </a:txBody>
+                  <a:tcPr anchor="ctr" marB="0" marT="0" marR="0" marL="0">
+                    <a:lnL algn="ctr" cmpd="sng" cap="flat" w="6350">
+                      <a:solidFill>
+                        <a:srgbClr val="D9D9D9">
+                          <a:alpha val="100000"/>
+                        </a:srgbClr>
+                      </a:solidFill>
+                      <a:prstDash val="solid"/>
+                    </a:lnL>
+                    <a:lnR algn="ctr" cmpd="sng" cap="flat" w="6350">
+                      <a:solidFill>
+                        <a:srgbClr val="D9D9D9">
+                          <a:alpha val="100000"/>
+                        </a:srgbClr>
+                      </a:solidFill>
+                      <a:prstDash val="solid"/>
+                    </a:lnR>
+                    <a:lnT algn="ctr" cmpd="sng" cap="flat" w="6350">
+                      <a:solidFill>
+                        <a:srgbClr val="D9D9D9">
+                          <a:alpha val="100000"/>
+                        </a:srgbClr>
+                      </a:solidFill>
+                      <a:prstDash val="solid"/>
+                    </a:lnT>
+                    <a:lnB algn="ctr" cmpd="sng" cap="flat" w="6350">
+                      <a:solidFill>
+                        <a:srgbClr val="D9D9D9">
+                          <a:alpha val="100000"/>
+                        </a:srgbClr>
+                      </a:solidFill>
+                      <a:prstDash val="solid"/>
+                    </a:lnB>
+                    <a:solidFill>
+                      <a:srgbClr val="E0E0E0">
+                        <a:alpha val="100000"/>
+                      </a:srgbClr>
+                    </a:solidFill>
+                  </a:tcPr>
+                </a:tc>
+                <a:tc hMerge="true">
+                  <a:txBody>
+                    <a:bodyPr/>
+                    <a:lstStyle/>
+                    <a:p>
+                      <a:pPr algn="ctr" marL="0" marR="0">
+                        <a:lnSpc>
+                          <a:spcPct val="10000"/>
+                        </a:lnSpc>
+                        <a:spcBef>
+                          <a:spcPts val="0"/>
+                        </a:spcBef>
+                        <a:spcAft>
+                          <a:spcPts val="0"/>
+                        </a:spcAft>
+                        <a:buNone/>
+                      </a:pPr>
+                      <a:r>
+                        <a:rPr cap="none" sz="850" i="0" b="1" u="none" strike="noStrike">
+                          <a:solidFill>
+                            <a:srgbClr val="333333">
+                              <a:alpha val="100000"/>
+                            </a:srgbClr>
+                          </a:solidFill>
+                          <a:latin typeface="Arial"/>
+                          <a:cs typeface="Arial"/>
+                          <a:ea typeface="Arial"/>
+                          <a:sym typeface="Arial"/>
+                        </a:rPr>
+                        <a:t> </a:t>
+                      </a:r>
+                    </a:p>
+                  </a:txBody>
+                  <a:tcPr anchor="ctr" marB="0" marT="0" marR="0" marL="0">
+                    <a:lnL algn="ctr" cmpd="sng" cap="flat" w="6350">
+                      <a:solidFill>
+                        <a:srgbClr val="D9D9D9">
+                          <a:alpha val="100000"/>
+                        </a:srgbClr>
+                      </a:solidFill>
+                      <a:prstDash val="solid"/>
+                    </a:lnL>
+                    <a:lnR algn="ctr" cmpd="sng" cap="flat" w="6350">
+                      <a:solidFill>
+                        <a:srgbClr val="D9D9D9">
+                          <a:alpha val="100000"/>
+                        </a:srgbClr>
+                      </a:solidFill>
+                      <a:prstDash val="solid"/>
+                    </a:lnR>
+                    <a:lnT algn="ctr" cmpd="sng" cap="flat" w="6350">
+                      <a:solidFill>
+                        <a:srgbClr val="D9D9D9">
+                          <a:alpha val="100000"/>
+                        </a:srgbClr>
+                      </a:solidFill>
+                      <a:prstDash val="solid"/>
+                    </a:lnT>
+                    <a:lnB algn="ctr" cmpd="sng" cap="flat" w="6350">
+                      <a:solidFill>
+                        <a:srgbClr val="D9D9D9">
+                          <a:alpha val="100000"/>
+                        </a:srgbClr>
+                      </a:solidFill>
+                      <a:prstDash val="solid"/>
+                    </a:lnB>
+                    <a:solidFill>
+                      <a:srgbClr val="E0E0E0">
+                        <a:alpha val="100000"/>
+                      </a:srgbClr>
+                    </a:solidFill>
+                  </a:tcPr>
+                </a:tc>
+                <a:tc hMerge="true">
+                  <a:txBody>
+                    <a:bodyPr/>
+                    <a:lstStyle/>
+                    <a:p>
+                      <a:pPr algn="ctr" marL="0" marR="0">
+                        <a:lnSpc>
+                          <a:spcPct val="10000"/>
+                        </a:lnSpc>
+                        <a:spcBef>
+                          <a:spcPts val="0"/>
+                        </a:spcBef>
+                        <a:spcAft>
+                          <a:spcPts val="0"/>
+                        </a:spcAft>
+                        <a:buNone/>
+                      </a:pPr>
+                      <a:r>
+                        <a:rPr cap="none" sz="850" i="0" b="1" u="none" strike="noStrike">
+                          <a:solidFill>
+                            <a:srgbClr val="333333">
+                              <a:alpha val="100000"/>
+                            </a:srgbClr>
+                          </a:solidFill>
+                          <a:latin typeface="Arial"/>
+                          <a:cs typeface="Arial"/>
+                          <a:ea typeface="Arial"/>
+                          <a:sym typeface="Arial"/>
+                        </a:rPr>
+                        <a:t> </a:t>
+                      </a:r>
+                    </a:p>
+                  </a:txBody>
+                  <a:tcPr anchor="ctr" marB="0" marT="0" marR="0" marL="0">
+                    <a:lnL algn="ctr" cmpd="sng" cap="flat" w="6350">
+                      <a:solidFill>
+                        <a:srgbClr val="D9D9D9">
+                          <a:alpha val="100000"/>
+                        </a:srgbClr>
+                      </a:solidFill>
+                      <a:prstDash val="solid"/>
+                    </a:lnL>
+                    <a:lnR algn="ctr" cmpd="sng" cap="flat" w="6350">
+                      <a:solidFill>
+                        <a:srgbClr val="D9D9D9">
+                          <a:alpha val="100000"/>
+                        </a:srgbClr>
+                      </a:solidFill>
+                      <a:prstDash val="solid"/>
+                    </a:lnR>
+                    <a:lnT algn="ctr" cmpd="sng" cap="flat" w="6350">
+                      <a:solidFill>
+                        <a:srgbClr val="D9D9D9">
+                          <a:alpha val="100000"/>
+                        </a:srgbClr>
+                      </a:solidFill>
+                      <a:prstDash val="solid"/>
+                    </a:lnT>
+                    <a:lnB algn="ctr" cmpd="sng" cap="flat" w="6350">
+                      <a:solidFill>
+                        <a:srgbClr val="D9D9D9">
+                          <a:alpha val="100000"/>
+                        </a:srgbClr>
+                      </a:solidFill>
+                      <a:prstDash val="solid"/>
+                    </a:lnB>
+                    <a:solidFill>
+                      <a:srgbClr val="E0E0E0">
+                        <a:alpha val="100000"/>
+                      </a:srgbClr>
+                    </a:solidFill>
+                  </a:tcPr>
+                </a:tc>
+                <a:tc hMerge="true">
+                  <a:txBody>
+                    <a:bodyPr/>
+                    <a:lstStyle/>
+                    <a:p>
+                      <a:pPr algn="ctr" marL="0" marR="0">
+                        <a:lnSpc>
+                          <a:spcPct val="10000"/>
+                        </a:lnSpc>
+                        <a:spcBef>
+                          <a:spcPts val="0"/>
+                        </a:spcBef>
+                        <a:spcAft>
+                          <a:spcPts val="0"/>
+                        </a:spcAft>
+                        <a:buNone/>
+                      </a:pPr>
+                      <a:r>
+                        <a:rPr cap="none" sz="850" i="0" b="1" u="none" strike="noStrike">
+                          <a:solidFill>
+                            <a:srgbClr val="333333">
+                              <a:alpha val="100000"/>
+                            </a:srgbClr>
+                          </a:solidFill>
+                          <a:latin typeface="Arial"/>
+                          <a:cs typeface="Arial"/>
+                          <a:ea typeface="Arial"/>
+                          <a:sym typeface="Arial"/>
+                        </a:rPr>
+                        <a:t> </a:t>
+                      </a:r>
+                    </a:p>
+                  </a:txBody>
+                  <a:tcPr anchor="ctr" marB="0" marT="0" marR="0" marL="0">
+                    <a:lnL algn="ctr" cmpd="sng" cap="flat" w="6350">
+                      <a:solidFill>
+                        <a:srgbClr val="D9D9D9">
+                          <a:alpha val="100000"/>
+                        </a:srgbClr>
+                      </a:solidFill>
+                      <a:prstDash val="solid"/>
+                    </a:lnL>
+                    <a:lnR algn="ctr" cmpd="sng" cap="flat" w="6350">
+                      <a:solidFill>
+                        <a:srgbClr val="D9D9D9">
+                          <a:alpha val="100000"/>
+                        </a:srgbClr>
+                      </a:solidFill>
+                      <a:prstDash val="solid"/>
+                    </a:lnR>
+                    <a:lnT algn="ctr" cmpd="sng" cap="flat" w="6350">
+                      <a:solidFill>
+                        <a:srgbClr val="D9D9D9">
+                          <a:alpha val="100000"/>
+                        </a:srgbClr>
+                      </a:solidFill>
+                      <a:prstDash val="solid"/>
+                    </a:lnT>
+                    <a:lnB algn="ctr" cmpd="sng" cap="flat" w="6350">
+                      <a:solidFill>
+                        <a:srgbClr val="D9D9D9">
+                          <a:alpha val="100000"/>
+                        </a:srgbClr>
+                      </a:solidFill>
+                      <a:prstDash val="solid"/>
+                    </a:lnB>
+                    <a:solidFill>
+                      <a:srgbClr val="E0E0E0">
+                        <a:alpha val="100000"/>
+                      </a:srgbClr>
+                    </a:solidFill>
+                  </a:tcPr>
+                </a:tc>
+                <a:tc hMerge="true">
+                  <a:txBody>
+                    <a:bodyPr/>
+                    <a:lstStyle/>
+                    <a:p>
+                      <a:pPr algn="ctr" marL="0" marR="0">
+                        <a:lnSpc>
+                          <a:spcPct val="10000"/>
+                        </a:lnSpc>
+                        <a:spcBef>
+                          <a:spcPts val="0"/>
+                        </a:spcBef>
+                        <a:spcAft>
+                          <a:spcPts val="0"/>
+                        </a:spcAft>
+                        <a:buNone/>
+                      </a:pPr>
+                      <a:r>
+                        <a:rPr cap="none" sz="850" i="0" b="1" u="none" strike="noStrike">
+                          <a:solidFill>
+                            <a:srgbClr val="333333">
+                              <a:alpha val="100000"/>
+                            </a:srgbClr>
+                          </a:solidFill>
+                          <a:latin typeface="Arial"/>
+                          <a:cs typeface="Arial"/>
+                          <a:ea typeface="Arial"/>
+                          <a:sym typeface="Arial"/>
+                        </a:rPr>
+                        <a:t> </a:t>
+                      </a:r>
+                    </a:p>
+                  </a:txBody>
+                  <a:tcPr anchor="ctr" marB="0" marT="0" marR="0" marL="0">
+                    <a:lnL algn="ctr" cmpd="sng" cap="flat" w="6350">
+                      <a:solidFill>
+                        <a:srgbClr val="D9D9D9">
+                          <a:alpha val="100000"/>
+                        </a:srgbClr>
+                      </a:solidFill>
+                      <a:prstDash val="solid"/>
+                    </a:lnL>
+                    <a:lnR algn="ctr" cmpd="sng" cap="flat" w="6350">
+                      <a:solidFill>
+                        <a:srgbClr val="D9D9D9">
+                          <a:alpha val="100000"/>
+                        </a:srgbClr>
+                      </a:solidFill>
+                      <a:prstDash val="solid"/>
+                    </a:lnR>
+                    <a:lnT algn="ctr" cmpd="sng" cap="flat" w="6350">
+                      <a:solidFill>
+                        <a:srgbClr val="D9D9D9">
+                          <a:alpha val="100000"/>
+                        </a:srgbClr>
+                      </a:solidFill>
+                      <a:prstDash val="solid"/>
+                    </a:lnT>
+                    <a:lnB algn="ctr" cmpd="sng" cap="flat" w="6350">
+                      <a:solidFill>
+                        <a:srgbClr val="D9D9D9">
+                          <a:alpha val="100000"/>
+                        </a:srgbClr>
+                      </a:solidFill>
+                      <a:prstDash val="solid"/>
+                    </a:lnB>
+                    <a:solidFill>
+                      <a:srgbClr val="E0E0E0">
+                        <a:alpha val="100000"/>
+                      </a:srgbClr>
+                    </a:solidFill>
+                  </a:tcPr>
+                </a:tc>
+              </a:tr>
+              <a:tr h="256032">
+                <a:tc>
+                  <a:txBody>
+                    <a:bodyPr/>
+                    <a:lstStyle/>
+                    <a:p>
+                      <a:pPr algn="ctr" marL="0" marR="0">
+                        <a:lnSpc>
+                          <a:spcPct val="10000"/>
+                        </a:lnSpc>
+                        <a:spcBef>
+                          <a:spcPts val="0"/>
+                        </a:spcBef>
+                        <a:spcAft>
+                          <a:spcPts val="0"/>
+                        </a:spcAft>
+                        <a:buNone/>
+                      </a:pPr>
+                      <a:r>
+                        <a:rPr cap="none" sz="850" i="0" b="0" u="none" strike="noStrike">
+                          <a:solidFill>
+                            <a:srgbClr val="333333">
+                              <a:alpha val="100000"/>
+                            </a:srgbClr>
+                          </a:solidFill>
+                          <a:latin typeface="Arial"/>
+                          <a:cs typeface="Arial"/>
+                          <a:ea typeface="Arial"/>
+                          <a:sym typeface="Arial"/>
+                        </a:rPr>
+                        <a:t>1WL</a:t>
+                      </a:r>
+                    </a:p>
+                  </a:txBody>
+                  <a:tcPr anchor="ctr" marB="0" marT="0" marR="0" marL="0">
+                    <a:lnL algn="ctr" cmpd="sng" cap="flat" w="6350">
+                      <a:solidFill>
+                        <a:srgbClr val="D9D9D9">
+                          <a:alpha val="100000"/>
+                        </a:srgbClr>
+                      </a:solidFill>
+                      <a:prstDash val="solid"/>
+                    </a:lnL>
+                    <a:lnR algn="ctr" cmpd="sng" cap="flat" w="6350">
+                      <a:solidFill>
+                        <a:srgbClr val="D9D9D9">
+                          <a:alpha val="100000"/>
+                        </a:srgbClr>
+                      </a:solidFill>
+                      <a:prstDash val="solid"/>
+                    </a:lnR>
+                    <a:lnT algn="ctr" cmpd="sng" cap="flat" w="6350">
+                      <a:solidFill>
+                        <a:srgbClr val="D9D9D9">
+                          <a:alpha val="100000"/>
+                        </a:srgbClr>
+                      </a:solidFill>
+                      <a:prstDash val="solid"/>
+                    </a:lnT>
+                    <a:lnB algn="ctr" cmpd="sng" cap="flat" w="6350">
+                      <a:solidFill>
+                        <a:srgbClr val="D9D9D9">
+                          <a:alpha val="100000"/>
+                        </a:srgbClr>
+                      </a:solidFill>
+                      <a:prstDash val="solid"/>
+                    </a:lnB>
+                    <a:solidFill>
+                      <a:srgbClr val="F2F2F2">
+                        <a:alpha val="100000"/>
+                      </a:srgbClr>
+                    </a:solidFill>
+                  </a:tcPr>
+                </a:tc>
+                <a:tc>
+                  <a:txBody>
+                    <a:bodyPr/>
+                    <a:lstStyle/>
+                    <a:p>
+                      <a:pPr algn="ctr" marL="0" marR="0">
+                        <a:lnSpc>
+                          <a:spcPct val="10000"/>
+                        </a:lnSpc>
+                        <a:spcBef>
+                          <a:spcPts val="0"/>
+                        </a:spcBef>
+                        <a:spcAft>
+                          <a:spcPts val="0"/>
+                        </a:spcAft>
+                        <a:buNone/>
+                      </a:pPr>
+                      <a:r>
+                        <a:rPr cap="none" sz="850" i="0" b="0" u="none" strike="noStrike">
+                          <a:solidFill>
+                            <a:srgbClr val="333333">
+                              <a:alpha val="100000"/>
+                            </a:srgbClr>
+                          </a:solidFill>
+                          <a:latin typeface="Arial"/>
+                          <a:cs typeface="Arial"/>
+                          <a:ea typeface="Arial"/>
+                          <a:sym typeface="Arial"/>
+                        </a:rPr>
+                        <a:t>2WL</a:t>
+                      </a:r>
+                    </a:p>
+                  </a:txBody>
+                  <a:tcPr anchor="ctr" marB="0" marT="0" marR="0" marL="0">
+                    <a:lnL algn="ctr" cmpd="sng" cap="flat" w="6350">
+                      <a:solidFill>
+                        <a:srgbClr val="D9D9D9">
+                          <a:alpha val="100000"/>
+                        </a:srgbClr>
+                      </a:solidFill>
+                      <a:prstDash val="solid"/>
+                    </a:lnL>
+                    <a:lnR algn="ctr" cmpd="sng" cap="flat" w="6350">
+                      <a:solidFill>
+                        <a:srgbClr val="D9D9D9">
+                          <a:alpha val="100000"/>
+                        </a:srgbClr>
+                      </a:solidFill>
+                      <a:prstDash val="solid"/>
+                    </a:lnR>
+                    <a:lnT algn="ctr" cmpd="sng" cap="flat" w="6350">
+                      <a:solidFill>
+                        <a:srgbClr val="D9D9D9">
+                          <a:alpha val="100000"/>
+                        </a:srgbClr>
+                      </a:solidFill>
+                      <a:prstDash val="solid"/>
+                    </a:lnT>
+                    <a:lnB algn="ctr" cmpd="sng" cap="flat" w="6350">
+                      <a:solidFill>
+                        <a:srgbClr val="D9D9D9">
+                          <a:alpha val="100000"/>
+                        </a:srgbClr>
+                      </a:solidFill>
+                      <a:prstDash val="solid"/>
+                    </a:lnB>
+                    <a:solidFill>
+                      <a:srgbClr val="F2F2F2">
+                        <a:alpha val="100000"/>
+                      </a:srgbClr>
+                    </a:solidFill>
+                  </a:tcPr>
+                </a:tc>
+                <a:tc>
+                  <a:txBody>
+                    <a:bodyPr/>
+                    <a:lstStyle/>
+                    <a:p>
+                      <a:pPr algn="ctr" marL="0" marR="0">
+                        <a:lnSpc>
+                          <a:spcPct val="10000"/>
+                        </a:lnSpc>
+                        <a:spcBef>
+                          <a:spcPts val="0"/>
+                        </a:spcBef>
+                        <a:spcAft>
+                          <a:spcPts val="0"/>
+                        </a:spcAft>
+                        <a:buNone/>
+                      </a:pPr>
+                      <a:r>
+                        <a:rPr cap="none" sz="850" i="0" b="0" u="none" strike="noStrike">
+                          <a:solidFill>
+                            <a:srgbClr val="333333">
+                              <a:alpha val="100000"/>
+                            </a:srgbClr>
+                          </a:solidFill>
+                          <a:latin typeface="Arial"/>
+                          <a:cs typeface="Arial"/>
+                          <a:ea typeface="Arial"/>
+                          <a:sym typeface="Arial"/>
+                        </a:rPr>
+                        <a:t>1WL</a:t>
+                      </a:r>
+                    </a:p>
+                  </a:txBody>
+                  <a:tcPr anchor="ctr" marB="0" marT="0" marR="0" marL="0">
+                    <a:lnL algn="ctr" cmpd="sng" cap="flat" w="6350">
+                      <a:solidFill>
+                        <a:srgbClr val="D9D9D9">
+                          <a:alpha val="100000"/>
+                        </a:srgbClr>
+                      </a:solidFill>
+                      <a:prstDash val="solid"/>
+                    </a:lnL>
+                    <a:lnR algn="ctr" cmpd="sng" cap="flat" w="6350">
+                      <a:solidFill>
+                        <a:srgbClr val="D9D9D9">
+                          <a:alpha val="100000"/>
+                        </a:srgbClr>
+                      </a:solidFill>
+                      <a:prstDash val="solid"/>
+                    </a:lnR>
+                    <a:lnT algn="ctr" cmpd="sng" cap="flat" w="6350">
+                      <a:solidFill>
+                        <a:srgbClr val="D9D9D9">
+                          <a:alpha val="100000"/>
+                        </a:srgbClr>
+                      </a:solidFill>
+                      <a:prstDash val="solid"/>
+                    </a:lnT>
+                    <a:lnB algn="ctr" cmpd="sng" cap="flat" w="6350">
+                      <a:solidFill>
+                        <a:srgbClr val="D9D9D9">
+                          <a:alpha val="100000"/>
+                        </a:srgbClr>
+                      </a:solidFill>
+                      <a:prstDash val="solid"/>
+                    </a:lnB>
+                    <a:solidFill>
+                      <a:srgbClr val="F2F2F2">
+                        <a:alpha val="100000"/>
+                      </a:srgbClr>
+                    </a:solidFill>
+                  </a:tcPr>
+                </a:tc>
+                <a:tc>
+                  <a:txBody>
+                    <a:bodyPr/>
+                    <a:lstStyle/>
+                    <a:p>
+                      <a:pPr algn="ctr" marL="0" marR="0">
+                        <a:lnSpc>
+                          <a:spcPct val="10000"/>
+                        </a:lnSpc>
+                        <a:spcBef>
+                          <a:spcPts val="0"/>
+                        </a:spcBef>
+                        <a:spcAft>
+                          <a:spcPts val="0"/>
+                        </a:spcAft>
+                        <a:buNone/>
+                      </a:pPr>
+                      <a:r>
+                        <a:rPr cap="none" sz="850" i="0" b="0" u="none" strike="noStrike">
+                          <a:solidFill>
+                            <a:srgbClr val="333333">
+                              <a:alpha val="100000"/>
+                            </a:srgbClr>
+                          </a:solidFill>
+                          <a:latin typeface="Arial"/>
+                          <a:cs typeface="Arial"/>
+                          <a:ea typeface="Arial"/>
+                          <a:sym typeface="Arial"/>
+                        </a:rPr>
+                        <a:t> </a:t>
+                      </a:r>
+                    </a:p>
+                  </a:txBody>
+                  <a:tcPr anchor="ctr" marB="0" marT="0" marR="0" marL="0">
+                    <a:lnL algn="ctr" cmpd="sng" cap="flat" w="6350">
+                      <a:solidFill>
+                        <a:srgbClr val="D9D9D9">
+                          <a:alpha val="100000"/>
+                        </a:srgbClr>
+                      </a:solidFill>
+                      <a:prstDash val="solid"/>
+                    </a:lnL>
+                    <a:lnR algn="ctr" cmpd="sng" cap="flat" w="6350">
+                      <a:solidFill>
+                        <a:srgbClr val="D9D9D9">
+                          <a:alpha val="100000"/>
+                        </a:srgbClr>
+                      </a:solidFill>
+                      <a:prstDash val="solid"/>
+                    </a:lnR>
+                    <a:lnT algn="ctr" cmpd="sng" cap="flat" w="6350">
+                      <a:solidFill>
+                        <a:srgbClr val="D9D9D9">
+                          <a:alpha val="100000"/>
+                        </a:srgbClr>
+                      </a:solidFill>
+                      <a:prstDash val="solid"/>
+                    </a:lnT>
+                    <a:lnB algn="ctr" cmpd="sng" cap="flat" w="6350">
+                      <a:solidFill>
+                        <a:srgbClr val="D9D9D9">
+                          <a:alpha val="100000"/>
+                        </a:srgbClr>
+                      </a:solidFill>
+                      <a:prstDash val="solid"/>
+                    </a:lnB>
+                    <a:solidFill>
+                      <a:srgbClr val="F2F2F2">
+                        <a:alpha val="100000"/>
+                      </a:srgbClr>
+                    </a:solidFill>
+                  </a:tcPr>
+                </a:tc>
+                <a:tc>
+                  <a:txBody>
+                    <a:bodyPr/>
+                    <a:lstStyle/>
+                    <a:p>
+                      <a:pPr algn="ctr" marL="0" marR="0">
+                        <a:lnSpc>
+                          <a:spcPct val="10000"/>
+                        </a:lnSpc>
+                        <a:spcBef>
+                          <a:spcPts val="0"/>
+                        </a:spcBef>
+                        <a:spcAft>
+                          <a:spcPts val="0"/>
+                        </a:spcAft>
+                        <a:buNone/>
+                      </a:pPr>
+                      <a:r>
+                        <a:rPr cap="none" sz="850" i="0" b="0" u="none" strike="noStrike">
+                          <a:solidFill>
+                            <a:srgbClr val="333333">
+                              <a:alpha val="100000"/>
+                            </a:srgbClr>
+                          </a:solidFill>
+                          <a:latin typeface="Arial"/>
+                          <a:cs typeface="Arial"/>
+                          <a:ea typeface="Arial"/>
+                          <a:sym typeface="Arial"/>
+                        </a:rPr>
+                        <a:t> </a:t>
+                      </a:r>
+                    </a:p>
+                  </a:txBody>
+                  <a:tcPr anchor="ctr" marB="0" marT="0" marR="0" marL="0">
+                    <a:lnL algn="ctr" cmpd="sng" cap="flat" w="6350">
+                      <a:solidFill>
+                        <a:srgbClr val="D9D9D9">
+                          <a:alpha val="100000"/>
+                        </a:srgbClr>
+                      </a:solidFill>
+                      <a:prstDash val="solid"/>
+                    </a:lnL>
+                    <a:lnR algn="ctr" cmpd="sng" cap="flat" w="6350">
+                      <a:solidFill>
+                        <a:srgbClr val="D9D9D9">
+                          <a:alpha val="100000"/>
+                        </a:srgbClr>
+                      </a:solidFill>
+                      <a:prstDash val="solid"/>
+                    </a:lnR>
+                    <a:lnT algn="ctr" cmpd="sng" cap="flat" w="6350">
+                      <a:solidFill>
+                        <a:srgbClr val="D9D9D9">
+                          <a:alpha val="100000"/>
+                        </a:srgbClr>
+                      </a:solidFill>
+                      <a:prstDash val="solid"/>
+                    </a:lnT>
+                    <a:lnB algn="ctr" cmpd="sng" cap="flat" w="6350">
+                      <a:solidFill>
+                        <a:srgbClr val="D9D9D9">
+                          <a:alpha val="100000"/>
+                        </a:srgbClr>
+                      </a:solidFill>
+                      <a:prstDash val="solid"/>
+                    </a:lnB>
+                    <a:solidFill>
+                      <a:srgbClr val="F2F2F2">
+                        <a:alpha val="100000"/>
+                      </a:srgbClr>
+                    </a:solidFill>
+                  </a:tcPr>
+                </a:tc>
+                <a:tc>
+                  <a:txBody>
+                    <a:bodyPr/>
+                    <a:lstStyle/>
+                    <a:p>
+                      <a:pPr algn="ctr" marL="0" marR="0">
+                        <a:lnSpc>
+                          <a:spcPct val="10000"/>
+                        </a:lnSpc>
+                        <a:spcBef>
+                          <a:spcPts val="0"/>
+                        </a:spcBef>
+                        <a:spcAft>
+                          <a:spcPts val="0"/>
+                        </a:spcAft>
+                        <a:buNone/>
+                      </a:pPr>
+                      <a:r>
+                        <a:rPr cap="none" sz="850" i="0" b="0" u="none" strike="noStrike">
+                          <a:solidFill>
+                            <a:srgbClr val="333333">
+                              <a:alpha val="100000"/>
+                            </a:srgbClr>
+                          </a:solidFill>
+                          <a:latin typeface="Arial"/>
+                          <a:cs typeface="Arial"/>
+                          <a:ea typeface="Arial"/>
+                          <a:sym typeface="Arial"/>
+                        </a:rPr>
+                        <a:t> </a:t>
+                      </a:r>
+                    </a:p>
+                  </a:txBody>
+                  <a:tcPr anchor="ctr" marB="0" marT="0" marR="0" marL="0">
+                    <a:lnL algn="ctr" cmpd="sng" cap="flat" w="6350">
+                      <a:solidFill>
+                        <a:srgbClr val="D9D9D9">
+                          <a:alpha val="100000"/>
+                        </a:srgbClr>
+                      </a:solidFill>
+                      <a:prstDash val="solid"/>
+                    </a:lnL>
+                    <a:lnR algn="ctr" cmpd="sng" cap="flat" w="6350">
+                      <a:solidFill>
+                        <a:srgbClr val="D9D9D9">
+                          <a:alpha val="100000"/>
+                        </a:srgbClr>
+                      </a:solidFill>
+                      <a:prstDash val="solid"/>
+                    </a:lnR>
+                    <a:lnT algn="ctr" cmpd="sng" cap="flat" w="6350">
+                      <a:solidFill>
+                        <a:srgbClr val="D9D9D9">
+                          <a:alpha val="100000"/>
+                        </a:srgbClr>
+                      </a:solidFill>
+                      <a:prstDash val="solid"/>
+                    </a:lnT>
+                    <a:lnB algn="ctr" cmpd="sng" cap="flat" w="6350">
+                      <a:solidFill>
+                        <a:srgbClr val="D9D9D9">
+                          <a:alpha val="100000"/>
+                        </a:srgbClr>
+                      </a:solidFill>
+                      <a:prstDash val="solid"/>
+                    </a:lnB>
+                    <a:solidFill>
+                      <a:srgbClr val="F2F2F2">
+                        <a:alpha val="100000"/>
+                      </a:srgbClr>
+                    </a:solidFill>
+                  </a:tcPr>
+                </a:tc>
+                <a:tc>
+                  <a:txBody>
+                    <a:bodyPr/>
+                    <a:lstStyle/>
+                    <a:p>
+                      <a:pPr algn="ctr" marL="0" marR="0">
+                        <a:lnSpc>
+                          <a:spcPct val="10000"/>
+                        </a:lnSpc>
+                        <a:spcBef>
+                          <a:spcPts val="0"/>
+                        </a:spcBef>
+                        <a:spcAft>
+                          <a:spcPts val="0"/>
+                        </a:spcAft>
+                        <a:buNone/>
+                      </a:pPr>
+                      <a:r>
+                        <a:rPr cap="none" sz="850" i="0" b="0" u="none" strike="noStrike">
+                          <a:solidFill>
+                            <a:srgbClr val="333333">
+                              <a:alpha val="100000"/>
+                            </a:srgbClr>
+                          </a:solidFill>
+                          <a:latin typeface="Arial"/>
+                          <a:cs typeface="Arial"/>
+                          <a:ea typeface="Arial"/>
+                          <a:sym typeface="Arial"/>
+                        </a:rPr>
+                        <a:t> </a:t>
+                      </a:r>
+                    </a:p>
+                  </a:txBody>
+                  <a:tcPr anchor="ctr" marB="0" marT="0" marR="0" marL="0">
+                    <a:lnL algn="ctr" cmpd="sng" cap="flat" w="6350">
+                      <a:solidFill>
+                        <a:srgbClr val="D9D9D9">
+                          <a:alpha val="100000"/>
+                        </a:srgbClr>
+                      </a:solidFill>
+                      <a:prstDash val="solid"/>
+                    </a:lnL>
+                    <a:lnR algn="ctr" cmpd="sng" cap="flat" w="6350">
+                      <a:solidFill>
+                        <a:srgbClr val="D9D9D9">
+                          <a:alpha val="100000"/>
+                        </a:srgbClr>
+                      </a:solidFill>
+                      <a:prstDash val="solid"/>
+                    </a:lnR>
+                    <a:lnT algn="ctr" cmpd="sng" cap="flat" w="6350">
+                      <a:solidFill>
+                        <a:srgbClr val="D9D9D9">
+                          <a:alpha val="100000"/>
+                        </a:srgbClr>
+                      </a:solidFill>
+                      <a:prstDash val="solid"/>
+                    </a:lnT>
+                    <a:lnB algn="ctr" cmpd="sng" cap="flat" w="6350">
+                      <a:solidFill>
+                        <a:srgbClr val="D9D9D9">
+                          <a:alpha val="100000"/>
+                        </a:srgbClr>
+                      </a:solidFill>
+                      <a:prstDash val="solid"/>
+                    </a:lnB>
+                    <a:solidFill>
+                      <a:srgbClr val="F2F2F2">
+                        <a:alpha val="100000"/>
+                      </a:srgbClr>
+                    </a:solidFill>
+                  </a:tcPr>
+                </a:tc>
+                <a:tc>
+                  <a:txBody>
+                    <a:bodyPr/>
+                    <a:lstStyle/>
+                    <a:p>
+                      <a:pPr algn="ctr" marL="0" marR="0">
+                        <a:lnSpc>
+                          <a:spcPct val="10000"/>
+                        </a:lnSpc>
+                        <a:spcBef>
+                          <a:spcPts val="0"/>
+                        </a:spcBef>
+                        <a:spcAft>
+                          <a:spcPts val="0"/>
+                        </a:spcAft>
+                        <a:buNone/>
+                      </a:pPr>
+                      <a:r>
+                        <a:rPr cap="none" sz="850" i="0" b="0" u="none" strike="noStrike">
+                          <a:solidFill>
+                            <a:srgbClr val="333333">
+                              <a:alpha val="100000"/>
+                            </a:srgbClr>
+                          </a:solidFill>
+                          <a:latin typeface="Arial"/>
+                          <a:cs typeface="Arial"/>
+                          <a:ea typeface="Arial"/>
+                          <a:sym typeface="Arial"/>
+                        </a:rPr>
+                        <a:t> </a:t>
+                      </a:r>
+                    </a:p>
+                  </a:txBody>
+                  <a:tcPr anchor="ctr" marB="0" marT="0" marR="0" marL="0">
+                    <a:lnL algn="ctr" cmpd="sng" cap="flat" w="6350">
+                      <a:solidFill>
+                        <a:srgbClr val="D9D9D9">
+                          <a:alpha val="100000"/>
+                        </a:srgbClr>
+                      </a:solidFill>
+                      <a:prstDash val="solid"/>
+                    </a:lnL>
+                    <a:lnR algn="ctr" cmpd="sng" cap="flat" w="6350">
+                      <a:solidFill>
+                        <a:srgbClr val="D9D9D9">
+                          <a:alpha val="100000"/>
+                        </a:srgbClr>
+                      </a:solidFill>
+                      <a:prstDash val="solid"/>
+                    </a:lnR>
+                    <a:lnT algn="ctr" cmpd="sng" cap="flat" w="6350">
+                      <a:solidFill>
+                        <a:srgbClr val="D9D9D9">
+                          <a:alpha val="100000"/>
+                        </a:srgbClr>
+                      </a:solidFill>
+                      <a:prstDash val="solid"/>
+                    </a:lnT>
+                    <a:lnB algn="ctr" cmpd="sng" cap="flat" w="6350">
+                      <a:solidFill>
+                        <a:srgbClr val="D9D9D9">
+                          <a:alpha val="100000"/>
+                        </a:srgbClr>
+                      </a:solidFill>
+                      <a:prstDash val="solid"/>
+                    </a:lnB>
+                    <a:solidFill>
+                      <a:srgbClr val="F2F2F2">
+                        <a:alpha val="100000"/>
+                      </a:srgbClr>
+                    </a:solidFill>
+                  </a:tcPr>
+                </a:tc>
+                <a:tc>
+                  <a:txBody>
+                    <a:bodyPr/>
+                    <a:lstStyle/>
+                    <a:p>
+                      <a:pPr algn="ctr" marL="0" marR="0">
+                        <a:lnSpc>
+                          <a:spcPct val="10000"/>
+                        </a:lnSpc>
+                        <a:spcBef>
+                          <a:spcPts val="0"/>
+                        </a:spcBef>
+                        <a:spcAft>
+                          <a:spcPts val="0"/>
+                        </a:spcAft>
+                        <a:buNone/>
+                      </a:pPr>
+                      <a:r>
+                        <a:rPr cap="none" sz="850" i="0" b="0" u="none" strike="noStrike">
+                          <a:solidFill>
+                            <a:srgbClr val="333333">
+                              <a:alpha val="100000"/>
+                            </a:srgbClr>
+                          </a:solidFill>
+                          <a:latin typeface="Arial"/>
+                          <a:cs typeface="Arial"/>
+                          <a:ea typeface="Arial"/>
+                          <a:sym typeface="Arial"/>
+                        </a:rPr>
+                        <a:t> </a:t>
+                      </a:r>
+                    </a:p>
+                  </a:txBody>
+                  <a:tcPr anchor="ctr" marB="0" marT="0" marR="0" marL="0">
+                    <a:lnL algn="ctr" cmpd="sng" cap="flat" w="6350">
+                      <a:solidFill>
+                        <a:srgbClr val="D9D9D9">
+                          <a:alpha val="100000"/>
+                        </a:srgbClr>
+                      </a:solidFill>
+                      <a:prstDash val="solid"/>
+                    </a:lnL>
+                    <a:lnR algn="ctr" cmpd="sng" cap="flat" w="6350">
+                      <a:solidFill>
+                        <a:srgbClr val="D9D9D9">
+                          <a:alpha val="100000"/>
+                        </a:srgbClr>
+                      </a:solidFill>
+                      <a:prstDash val="solid"/>
+                    </a:lnR>
+                    <a:lnT algn="ctr" cmpd="sng" cap="flat" w="6350">
+                      <a:solidFill>
+                        <a:srgbClr val="D9D9D9">
+                          <a:alpha val="100000"/>
+                        </a:srgbClr>
+                      </a:solidFill>
+                      <a:prstDash val="solid"/>
+                    </a:lnT>
+                    <a:lnB algn="ctr" cmpd="sng" cap="flat" w="6350">
+                      <a:solidFill>
+                        <a:srgbClr val="D9D9D9">
+                          <a:alpha val="100000"/>
+                        </a:srgbClr>
+                      </a:solidFill>
+                      <a:prstDash val="solid"/>
+                    </a:lnB>
+                    <a:solidFill>
+                      <a:srgbClr val="F2F2F2">
+                        <a:alpha val="100000"/>
+                      </a:srgbClr>
+                    </a:solidFill>
+                  </a:tcPr>
+                </a:tc>
+                <a:tc>
+                  <a:txBody>
+                    <a:bodyPr/>
+                    <a:lstStyle/>
+                    <a:p>
+                      <a:pPr algn="ctr" marL="0" marR="0">
+                        <a:lnSpc>
+                          <a:spcPct val="10000"/>
+                        </a:lnSpc>
+                        <a:spcBef>
+                          <a:spcPts val="0"/>
+                        </a:spcBef>
+                        <a:spcAft>
+                          <a:spcPts val="0"/>
+                        </a:spcAft>
+                        <a:buNone/>
+                      </a:pPr>
+                      <a:r>
+                        <a:rPr cap="none" sz="850" i="0" b="0" u="none" strike="noStrike">
+                          <a:solidFill>
+                            <a:srgbClr val="333333">
+                              <a:alpha val="100000"/>
+                            </a:srgbClr>
+                          </a:solidFill>
+                          <a:latin typeface="Arial"/>
+                          <a:cs typeface="Arial"/>
+                          <a:ea typeface="Arial"/>
+                          <a:sym typeface="Arial"/>
+                        </a:rPr>
+                        <a:t> </a:t>
+                      </a:r>
+                    </a:p>
+                  </a:txBody>
+                  <a:tcPr anchor="ctr" marB="0" marT="0" marR="0" marL="0">
+                    <a:lnL algn="ctr" cmpd="sng" cap="flat" w="6350">
+                      <a:solidFill>
+                        <a:srgbClr val="D9D9D9">
+                          <a:alpha val="100000"/>
+                        </a:srgbClr>
+                      </a:solidFill>
+                      <a:prstDash val="solid"/>
+                    </a:lnL>
+                    <a:lnR algn="ctr" cmpd="sng" cap="flat" w="6350">
+                      <a:solidFill>
+                        <a:srgbClr val="D9D9D9">
+                          <a:alpha val="100000"/>
+                        </a:srgbClr>
+                      </a:solidFill>
+                      <a:prstDash val="solid"/>
+                    </a:lnR>
+                    <a:lnT algn="ctr" cmpd="sng" cap="flat" w="6350">
+                      <a:solidFill>
+                        <a:srgbClr val="D9D9D9">
+                          <a:alpha val="100000"/>
+                        </a:srgbClr>
+                      </a:solidFill>
+                      <a:prstDash val="solid"/>
+                    </a:lnT>
+                    <a:lnB algn="ctr" cmpd="sng" cap="flat" w="6350">
+                      <a:solidFill>
+                        <a:srgbClr val="D9D9D9">
+                          <a:alpha val="100000"/>
+                        </a:srgbClr>
+                      </a:solidFill>
+                      <a:prstDash val="solid"/>
+                    </a:lnB>
+                    <a:solidFill>
+                      <a:srgbClr val="F2F2F2">
+                        <a:alpha val="100000"/>
+                      </a:srgbClr>
+                    </a:solidFill>
+                  </a:tcPr>
+                </a:tc>
+                <a:tc>
+                  <a:txBody>
+                    <a:bodyPr/>
+                    <a:lstStyle/>
+                    <a:p>
+                      <a:pPr algn="ctr" marL="0" marR="0">
+                        <a:lnSpc>
+                          <a:spcPct val="10000"/>
+                        </a:lnSpc>
+                        <a:spcBef>
+                          <a:spcPts val="0"/>
+                        </a:spcBef>
+                        <a:spcAft>
+                          <a:spcPts val="0"/>
+                        </a:spcAft>
+                        <a:buNone/>
+                      </a:pPr>
+                      <a:r>
+                        <a:rPr cap="none" sz="850" i="0" b="0" u="none" strike="noStrike">
+                          <a:solidFill>
+                            <a:srgbClr val="333333">
+                              <a:alpha val="100000"/>
+                            </a:srgbClr>
+                          </a:solidFill>
+                          <a:latin typeface="Arial"/>
+                          <a:cs typeface="Arial"/>
+                          <a:ea typeface="Arial"/>
+                          <a:sym typeface="Arial"/>
+                        </a:rPr>
+                        <a:t> </a:t>
+                      </a:r>
+                    </a:p>
+                  </a:txBody>
+                  <a:tcPr anchor="ctr" marB="0" marT="0" marR="0" marL="0">
+                    <a:lnL algn="ctr" cmpd="sng" cap="flat" w="6350">
+                      <a:solidFill>
+                        <a:srgbClr val="D9D9D9">
+                          <a:alpha val="100000"/>
+                        </a:srgbClr>
+                      </a:solidFill>
+                      <a:prstDash val="solid"/>
+                    </a:lnL>
+                    <a:lnR algn="ctr" cmpd="sng" cap="flat" w="6350">
+                      <a:solidFill>
+                        <a:srgbClr val="D9D9D9">
+                          <a:alpha val="100000"/>
+                        </a:srgbClr>
+                      </a:solidFill>
+                      <a:prstDash val="solid"/>
+                    </a:lnR>
+                    <a:lnT algn="ctr" cmpd="sng" cap="flat" w="6350">
+                      <a:solidFill>
+                        <a:srgbClr val="D9D9D9">
+                          <a:alpha val="100000"/>
+                        </a:srgbClr>
+                      </a:solidFill>
+                      <a:prstDash val="solid"/>
+                    </a:lnT>
+                    <a:lnB algn="ctr" cmpd="sng" cap="flat" w="6350">
+                      <a:solidFill>
+                        <a:srgbClr val="D9D9D9">
+                          <a:alpha val="100000"/>
+                        </a:srgbClr>
+                      </a:solidFill>
+                      <a:prstDash val="solid"/>
+                    </a:lnB>
+                    <a:solidFill>
+                      <a:srgbClr val="F2F2F2">
+                        <a:alpha val="100000"/>
+                      </a:srgbClr>
+                    </a:solidFill>
+                  </a:tcPr>
+                </a:tc>
+                <a:tc>
+                  <a:txBody>
+                    <a:bodyPr/>
+                    <a:lstStyle/>
+                    <a:p>
+                      <a:pPr algn="ctr" marL="0" marR="0">
+                        <a:lnSpc>
+                          <a:spcPct val="10000"/>
+                        </a:lnSpc>
+                        <a:spcBef>
+                          <a:spcPts val="0"/>
+                        </a:spcBef>
+                        <a:spcAft>
+                          <a:spcPts val="0"/>
+                        </a:spcAft>
+                        <a:buNone/>
+                      </a:pPr>
+                      <a:r>
+                        <a:rPr cap="none" sz="850" i="0" b="0" u="none" strike="noStrike">
+                          <a:solidFill>
+                            <a:srgbClr val="333333">
+                              <a:alpha val="100000"/>
+                            </a:srgbClr>
+                          </a:solidFill>
+                          <a:latin typeface="Arial"/>
+                          <a:cs typeface="Arial"/>
+                          <a:ea typeface="Arial"/>
+                          <a:sym typeface="Arial"/>
+                        </a:rPr>
+                        <a:t> </a:t>
+                      </a:r>
+                    </a:p>
+                  </a:txBody>
+                  <a:tcPr anchor="ctr" marB="0" marT="0" marR="0" marL="0">
+                    <a:lnL algn="ctr" cmpd="sng" cap="flat" w="6350">
+                      <a:solidFill>
+                        <a:srgbClr val="D9D9D9">
+                          <a:alpha val="100000"/>
+                        </a:srgbClr>
+                      </a:solidFill>
+                      <a:prstDash val="solid"/>
+                    </a:lnL>
+                    <a:lnR algn="ctr" cmpd="sng" cap="flat" w="6350">
+                      <a:solidFill>
+                        <a:srgbClr val="D9D9D9">
+                          <a:alpha val="100000"/>
+                        </a:srgbClr>
+                      </a:solidFill>
+                      <a:prstDash val="solid"/>
+                    </a:lnR>
+                    <a:lnT algn="ctr" cmpd="sng" cap="flat" w="6350">
+                      <a:solidFill>
+                        <a:srgbClr val="D9D9D9">
+                          <a:alpha val="100000"/>
+                        </a:srgbClr>
+                      </a:solidFill>
+                      <a:prstDash val="solid"/>
+                    </a:lnT>
+                    <a:lnB algn="ctr" cmpd="sng" cap="flat" w="6350">
+                      <a:solidFill>
+                        <a:srgbClr val="D9D9D9">
+                          <a:alpha val="100000"/>
+                        </a:srgbClr>
+                      </a:solidFill>
+                      <a:prstDash val="solid"/>
+                    </a:lnB>
+                    <a:solidFill>
+                      <a:srgbClr val="F2F2F2">
+                        <a:alpha val="100000"/>
+                      </a:srgbClr>
+                    </a:solidFill>
+                  </a:tcPr>
+                </a:tc>
+              </a:tr>
+              <a:tr h="4315968">
+                <a:tc>
+                  <a:txBody>
+                    <a:bodyPr/>
+                    <a:lstStyle/>
+                    <a:p>
+                      <a:pPr algn="ctr" marL="0" marR="0">
+                        <a:lnSpc>
+                          <a:spcPct val="10000"/>
+                        </a:lnSpc>
+                        <a:spcBef>
+                          <a:spcPts val="0"/>
+                        </a:spcBef>
+                        <a:spcAft>
+                          <a:spcPts val="0"/>
+                        </a:spcAft>
+                        <a:buNone/>
+                      </a:pPr>
+                      <a:r>
+                        <a:rPr cap="none" sz="400" i="0" b="0" u="none" strike="noStrike">
+                          <a:solidFill>
+                            <a:srgbClr val="000000">
+                              <a:alpha val="100000"/>
+                            </a:srgbClr>
+                          </a:solidFill>
+                          <a:latin typeface="Arial"/>
+                          <a:cs typeface="Arial"/>
+                          <a:ea typeface="Arial"/>
+                          <a:sym typeface="Arial"/>
+                        </a:rPr>
+                        <a:t> </a:t>
+                      </a:r>
+                    </a:p>
+                  </a:txBody>
+                  <a:tcPr anchor="ctr" marB="0" marT="0" marR="0" marL="0">
+                    <a:lnL algn="ctr" cmpd="sng" cap="flat" w="6350">
+                      <a:solidFill>
+                        <a:srgbClr val="D9D9D9">
+                          <a:alpha val="100000"/>
+                        </a:srgbClr>
+                      </a:solidFill>
+                      <a:prstDash val="solid"/>
+                    </a:lnL>
+                    <a:lnR algn="ctr" cmpd="sng" cap="flat" w="6350">
+                      <a:solidFill>
+                        <a:srgbClr val="D9D9D9">
+                          <a:alpha val="100000"/>
+                        </a:srgbClr>
+                      </a:solidFill>
+                      <a:prstDash val="solid"/>
+                    </a:lnR>
+                    <a:lnT algn="ctr" cmpd="sng" cap="flat" w="6350">
+                      <a:solidFill>
+                        <a:srgbClr val="D9D9D9">
+                          <a:alpha val="100000"/>
+                        </a:srgbClr>
+                      </a:solidFill>
+                      <a:prstDash val="solid"/>
+                    </a:lnT>
+                    <a:lnB algn="ctr" cmpd="sng" cap="flat" w="6350">
+                      <a:solidFill>
+                        <a:srgbClr val="D9D9D9">
+                          <a:alpha val="100000"/>
+                        </a:srgbClr>
+                      </a:solidFill>
+                      <a:prstDash val="solid"/>
+                    </a:lnB>
+                    <a:solidFill>
+                      <a:srgbClr val="FFFFFF">
+                        <a:alpha val="0"/>
+                      </a:srgbClr>
+                    </a:solidFill>
+                  </a:tcPr>
+                </a:tc>
+                <a:tc>
+                  <a:txBody>
+                    <a:bodyPr/>
+                    <a:lstStyle/>
+                    <a:p>
+                      <a:pPr algn="ctr" marL="0" marR="0">
+                        <a:lnSpc>
+                          <a:spcPct val="10000"/>
+                        </a:lnSpc>
+                        <a:spcBef>
+                          <a:spcPts val="0"/>
+                        </a:spcBef>
+                        <a:spcAft>
+                          <a:spcPts val="0"/>
+                        </a:spcAft>
+                        <a:buNone/>
+                      </a:pPr>
+                      <a:r>
+                        <a:rPr cap="none" sz="400" i="0" b="0" u="none" strike="noStrike">
+                          <a:solidFill>
+                            <a:srgbClr val="000000">
+                              <a:alpha val="100000"/>
+                            </a:srgbClr>
+                          </a:solidFill>
+                          <a:latin typeface="Arial"/>
+                          <a:cs typeface="Arial"/>
+                          <a:ea typeface="Arial"/>
+                          <a:sym typeface="Arial"/>
+                        </a:rPr>
+                        <a:t> </a:t>
+                      </a:r>
+                    </a:p>
+                  </a:txBody>
+                  <a:tcPr anchor="ctr" marB="0" marT="0" marR="0" marL="0">
+                    <a:lnL algn="ctr" cmpd="sng" cap="flat" w="6350">
+                      <a:solidFill>
+                        <a:srgbClr val="D9D9D9">
+                          <a:alpha val="100000"/>
+                        </a:srgbClr>
+                      </a:solidFill>
+                      <a:prstDash val="solid"/>
+                    </a:lnL>
+                    <a:lnR algn="ctr" cmpd="sng" cap="flat" w="6350">
+                      <a:solidFill>
+                        <a:srgbClr val="D9D9D9">
+                          <a:alpha val="100000"/>
+                        </a:srgbClr>
+                      </a:solidFill>
+                      <a:prstDash val="solid"/>
+                    </a:lnR>
+                    <a:lnT algn="ctr" cmpd="sng" cap="flat" w="6350">
+                      <a:solidFill>
+                        <a:srgbClr val="D9D9D9">
+                          <a:alpha val="100000"/>
+                        </a:srgbClr>
+                      </a:solidFill>
+                      <a:prstDash val="solid"/>
+                    </a:lnT>
+                    <a:lnB algn="ctr" cmpd="sng" cap="flat" w="6350">
+                      <a:solidFill>
+                        <a:srgbClr val="D9D9D9">
+                          <a:alpha val="100000"/>
+                        </a:srgbClr>
+                      </a:solidFill>
+                      <a:prstDash val="solid"/>
+                    </a:lnB>
+                    <a:solidFill>
+                      <a:srgbClr val="FFFFFF">
+                        <a:alpha val="0"/>
+                      </a:srgbClr>
+                    </a:solidFill>
+                  </a:tcPr>
+                </a:tc>
+                <a:tc>
+                  <a:txBody>
+                    <a:bodyPr/>
+                    <a:lstStyle/>
+                    <a:p>
+                      <a:pPr algn="ctr" marL="0" marR="0">
+                        <a:lnSpc>
+                          <a:spcPct val="10000"/>
+                        </a:lnSpc>
+                        <a:spcBef>
+                          <a:spcPts val="0"/>
+                        </a:spcBef>
+                        <a:spcAft>
+                          <a:spcPts val="0"/>
+                        </a:spcAft>
+                        <a:buNone/>
+                      </a:pPr>
+                      <a:r>
+                        <a:rPr cap="none" sz="400" i="0" b="0" u="none" strike="noStrike">
+                          <a:solidFill>
+                            <a:srgbClr val="000000">
+                              <a:alpha val="100000"/>
+                            </a:srgbClr>
+                          </a:solidFill>
+                          <a:latin typeface="Arial"/>
+                          <a:cs typeface="Arial"/>
+                          <a:ea typeface="Arial"/>
+                          <a:sym typeface="Arial"/>
+                        </a:rPr>
+                        <a:t> </a:t>
+                      </a:r>
+                    </a:p>
+                  </a:txBody>
+                  <a:tcPr anchor="ctr" marB="0" marT="0" marR="0" marL="0">
+                    <a:lnL algn="ctr" cmpd="sng" cap="flat" w="6350">
+                      <a:solidFill>
+                        <a:srgbClr val="D9D9D9">
+                          <a:alpha val="100000"/>
+                        </a:srgbClr>
+                      </a:solidFill>
+                      <a:prstDash val="solid"/>
+                    </a:lnL>
+                    <a:lnR algn="ctr" cmpd="sng" cap="flat" w="6350">
+                      <a:solidFill>
+                        <a:srgbClr val="D9D9D9">
+                          <a:alpha val="100000"/>
+                        </a:srgbClr>
+                      </a:solidFill>
+                      <a:prstDash val="solid"/>
+                    </a:lnR>
+                    <a:lnT algn="ctr" cmpd="sng" cap="flat" w="6350">
+                      <a:solidFill>
+                        <a:srgbClr val="D9D9D9">
+                          <a:alpha val="100000"/>
+                        </a:srgbClr>
+                      </a:solidFill>
+                      <a:prstDash val="solid"/>
+                    </a:lnT>
+                    <a:lnB algn="ctr" cmpd="sng" cap="flat" w="6350">
+                      <a:solidFill>
+                        <a:srgbClr val="D9D9D9">
+                          <a:alpha val="100000"/>
+                        </a:srgbClr>
+                      </a:solidFill>
+                      <a:prstDash val="solid"/>
+                    </a:lnB>
+                    <a:solidFill>
+                      <a:srgbClr val="FFFFFF">
+                        <a:alpha val="0"/>
+                      </a:srgbClr>
+                    </a:solidFill>
+                  </a:tcPr>
+                </a:tc>
+                <a:tc>
+                  <a:txBody>
+                    <a:bodyPr/>
+                    <a:lstStyle/>
+                    <a:p>
+                      <a:pPr algn="ctr" marL="0" marR="0">
+                        <a:lnSpc>
+                          <a:spcPct val="10000"/>
+                        </a:lnSpc>
+                        <a:spcBef>
+                          <a:spcPts val="0"/>
+                        </a:spcBef>
+                        <a:spcAft>
+                          <a:spcPts val="0"/>
+                        </a:spcAft>
+                        <a:buNone/>
+                      </a:pPr>
+                      <a:r>
+                        <a:rPr cap="none" sz="400" i="0" b="0" u="none" strike="noStrike">
+                          <a:solidFill>
+                            <a:srgbClr val="000000">
+                              <a:alpha val="100000"/>
+                            </a:srgbClr>
+                          </a:solidFill>
+                          <a:latin typeface="Arial"/>
+                          <a:cs typeface="Arial"/>
+                          <a:ea typeface="Arial"/>
+                          <a:sym typeface="Arial"/>
+                        </a:rPr>
+                        <a:t> </a:t>
+                      </a:r>
+                    </a:p>
+                  </a:txBody>
+                  <a:tcPr anchor="ctr" marB="0" marT="0" marR="0" marL="0">
+                    <a:lnL algn="ctr" cmpd="sng" cap="flat" w="6350">
+                      <a:solidFill>
+                        <a:srgbClr val="D9D9D9">
+                          <a:alpha val="100000"/>
+                        </a:srgbClr>
+                      </a:solidFill>
+                      <a:prstDash val="solid"/>
+                    </a:lnL>
+                    <a:lnR algn="ctr" cmpd="sng" cap="flat" w="6350">
+                      <a:solidFill>
+                        <a:srgbClr val="D9D9D9">
+                          <a:alpha val="100000"/>
+                        </a:srgbClr>
+                      </a:solidFill>
+                      <a:prstDash val="solid"/>
+                    </a:lnR>
+                    <a:lnT algn="ctr" cmpd="sng" cap="flat" w="6350">
+                      <a:solidFill>
+                        <a:srgbClr val="D9D9D9">
+                          <a:alpha val="100000"/>
+                        </a:srgbClr>
+                      </a:solidFill>
+                      <a:prstDash val="solid"/>
+                    </a:lnT>
+                    <a:lnB algn="ctr" cmpd="sng" cap="flat" w="6350">
+                      <a:solidFill>
+                        <a:srgbClr val="D9D9D9">
+                          <a:alpha val="100000"/>
+                        </a:srgbClr>
+                      </a:solidFill>
+                      <a:prstDash val="solid"/>
+                    </a:lnB>
+                    <a:solidFill>
+                      <a:srgbClr val="FFFFFF">
+                        <a:alpha val="0"/>
+                      </a:srgbClr>
+                    </a:solidFill>
+                  </a:tcPr>
+                </a:tc>
+                <a:tc>
+                  <a:txBody>
+                    <a:bodyPr/>
+                    <a:lstStyle/>
+                    <a:p>
+                      <a:pPr algn="ctr" marL="0" marR="0">
+                        <a:lnSpc>
+                          <a:spcPct val="10000"/>
+                        </a:lnSpc>
+                        <a:spcBef>
+                          <a:spcPts val="0"/>
+                        </a:spcBef>
+                        <a:spcAft>
+                          <a:spcPts val="0"/>
+                        </a:spcAft>
+                        <a:buNone/>
+                      </a:pPr>
+                      <a:r>
+                        <a:rPr cap="none" sz="400" i="0" b="0" u="none" strike="noStrike">
+                          <a:solidFill>
+                            <a:srgbClr val="000000">
+                              <a:alpha val="100000"/>
+                            </a:srgbClr>
+                          </a:solidFill>
+                          <a:latin typeface="Arial"/>
+                          <a:cs typeface="Arial"/>
+                          <a:ea typeface="Arial"/>
+                          <a:sym typeface="Arial"/>
+                        </a:rPr>
+                        <a:t> </a:t>
+                      </a:r>
+                    </a:p>
+                  </a:txBody>
+                  <a:tcPr anchor="ctr" marB="0" marT="0" marR="0" marL="0">
+                    <a:lnL algn="ctr" cmpd="sng" cap="flat" w="6350">
+                      <a:solidFill>
+                        <a:srgbClr val="D9D9D9">
+                          <a:alpha val="100000"/>
+                        </a:srgbClr>
+                      </a:solidFill>
+                      <a:prstDash val="solid"/>
+                    </a:lnL>
+                    <a:lnR algn="ctr" cmpd="sng" cap="flat" w="6350">
+                      <a:solidFill>
+                        <a:srgbClr val="D9D9D9">
+                          <a:alpha val="100000"/>
+                        </a:srgbClr>
+                      </a:solidFill>
+                      <a:prstDash val="solid"/>
+                    </a:lnR>
+                    <a:lnT algn="ctr" cmpd="sng" cap="flat" w="6350">
+                      <a:solidFill>
+                        <a:srgbClr val="D9D9D9">
+                          <a:alpha val="100000"/>
+                        </a:srgbClr>
+                      </a:solidFill>
+                      <a:prstDash val="solid"/>
+                    </a:lnT>
+                    <a:lnB algn="ctr" cmpd="sng" cap="flat" w="6350">
+                      <a:solidFill>
+                        <a:srgbClr val="D9D9D9">
+                          <a:alpha val="100000"/>
+                        </a:srgbClr>
+                      </a:solidFill>
+                      <a:prstDash val="solid"/>
+                    </a:lnB>
+                    <a:solidFill>
+                      <a:srgbClr val="FFFFFF">
+                        <a:alpha val="0"/>
+                      </a:srgbClr>
+                    </a:solidFill>
+                  </a:tcPr>
+                </a:tc>
+                <a:tc>
+                  <a:txBody>
+                    <a:bodyPr/>
+                    <a:lstStyle/>
+                    <a:p>
+                      <a:pPr algn="ctr" marL="0" marR="0">
+                        <a:lnSpc>
+                          <a:spcPct val="10000"/>
+                        </a:lnSpc>
+                        <a:spcBef>
+                          <a:spcPts val="0"/>
+                        </a:spcBef>
+                        <a:spcAft>
+                          <a:spcPts val="0"/>
+                        </a:spcAft>
+                        <a:buNone/>
+                      </a:pPr>
+                      <a:r>
+                        <a:rPr cap="none" sz="400" i="0" b="0" u="none" strike="noStrike">
+                          <a:solidFill>
+                            <a:srgbClr val="000000">
+                              <a:alpha val="100000"/>
+                            </a:srgbClr>
+                          </a:solidFill>
+                          <a:latin typeface="Arial"/>
+                          <a:cs typeface="Arial"/>
+                          <a:ea typeface="Arial"/>
+                          <a:sym typeface="Arial"/>
+                        </a:rPr>
+                        <a:t> </a:t>
+                      </a:r>
+                    </a:p>
+                  </a:txBody>
+                  <a:tcPr anchor="ctr" marB="0" marT="0" marR="0" marL="0">
+                    <a:lnL algn="ctr" cmpd="sng" cap="flat" w="6350">
+                      <a:solidFill>
+                        <a:srgbClr val="D9D9D9">
+                          <a:alpha val="100000"/>
+                        </a:srgbClr>
+                      </a:solidFill>
+                      <a:prstDash val="solid"/>
+                    </a:lnL>
+                    <a:lnR algn="ctr" cmpd="sng" cap="flat" w="6350">
+                      <a:solidFill>
+                        <a:srgbClr val="D9D9D9">
+                          <a:alpha val="100000"/>
+                        </a:srgbClr>
+                      </a:solidFill>
+                      <a:prstDash val="solid"/>
+                    </a:lnR>
+                    <a:lnT algn="ctr" cmpd="sng" cap="flat" w="6350">
+                      <a:solidFill>
+                        <a:srgbClr val="D9D9D9">
+                          <a:alpha val="100000"/>
+                        </a:srgbClr>
+                      </a:solidFill>
+                      <a:prstDash val="solid"/>
+                    </a:lnT>
+                    <a:lnB algn="ctr" cmpd="sng" cap="flat" w="6350">
+                      <a:solidFill>
+                        <a:srgbClr val="D9D9D9">
+                          <a:alpha val="100000"/>
+                        </a:srgbClr>
+                      </a:solidFill>
+                      <a:prstDash val="solid"/>
+                    </a:lnB>
+                    <a:solidFill>
+                      <a:srgbClr val="FFFFFF">
+                        <a:alpha val="0"/>
+                      </a:srgbClr>
+                    </a:solidFill>
+                  </a:tcPr>
+                </a:tc>
+                <a:tc>
+                  <a:txBody>
+                    <a:bodyPr/>
+                    <a:lstStyle/>
+                    <a:p>
+                      <a:pPr algn="ctr" marL="0" marR="0">
+                        <a:lnSpc>
+                          <a:spcPct val="10000"/>
+                        </a:lnSpc>
+                        <a:spcBef>
+                          <a:spcPts val="0"/>
+                        </a:spcBef>
+                        <a:spcAft>
+                          <a:spcPts val="0"/>
+                        </a:spcAft>
+                        <a:buNone/>
+                      </a:pPr>
+                      <a:r>
+                        <a:rPr cap="none" sz="400" i="0" b="0" u="none" strike="noStrike">
+                          <a:solidFill>
+                            <a:srgbClr val="000000">
+                              <a:alpha val="100000"/>
+                            </a:srgbClr>
+                          </a:solidFill>
+                          <a:latin typeface="Arial"/>
+                          <a:cs typeface="Arial"/>
+                          <a:ea typeface="Arial"/>
+                          <a:sym typeface="Arial"/>
+                        </a:rPr>
+                        <a:t> </a:t>
+                      </a:r>
+                    </a:p>
+                  </a:txBody>
+                  <a:tcPr anchor="ctr" marB="0" marT="0" marR="0" marL="0">
+                    <a:lnL algn="ctr" cmpd="sng" cap="flat" w="6350">
+                      <a:solidFill>
+                        <a:srgbClr val="D9D9D9">
+                          <a:alpha val="100000"/>
+                        </a:srgbClr>
+                      </a:solidFill>
+                      <a:prstDash val="solid"/>
+                    </a:lnL>
+                    <a:lnR algn="ctr" cmpd="sng" cap="flat" w="6350">
+                      <a:solidFill>
+                        <a:srgbClr val="D9D9D9">
+                          <a:alpha val="100000"/>
+                        </a:srgbClr>
+                      </a:solidFill>
+                      <a:prstDash val="solid"/>
+                    </a:lnR>
+                    <a:lnT algn="ctr" cmpd="sng" cap="flat" w="6350">
+                      <a:solidFill>
+                        <a:srgbClr val="D9D9D9">
+                          <a:alpha val="100000"/>
+                        </a:srgbClr>
+                      </a:solidFill>
+                      <a:prstDash val="solid"/>
+                    </a:lnT>
+                    <a:lnB algn="ctr" cmpd="sng" cap="flat" w="6350">
+                      <a:solidFill>
+                        <a:srgbClr val="D9D9D9">
+                          <a:alpha val="100000"/>
+                        </a:srgbClr>
+                      </a:solidFill>
+                      <a:prstDash val="solid"/>
+                    </a:lnB>
+                    <a:solidFill>
+                      <a:srgbClr val="FFFFFF">
+                        <a:alpha val="0"/>
+                      </a:srgbClr>
+                    </a:solidFill>
+                  </a:tcPr>
+                </a:tc>
+                <a:tc>
+                  <a:txBody>
+                    <a:bodyPr/>
+                    <a:lstStyle/>
+                    <a:p>
+                      <a:pPr algn="ctr" marL="0" marR="0">
+                        <a:lnSpc>
+                          <a:spcPct val="10000"/>
+                        </a:lnSpc>
+                        <a:spcBef>
+                          <a:spcPts val="0"/>
+                        </a:spcBef>
+                        <a:spcAft>
+                          <a:spcPts val="0"/>
+                        </a:spcAft>
+                        <a:buNone/>
+                      </a:pPr>
+                      <a:r>
+                        <a:rPr cap="none" sz="400" i="0" b="0" u="none" strike="noStrike">
+                          <a:solidFill>
+                            <a:srgbClr val="000000">
+                              <a:alpha val="100000"/>
+                            </a:srgbClr>
+                          </a:solidFill>
+                          <a:latin typeface="Arial"/>
+                          <a:cs typeface="Arial"/>
+                          <a:ea typeface="Arial"/>
+                          <a:sym typeface="Arial"/>
+                        </a:rPr>
+                        <a:t> </a:t>
+                      </a:r>
+                    </a:p>
+                  </a:txBody>
+                  <a:tcPr anchor="ctr" marB="0" marT="0" marR="0" marL="0">
+                    <a:lnL algn="ctr" cmpd="sng" cap="flat" w="6350">
+                      <a:solidFill>
+                        <a:srgbClr val="D9D9D9">
+                          <a:alpha val="100000"/>
+                        </a:srgbClr>
+                      </a:solidFill>
+                      <a:prstDash val="solid"/>
+                    </a:lnL>
+                    <a:lnR algn="ctr" cmpd="sng" cap="flat" w="6350">
+                      <a:solidFill>
+                        <a:srgbClr val="D9D9D9">
+                          <a:alpha val="100000"/>
+                        </a:srgbClr>
+                      </a:solidFill>
+                      <a:prstDash val="solid"/>
+                    </a:lnR>
+                    <a:lnT algn="ctr" cmpd="sng" cap="flat" w="6350">
+                      <a:solidFill>
+                        <a:srgbClr val="D9D9D9">
+                          <a:alpha val="100000"/>
+                        </a:srgbClr>
+                      </a:solidFill>
+                      <a:prstDash val="solid"/>
+                    </a:lnT>
+                    <a:lnB algn="ctr" cmpd="sng" cap="flat" w="6350">
+                      <a:solidFill>
+                        <a:srgbClr val="D9D9D9">
+                          <a:alpha val="100000"/>
+                        </a:srgbClr>
+                      </a:solidFill>
+                      <a:prstDash val="solid"/>
+                    </a:lnB>
+                    <a:solidFill>
+                      <a:srgbClr val="FFFFFF">
+                        <a:alpha val="0"/>
+                      </a:srgbClr>
+                    </a:solidFill>
+                  </a:tcPr>
+                </a:tc>
+                <a:tc>
+                  <a:txBody>
+                    <a:bodyPr/>
+                    <a:lstStyle/>
+                    <a:p>
+                      <a:pPr algn="ctr" marL="0" marR="0">
+                        <a:lnSpc>
+                          <a:spcPct val="10000"/>
+                        </a:lnSpc>
+                        <a:spcBef>
+                          <a:spcPts val="0"/>
+                        </a:spcBef>
+                        <a:spcAft>
+                          <a:spcPts val="0"/>
+                        </a:spcAft>
+                        <a:buNone/>
+                      </a:pPr>
+                      <a:r>
+                        <a:rPr cap="none" sz="400" i="0" b="0" u="none" strike="noStrike">
+                          <a:solidFill>
+                            <a:srgbClr val="000000">
+                              <a:alpha val="100000"/>
+                            </a:srgbClr>
+                          </a:solidFill>
+                          <a:latin typeface="Arial"/>
+                          <a:cs typeface="Arial"/>
+                          <a:ea typeface="Arial"/>
+                          <a:sym typeface="Arial"/>
+                        </a:rPr>
+                        <a:t> </a:t>
+                      </a:r>
+                    </a:p>
+                  </a:txBody>
+                  <a:tcPr anchor="ctr" marB="0" marT="0" marR="0" marL="0">
+                    <a:lnL algn="ctr" cmpd="sng" cap="flat" w="6350">
+                      <a:solidFill>
+                        <a:srgbClr val="D9D9D9">
+                          <a:alpha val="100000"/>
+                        </a:srgbClr>
+                      </a:solidFill>
+                      <a:prstDash val="solid"/>
+                    </a:lnL>
+                    <a:lnR algn="ctr" cmpd="sng" cap="flat" w="6350">
+                      <a:solidFill>
+                        <a:srgbClr val="D9D9D9">
+                          <a:alpha val="100000"/>
+                        </a:srgbClr>
+                      </a:solidFill>
+                      <a:prstDash val="solid"/>
+                    </a:lnR>
+                    <a:lnT algn="ctr" cmpd="sng" cap="flat" w="6350">
+                      <a:solidFill>
+                        <a:srgbClr val="D9D9D9">
+                          <a:alpha val="100000"/>
+                        </a:srgbClr>
+                      </a:solidFill>
+                      <a:prstDash val="solid"/>
+                    </a:lnT>
+                    <a:lnB algn="ctr" cmpd="sng" cap="flat" w="6350">
+                      <a:solidFill>
+                        <a:srgbClr val="D9D9D9">
+                          <a:alpha val="100000"/>
+                        </a:srgbClr>
+                      </a:solidFill>
+                      <a:prstDash val="solid"/>
+                    </a:lnB>
+                    <a:solidFill>
+                      <a:srgbClr val="FFFFFF">
+                        <a:alpha val="0"/>
+                      </a:srgbClr>
+                    </a:solidFill>
+                  </a:tcPr>
+                </a:tc>
+                <a:tc>
+                  <a:txBody>
+                    <a:bodyPr/>
+                    <a:lstStyle/>
+                    <a:p>
+                      <a:pPr algn="ctr" marL="0" marR="0">
+                        <a:lnSpc>
+                          <a:spcPct val="10000"/>
+                        </a:lnSpc>
+                        <a:spcBef>
+                          <a:spcPts val="0"/>
+                        </a:spcBef>
+                        <a:spcAft>
+                          <a:spcPts val="0"/>
+                        </a:spcAft>
+                        <a:buNone/>
+                      </a:pPr>
+                      <a:r>
+                        <a:rPr cap="none" sz="400" i="0" b="0" u="none" strike="noStrike">
+                          <a:solidFill>
+                            <a:srgbClr val="000000">
+                              <a:alpha val="100000"/>
+                            </a:srgbClr>
+                          </a:solidFill>
+                          <a:latin typeface="Arial"/>
+                          <a:cs typeface="Arial"/>
+                          <a:ea typeface="Arial"/>
+                          <a:sym typeface="Arial"/>
+                        </a:rPr>
+                        <a:t> </a:t>
+                      </a:r>
+                    </a:p>
+                  </a:txBody>
+                  <a:tcPr anchor="ctr" marB="0" marT="0" marR="0" marL="0">
+                    <a:lnL algn="ctr" cmpd="sng" cap="flat" w="6350">
+                      <a:solidFill>
+                        <a:srgbClr val="D9D9D9">
+                          <a:alpha val="100000"/>
+                        </a:srgbClr>
+                      </a:solidFill>
+                      <a:prstDash val="solid"/>
+                    </a:lnL>
+                    <a:lnR algn="ctr" cmpd="sng" cap="flat" w="6350">
+                      <a:solidFill>
+                        <a:srgbClr val="D9D9D9">
+                          <a:alpha val="100000"/>
+                        </a:srgbClr>
+                      </a:solidFill>
+                      <a:prstDash val="solid"/>
+                    </a:lnR>
+                    <a:lnT algn="ctr" cmpd="sng" cap="flat" w="6350">
+                      <a:solidFill>
+                        <a:srgbClr val="D9D9D9">
+                          <a:alpha val="100000"/>
+                        </a:srgbClr>
+                      </a:solidFill>
+                      <a:prstDash val="solid"/>
+                    </a:lnT>
+                    <a:lnB algn="ctr" cmpd="sng" cap="flat" w="6350">
+                      <a:solidFill>
+                        <a:srgbClr val="D9D9D9">
+                          <a:alpha val="100000"/>
+                        </a:srgbClr>
+                      </a:solidFill>
+                      <a:prstDash val="solid"/>
+                    </a:lnB>
+                    <a:solidFill>
+                      <a:srgbClr val="FFFFFF">
+                        <a:alpha val="0"/>
+                      </a:srgbClr>
+                    </a:solidFill>
+                  </a:tcPr>
+                </a:tc>
+                <a:tc>
+                  <a:txBody>
+                    <a:bodyPr/>
+                    <a:lstStyle/>
+                    <a:p>
+                      <a:pPr algn="ctr" marL="0" marR="0">
+                        <a:lnSpc>
+                          <a:spcPct val="10000"/>
+                        </a:lnSpc>
+                        <a:spcBef>
+                          <a:spcPts val="0"/>
+                        </a:spcBef>
+                        <a:spcAft>
+                          <a:spcPts val="0"/>
+                        </a:spcAft>
+                        <a:buNone/>
+                      </a:pPr>
+                      <a:r>
+                        <a:rPr cap="none" sz="400" i="0" b="0" u="none" strike="noStrike">
+                          <a:solidFill>
+                            <a:srgbClr val="000000">
+                              <a:alpha val="100000"/>
+                            </a:srgbClr>
+                          </a:solidFill>
+                          <a:latin typeface="Arial"/>
+                          <a:cs typeface="Arial"/>
+                          <a:ea typeface="Arial"/>
+                          <a:sym typeface="Arial"/>
+                        </a:rPr>
+                        <a:t> </a:t>
+                      </a:r>
+                    </a:p>
+                  </a:txBody>
+                  <a:tcPr anchor="ctr" marB="0" marT="0" marR="0" marL="0">
+                    <a:lnL algn="ctr" cmpd="sng" cap="flat" w="6350">
+                      <a:solidFill>
+                        <a:srgbClr val="D9D9D9">
+                          <a:alpha val="100000"/>
+                        </a:srgbClr>
+                      </a:solidFill>
+                      <a:prstDash val="solid"/>
+                    </a:lnL>
+                    <a:lnR algn="ctr" cmpd="sng" cap="flat" w="6350">
+                      <a:solidFill>
+                        <a:srgbClr val="D9D9D9">
+                          <a:alpha val="100000"/>
+                        </a:srgbClr>
+                      </a:solidFill>
+                      <a:prstDash val="solid"/>
+                    </a:lnR>
+                    <a:lnT algn="ctr" cmpd="sng" cap="flat" w="6350">
+                      <a:solidFill>
+                        <a:srgbClr val="D9D9D9">
+                          <a:alpha val="100000"/>
+                        </a:srgbClr>
+                      </a:solidFill>
+                      <a:prstDash val="solid"/>
+                    </a:lnT>
+                    <a:lnB algn="ctr" cmpd="sng" cap="flat" w="6350">
+                      <a:solidFill>
+                        <a:srgbClr val="D9D9D9">
+                          <a:alpha val="100000"/>
+                        </a:srgbClr>
+                      </a:solidFill>
+                      <a:prstDash val="solid"/>
+                    </a:lnB>
+                    <a:solidFill>
+                      <a:srgbClr val="FFFFFF">
+                        <a:alpha val="0"/>
+                      </a:srgbClr>
+                    </a:solidFill>
+                  </a:tcPr>
+                </a:tc>
+                <a:tc>
+                  <a:txBody>
+                    <a:bodyPr/>
+                    <a:lstStyle/>
+                    <a:p>
+                      <a:pPr algn="ctr" marL="0" marR="0">
+                        <a:lnSpc>
+                          <a:spcPct val="10000"/>
+                        </a:lnSpc>
+                        <a:spcBef>
+                          <a:spcPts val="0"/>
+                        </a:spcBef>
+                        <a:spcAft>
+                          <a:spcPts val="0"/>
+                        </a:spcAft>
+                        <a:buNone/>
+                      </a:pPr>
+                      <a:r>
+                        <a:rPr cap="none" sz="400" i="0" b="0" u="none" strike="noStrike">
+                          <a:solidFill>
+                            <a:srgbClr val="000000">
+                              <a:alpha val="100000"/>
+                            </a:srgbClr>
+                          </a:solidFill>
+                          <a:latin typeface="Arial"/>
+                          <a:cs typeface="Arial"/>
+                          <a:ea typeface="Arial"/>
+                          <a:sym typeface="Arial"/>
+                        </a:rPr>
+                        <a:t> </a:t>
+                      </a:r>
+                    </a:p>
+                  </a:txBody>
+                  <a:tcPr anchor="ctr" marB="0" marT="0" marR="0" marL="0">
+                    <a:lnL algn="ctr" cmpd="sng" cap="flat" w="6350">
+                      <a:solidFill>
+                        <a:srgbClr val="D9D9D9">
+                          <a:alpha val="100000"/>
+                        </a:srgbClr>
+                      </a:solidFill>
+                      <a:prstDash val="solid"/>
+                    </a:lnL>
+                    <a:lnR algn="ctr" cmpd="sng" cap="flat" w="6350">
+                      <a:solidFill>
+                        <a:srgbClr val="D9D9D9">
+                          <a:alpha val="100000"/>
+                        </a:srgbClr>
+                      </a:solidFill>
+                      <a:prstDash val="solid"/>
+                    </a:lnR>
+                    <a:lnT algn="ctr" cmpd="sng" cap="flat" w="6350">
+                      <a:solidFill>
+                        <a:srgbClr val="D9D9D9">
+                          <a:alpha val="100000"/>
+                        </a:srgbClr>
+                      </a:solidFill>
+                      <a:prstDash val="solid"/>
+                    </a:lnT>
+                    <a:lnB algn="ctr" cmpd="sng" cap="flat" w="6350">
+                      <a:solidFill>
+                        <a:srgbClr val="D9D9D9">
+                          <a:alpha val="100000"/>
+                        </a:srgbClr>
+                      </a:solidFill>
+                      <a:prstDash val="solid"/>
+                    </a:lnB>
+                    <a:solidFill>
+                      <a:srgbClr val="FFFFFF">
+                        <a:alpha val="0"/>
+                      </a:srgbClr>
+                    </a:solidFill>
+                  </a:tcPr>
+                </a:tc>
+              </a:tr>
+            </a:tbl>
+          </a:graphicData>
+        </a:graphic>
+      </p:graphicFrame>
+      <p:pic>
+        <p:nvPicPr>
+          <p:cNvPr id="5" name="" descr=""/>
+          <p:cNvPicPr>
+            <a:picLocks noGrp="1"/>
+          </p:cNvPicPr>
+          <p:nvPr>
+            <p:ph/>
+          </p:nvPr>
+        </p:nvPicPr>
+        <p:blipFill>
+          <a:blip r:embed="rId2"/>
+          <a:stretch>
+            <a:fillRect/>
+          </a:stretch>
+        </p:blipFill>
+        <p:spPr>
+          <a:xfrm>
+            <a:off x="9144" y="2139696"/>
+            <a:ext cx="310896" cy="4206240"/>
+          </a:xfrm>
+          <a:prstGeom prst="rect">
+            <a:avLst/>
+          </a:prstGeom>
+        </p:spPr>
+      </p:pic>
+      <p:pic>
+        <p:nvPicPr>
+          <p:cNvPr id="6" name="" descr=""/>
+          <p:cNvPicPr>
+            <a:picLocks noGrp="1"/>
+          </p:cNvPicPr>
+          <p:nvPr>
+            <p:ph/>
+          </p:nvPr>
+        </p:nvPicPr>
+        <p:blipFill>
+          <a:blip r:embed="rId3"/>
+          <a:stretch>
+            <a:fillRect/>
+          </a:stretch>
+        </p:blipFill>
+        <p:spPr>
+          <a:xfrm>
+            <a:off x="338328" y="2139696"/>
+            <a:ext cx="875538" cy="4206240"/>
+          </a:xfrm>
+          <a:prstGeom prst="rect">
+            <a:avLst/>
+          </a:prstGeom>
+        </p:spPr>
+      </p:pic>
+      <p:pic>
+        <p:nvPicPr>
+          <p:cNvPr id="7" name="" descr=""/>
+          <p:cNvPicPr>
+            <a:picLocks noGrp="1"/>
+          </p:cNvPicPr>
+          <p:nvPr>
+            <p:ph/>
+          </p:nvPr>
+        </p:nvPicPr>
+        <p:blipFill>
+          <a:blip r:embed="rId4"/>
+          <a:stretch>
+            <a:fillRect/>
+          </a:stretch>
+        </p:blipFill>
+        <p:spPr>
+          <a:xfrm>
+            <a:off x="1305306" y="2139696"/>
+            <a:ext cx="875538" cy="4206240"/>
+          </a:xfrm>
+          <a:prstGeom prst="rect">
+            <a:avLst/>
+          </a:prstGeom>
+        </p:spPr>
+      </p:pic>
+      <p:pic>
+        <p:nvPicPr>
+          <p:cNvPr id="8" name="" descr=""/>
+          <p:cNvPicPr>
+            <a:picLocks noGrp="1"/>
+          </p:cNvPicPr>
+          <p:nvPr>
+            <p:ph/>
+          </p:nvPr>
+        </p:nvPicPr>
+        <p:blipFill>
+          <a:blip r:embed="rId5"/>
+          <a:stretch>
+            <a:fillRect/>
+          </a:stretch>
+        </p:blipFill>
+        <p:spPr>
+          <a:xfrm>
+            <a:off x="2272284" y="2139696"/>
+            <a:ext cx="875538" cy="4206240"/>
+          </a:xfrm>
+          <a:prstGeom prst="rect">
+            <a:avLst/>
+          </a:prstGeom>
+        </p:spPr>
+      </p:pic>
+      <p:sp>
+        <p:nvSpPr>
+          <p:cNvPr id="9" name=""/>
+          <p:cNvSpPr>
+            <a:spLocks noGrp="1"/>
+          </p:cNvSpPr>
+          <p:nvPr>
+            <p:ph/>
+          </p:nvPr>
+        </p:nvSpPr>
+        <p:spPr>
+          <a:xfrm>
+            <a:off x="4711446" y="6446520"/>
+            <a:ext cx="2766060" cy="219456"/>
+          </a:xfrm>
+          <a:solidFill>
+            <a:srgbClr val="FFFFFF">
+              <a:alpha val="0"/>
+            </a:srgbClr>
+          </a:solidFill>
+        </p:spPr>
+        <p:txBody>
+          <a:bodyPr/>
+          <a:lstStyle/>
+          <a:p>
+            <a:pPr algn="ctr" marL="0" marR="0">
+              <a:lnSpc>
+                <a:spcPct val="100000"/>
+              </a:lnSpc>
+              <a:spcBef>
+                <a:spcPts val="0"/>
+              </a:spcBef>
+              <a:spcAft>
+                <a:spcPts val="0"/>
+              </a:spcAft>
+              <a:buNone/>
+            </a:pPr>
+            <a:r>
+              <a:rPr cap="none" sz="1000" i="0" b="1" u="none" strike="noStrike">
+                <a:solidFill>
+                  <a:srgbClr val="6489FA">
+                    <a:alpha val="100000"/>
+                  </a:srgbClr>
+                </a:solidFill>
+                <a:latin typeface="Arial"/>
+                <a:cs typeface="Arial"/>
+                <a:ea typeface="Arial"/>
+                <a:sym typeface="Arial"/>
+              </a:rPr>
+              <a:t>● A (REF, 16매)</a:t>
+            </a:r>
+            <a:r>
+              <a:rPr cap="none" sz="1000" i="0" b="0" u="none" strike="noStrike">
+                <a:solidFill>
+                  <a:srgbClr val="333333">
+                    <a:alpha val="100000"/>
+                  </a:srgbClr>
+                </a:solidFill>
+                <a:latin typeface="Arial"/>
+                <a:cs typeface="Arial"/>
+                <a:ea typeface="Arial"/>
+                <a:sym typeface="Arial"/>
+              </a:rPr>
+              <a:t>    </a:t>
+            </a:r>
+            <a:r>
+              <a:rPr cap="none" sz="1000" i="0" b="1" u="none" strike="noStrike">
+                <a:solidFill>
+                  <a:srgbClr val="FA7864">
+                    <a:alpha val="100000"/>
+                  </a:srgbClr>
+                </a:solidFill>
+                <a:latin typeface="Arial"/>
+                <a:cs typeface="Arial"/>
+                <a:ea typeface="Arial"/>
+                <a:sym typeface="Arial"/>
+              </a:rPr>
+              <a:t>● B (TARGET, 10매)</a:t>
+            </a:r>
+          </a:p>
+        </p:txBody>
+      </p:sp>
+    </p:spTree>
+  </p:cSld>
+  <p:clrMapOvr>
+    <a:masterClrMapping/>
+  </p:clrMapOvr>
+</p:sld>
+</file>
+
+<file path=ppt/slides/slide3.xml><?xml version="1.0" encoding="utf-8"?>
+<p:sld xmlns:a="http://schemas.openxmlformats.org/drawingml/2006/main" xmlns:r="http://schemas.openxmlformats.org/officeDocument/2006/relationships" xmlns:p="http://schemas.openxmlformats.org/presentationml/2006/main">
+  <p:cSld>
+    <p:spTree>
+      <p:nvGrpSpPr>
+        <p:cNvPr id="1" name=""/>
+        <p:cNvGrpSpPr/>
+        <p:nvPr/>
+      </p:nvGrpSpPr>
+      <p:grpSpPr>
+        <a:xfrm>
+          <a:off x="0" y="0"/>
+          <a:ext cx="0" cy="0"/>
+          <a:chOff x="0" y="0"/>
+          <a:chExt cx="0" cy="0"/>
+        </a:xfrm>
+      </p:grpSpPr>
+      <p:sp>
+        <p:nvSpPr>
+          <p:cNvPr id="2" name=""/>
+          <p:cNvSpPr>
+            <a:spLocks noGrp="1"/>
+          </p:cNvSpPr>
+          <p:nvPr>
+            <p:ph/>
+          </p:nvPr>
+        </p:nvSpPr>
+        <p:spPr>
+          <a:xfrm>
+            <a:off x="457200" y="237744"/>
+            <a:ext cx="11155680" cy="310896"/>
+          </a:xfrm>
+          <a:solidFill>
+            <a:srgbClr val="FFFFFF">
+              <a:alpha val="0"/>
+            </a:srgbClr>
+          </a:solidFill>
+        </p:spPr>
+        <p:txBody>
+          <a:bodyPr/>
+          <a:lstStyle/>
+          <a:p>
+            <a:pPr algn="l" marL="0" marR="0">
+              <a:lnSpc>
+                <a:spcPct val="100000"/>
+              </a:lnSpc>
+              <a:spcBef>
+                <a:spcPts val="0"/>
+              </a:spcBef>
+              <a:spcAft>
+                <a:spcPts val="0"/>
+              </a:spcAft>
+              <a:buNone/>
+            </a:pPr>
+            <a:r>
+              <a:rPr cap="none" sz="2000" i="0" b="1" u="none" strike="noStrike">
+                <a:solidFill>
+                  <a:srgbClr val="111111">
+                    <a:alpha val="100000"/>
+                  </a:srgbClr>
+                </a:solidFill>
+                <a:latin typeface="Arial"/>
+                <a:cs typeface="Arial"/>
+                <a:ea typeface="Arial"/>
+                <a:sym typeface="Arial"/>
+              </a:rPr>
+              <a:t>[DM] Data Review Board Auto Report</a:t>
+            </a:r>
+          </a:p>
+        </p:txBody>
+      </p:sp>
+      <p:sp>
+        <p:nvSpPr>
+          <p:cNvPr id="3" name=""/>
+          <p:cNvSpPr>
+            <a:spLocks noGrp="1"/>
+          </p:cNvSpPr>
+          <p:nvPr>
+            <p:ph/>
+          </p:nvPr>
+        </p:nvSpPr>
+        <p:spPr>
+          <a:xfrm>
+            <a:off x="457200" y="676656"/>
+            <a:ext cx="11155680" cy="640080"/>
+          </a:xfrm>
+          <a:solidFill>
+            <a:srgbClr val="FFFFFF">
+              <a:alpha val="0"/>
+            </a:srgbClr>
+          </a:solidFill>
+        </p:spPr>
+        <p:txBody>
+          <a:bodyPr/>
+          <a:lstStyle/>
+          <a:p>
+            <a:pPr algn="l" marL="0" marR="0">
+              <a:lnSpc>
+                <a:spcPct val="100000"/>
+              </a:lnSpc>
+              <a:spcBef>
+                <a:spcPts val="0"/>
+              </a:spcBef>
+              <a:spcAft>
+                <a:spcPts val="0"/>
+              </a:spcAft>
+              <a:buNone/>
+            </a:pPr>
+            <a:r>
+              <a:rPr cap="none" sz="1100" i="0" b="1" u="none" strike="noStrike">
+                <a:solidFill>
+                  <a:srgbClr val="333333">
+                    <a:alpha val="100000"/>
+                  </a:srgbClr>
+                </a:solidFill>
+                <a:latin typeface="Arial"/>
+                <a:cs typeface="Arial"/>
+                <a:ea typeface="Arial"/>
+                <a:sym typeface="Arial"/>
+              </a:rPr>
+              <a:t>■</a:t>
+            </a:r>
+            <a:r>
+              <a:rPr cap="none" sz="1100" i="0" b="0" u="none" strike="noStrike">
+                <a:solidFill>
+                  <a:srgbClr val="333333">
+                    <a:alpha val="100000"/>
+                  </a:srgbClr>
+                </a:solidFill>
+                <a:latin typeface="Arial"/>
+                <a:cs typeface="Arial"/>
+                <a:ea typeface="Arial"/>
+                <a:sym typeface="Arial"/>
+              </a:rPr>
               <a:t> Category: Category2: PB</a:t>
             </a:r>
           </a:p>
@@ -16372,8 +19458,8 @@
         </p:nvSpPr>
         <p:spPr>
           <a:xfrm>
-            <a:off x="4642866" y="6446520"/>
-            <a:ext cx="2903220" cy="219456"/>
+            <a:off x="4711446" y="6446520"/>
+            <a:ext cx="2766060" cy="219456"/>
           </a:xfrm>
           <a:solidFill>
             <a:srgbClr val="FFFFFF">
@@ -16450,7 +19536,7 @@
 </p:sld>
 </file>
 
-<file path=ppt/slides/slide3.xml><?xml version="1.0" encoding="utf-8"?>
+<file path=ppt/slides/slide4.xml><?xml version="1.0" encoding="utf-8"?>
 <p:sld xmlns:a="http://schemas.openxmlformats.org/drawingml/2006/main" xmlns:r="http://schemas.openxmlformats.org/officeDocument/2006/relationships" xmlns:p="http://schemas.openxmlformats.org/presentationml/2006/main">
   <p:cSld>
     <p:spTree>
@@ -18625,8 +21711,8 @@
         </p:nvSpPr>
         <p:spPr>
           <a:xfrm>
-            <a:off x="4642866" y="6446520"/>
-            <a:ext cx="2903220" cy="219456"/>
+            <a:off x="4711446" y="6446520"/>
+            <a:ext cx="2766060" cy="219456"/>
           </a:xfrm>
           <a:solidFill>
             <a:srgbClr val="FFFFFF">
@@ -18703,7 +21789,7 @@
 </p:sld>
 </file>
 
-<file path=ppt/slides/slide4.xml><?xml version="1.0" encoding="utf-8"?>
+<file path=ppt/slides/slide5.xml><?xml version="1.0" encoding="utf-8"?>
 <p:sld xmlns:a="http://schemas.openxmlformats.org/drawingml/2006/main" xmlns:r="http://schemas.openxmlformats.org/officeDocument/2006/relationships" xmlns:p="http://schemas.openxmlformats.org/presentationml/2006/main">
   <p:cSld>
     <p:spTree>
@@ -21322,8 +24408,8 @@
         </p:nvSpPr>
         <p:spPr>
           <a:xfrm>
-            <a:off x="4642866" y="6446520"/>
-            <a:ext cx="2903220" cy="219456"/>
+            <a:off x="4711446" y="6446520"/>
+            <a:ext cx="2766060" cy="219456"/>
           </a:xfrm>
           <a:solidFill>
             <a:srgbClr val="FFFFFF">
@@ -21400,7 +24486,7 @@
 </p:sld>
 </file>
 
-<file path=ppt/slides/slide5.xml><?xml version="1.0" encoding="utf-8"?>
+<file path=ppt/slides/slide6.xml><?xml version="1.0" encoding="utf-8"?>
 <p:sld xmlns:a="http://schemas.openxmlformats.org/drawingml/2006/main" xmlns:r="http://schemas.openxmlformats.org/officeDocument/2006/relationships" xmlns:p="http://schemas.openxmlformats.org/presentationml/2006/main">
   <p:cSld>
     <p:spTree>
@@ -23723,8 +26809,8 @@
         </p:nvSpPr>
         <p:spPr>
           <a:xfrm>
-            <a:off x="4642866" y="6446520"/>
-            <a:ext cx="2903220" cy="219456"/>
+            <a:off x="4711446" y="6446520"/>
+            <a:ext cx="2766060" cy="219456"/>
           </a:xfrm>
           <a:solidFill>
             <a:srgbClr val="FFFFFF">
@@ -23801,7 +26887,7 @@
 </p:sld>
 </file>
 
-<file path=ppt/slides/slide6.xml><?xml version="1.0" encoding="utf-8"?>
+<file path=ppt/slides/slide7.xml><?xml version="1.0" encoding="utf-8"?>
 <p:sld xmlns:a="http://schemas.openxmlformats.org/drawingml/2006/main" xmlns:r="http://schemas.openxmlformats.org/officeDocument/2006/relationships" xmlns:p="http://schemas.openxmlformats.org/presentationml/2006/main">
   <p:cSld>
     <p:spTree>
@@ -26420,8 +29506,8 @@
         </p:nvSpPr>
         <p:spPr>
           <a:xfrm>
-            <a:off x="4642866" y="6446520"/>
-            <a:ext cx="2903220" cy="219456"/>
+            <a:off x="4711446" y="6446520"/>
+            <a:ext cx="2766060" cy="219456"/>
           </a:xfrm>
           <a:solidFill>
             <a:srgbClr val="FFFFFF">

</xml_diff>

<commit_message>
Split Main and Suggested PPT workflows
</commit_message>
<xml_diff>
--- a/output/sigma_summary_latest.pptx
+++ b/output/sigma_summary_latest.pptx
@@ -14,7 +14,6 @@
     <p:sldId id="259" r:id="rId11"/>
     <p:sldId id="260" r:id="rId12"/>
     <p:sldId id="261" r:id="rId13"/>
-    <p:sldId id="262" r:id="rId14"/>
   </p:sldIdLst>
   <p:sldSz cx="12192000" cy="6858000"/>
   <p:notesSz cx="6858000" cy="9144000"/>
@@ -5669,7 +5668,7 @@
                   </a:tcPr>
                 </a:tc>
               </a:tr>
-              <a:tr h="370332">
+              <a:tr h="296266">
                 <a:tc rowSpan="6">
                   <a:txBody>
                     <a:bodyPr/>
@@ -6382,7 +6381,7 @@
                   </a:tcPr>
                 </a:tc>
               </a:tr>
-              <a:tr h="370332">
+              <a:tr h="296266">
                 <a:tc vMerge="true">
                   <a:txBody>
                     <a:bodyPr/>
@@ -7139,7 +7138,7 @@
                   </a:tcPr>
                 </a:tc>
               </a:tr>
-              <a:tr h="370332">
+              <a:tr h="296266">
                 <a:tc vMerge="true">
                   <a:txBody>
                     <a:bodyPr/>
@@ -7896,7 +7895,7 @@
                   </a:tcPr>
                 </a:tc>
               </a:tr>
-              <a:tr h="370332">
+              <a:tr h="296266">
                 <a:tc vMerge="true">
                   <a:txBody>
                     <a:bodyPr/>
@@ -8653,7 +8652,7 @@
                   </a:tcPr>
                 </a:tc>
               </a:tr>
-              <a:tr h="370332">
+              <a:tr h="296266">
                 <a:tc vMerge="true">
                   <a:txBody>
                     <a:bodyPr/>
@@ -9410,7 +9409,7 @@
                   </a:tcPr>
                 </a:tc>
               </a:tr>
-              <a:tr h="370332">
+              <a:tr h="296266">
                 <a:tc vMerge="true">
                   <a:txBody>
                     <a:bodyPr/>
@@ -10167,7 +10166,7 @@
                   </a:tcPr>
                 </a:tc>
               </a:tr>
-              <a:tr h="370332">
+              <a:tr h="296266">
                 <a:tc rowSpan="6">
                   <a:txBody>
                     <a:bodyPr/>
@@ -10924,7 +10923,7 @@
                   </a:tcPr>
                 </a:tc>
               </a:tr>
-              <a:tr h="370332">
+              <a:tr h="296266">
                 <a:tc vMerge="true">
                   <a:txBody>
                     <a:bodyPr/>
@@ -11681,7 +11680,7 @@
                   </a:tcPr>
                 </a:tc>
               </a:tr>
-              <a:tr h="370332">
+              <a:tr h="296266">
                 <a:tc vMerge="true">
                   <a:txBody>
                     <a:bodyPr/>
@@ -12438,7 +12437,7 @@
                   </a:tcPr>
                 </a:tc>
               </a:tr>
-              <a:tr h="370332">
+              <a:tr h="296266">
                 <a:tc vMerge="true">
                   <a:txBody>
                     <a:bodyPr/>
@@ -13195,7 +13194,7 @@
                   </a:tcPr>
                 </a:tc>
               </a:tr>
-              <a:tr h="370332">
+              <a:tr h="296266">
                 <a:tc vMerge="true">
                   <a:txBody>
                     <a:bodyPr/>
@@ -13952,7 +13951,7 @@
                   </a:tcPr>
                 </a:tc>
               </a:tr>
-              <a:tr h="370332">
+              <a:tr h="296266">
                 <a:tc vMerge="true">
                   <a:txBody>
                     <a:bodyPr/>
@@ -17877,7 +17876,7 @@
                           <a:ea typeface="Malgun Gothic"/>
                           <a:sym typeface="Malgun Gothic"/>
                         </a:rPr>
-                        <a:t>Category2: PB - MSR 1-6 of 6</a:t>
+                        <a:t>Category2: PB - MSR 1-4 of 4</a:t>
                       </a:r>
                     </a:p>
                   </a:txBody>
@@ -19925,302 +19924,6 @@
         </p:nvSpPr>
         <p:spPr>
           <a:xfrm>
-            <a:off x="329184" y="4128516"/>
-            <a:ext cx="2827782" cy="228600"/>
-          </a:xfrm>
-          <a:solidFill>
-            <a:srgbClr val="FFFFFF">
-              <a:alpha val="0"/>
-            </a:srgbClr>
-          </a:solidFill>
-        </p:spPr>
-        <p:txBody>
-          <a:bodyPr/>
-          <a:lstStyle/>
-          <a:p>
-            <a:pPr algn="ctr" marL="0" marR="0">
-              <a:lnSpc>
-                <a:spcPct val="100000"/>
-              </a:lnSpc>
-              <a:spcBef>
-                <a:spcPts val="0"/>
-              </a:spcBef>
-              <a:spcAft>
-                <a:spcPts val="0"/>
-              </a:spcAft>
-              <a:buNone/>
-            </a:pPr>
-            <a:r>
-              <a:rPr cap="none" sz="900" i="0" b="1" u="none" strike="noStrike">
-                <a:solidFill>
-                  <a:srgbClr val="D62728">
-                    <a:alpha val="100000"/>
-                  </a:srgbClr>
-                </a:solidFill>
-                <a:latin typeface="Malgun Gothic"/>
-                <a:cs typeface="Malgun Gothic"/>
-                <a:ea typeface="Malgun Gothic"/>
-                <a:sym typeface="Malgun Gothic"/>
-              </a:rPr>
-              <a:t>⬤</a:t>
-            </a:r>
-            <a:r>
-              <a:rPr cap="none" sz="900" i="0" b="0" u="none" strike="noStrike">
-                <a:solidFill>
-                  <a:srgbClr val="333333">
-                    <a:alpha val="100000"/>
-                  </a:srgbClr>
-                </a:solidFill>
-                <a:latin typeface="Malgun Gothic"/>
-                <a:cs typeface="Malgun Gothic"/>
-                <a:ea typeface="Malgun Gothic"/>
-                <a:sym typeface="Malgun Gothic"/>
-              </a:rPr>
-              <a:t> (ML_MSR_004) Peri_PB_004</a:t>
-            </a:r>
-          </a:p>
-        </p:txBody>
-      </p:sp>
-      <p:pic>
-        <p:nvPicPr>
-          <p:cNvPr id="16" name="" descr=""/>
-          <p:cNvPicPr>
-            <a:picLocks noGrp="1"/>
-          </p:cNvPicPr>
-          <p:nvPr>
-            <p:ph/>
-          </p:nvPr>
-        </p:nvPicPr>
-        <p:blipFill>
-          <a:blip r:embed="rId6"/>
-          <a:stretch>
-            <a:fillRect/>
-          </a:stretch>
-        </p:blipFill>
-        <p:spPr>
-          <a:xfrm>
-            <a:off x="329184" y="4398264"/>
-            <a:ext cx="2827782" cy="1965960"/>
-          </a:xfrm>
-          <a:prstGeom prst="rect">
-            <a:avLst/>
-          </a:prstGeom>
-        </p:spPr>
-      </p:pic>
-      <p:sp>
-        <p:nvSpPr>
-          <p:cNvPr id="17" name=""/>
-          <p:cNvSpPr>
-            <a:spLocks noGrp="1"/>
-          </p:cNvSpPr>
-          <p:nvPr>
-            <p:ph/>
-          </p:nvPr>
-        </p:nvSpPr>
-        <p:spPr>
-          <a:xfrm>
-            <a:off x="2562606" y="4425696"/>
-            <a:ext cx="566928" cy="164592"/>
-          </a:xfrm>
-          <a:solidFill>
-            <a:srgbClr val="FFFFFF">
-              <a:alpha val="0"/>
-            </a:srgbClr>
-          </a:solidFill>
-        </p:spPr>
-        <p:txBody>
-          <a:bodyPr/>
-          <a:lstStyle/>
-          <a:p>
-            <a:pPr algn="r" marL="0" marR="0">
-              <a:lnSpc>
-                <a:spcPct val="100000"/>
-              </a:lnSpc>
-              <a:spcBef>
-                <a:spcPts val="0"/>
-              </a:spcBef>
-              <a:spcAft>
-                <a:spcPts val="0"/>
-              </a:spcAft>
-              <a:buNone/>
-            </a:pPr>
-            <a:r>
-              <a:rPr cap="none" sz="800" i="0" b="0" u="none" strike="noStrike">
-                <a:solidFill>
-                  <a:srgbClr val="808080">
-                    <a:alpha val="100000"/>
-                  </a:srgbClr>
-                </a:solidFill>
-                <a:latin typeface="Malgun Gothic"/>
-                <a:cs typeface="Malgun Gothic"/>
-                <a:ea typeface="Malgun Gothic"/>
-                <a:sym typeface="Malgun Gothic"/>
-              </a:rPr>
-              <a:t>+0.6sig</a:t>
-            </a:r>
-          </a:p>
-        </p:txBody>
-      </p:sp>
-      <p:sp>
-        <p:nvSpPr>
-          <p:cNvPr id="18" name=""/>
-          <p:cNvSpPr>
-            <a:spLocks noGrp="1"/>
-          </p:cNvSpPr>
-          <p:nvPr>
-            <p:ph/>
-          </p:nvPr>
-        </p:nvSpPr>
-        <p:spPr>
-          <a:xfrm>
-            <a:off x="3230118" y="4128516"/>
-            <a:ext cx="2827782" cy="228600"/>
-          </a:xfrm>
-          <a:solidFill>
-            <a:srgbClr val="FFFFFF">
-              <a:alpha val="0"/>
-            </a:srgbClr>
-          </a:solidFill>
-        </p:spPr>
-        <p:txBody>
-          <a:bodyPr/>
-          <a:lstStyle/>
-          <a:p>
-            <a:pPr algn="ctr" marL="0" marR="0">
-              <a:lnSpc>
-                <a:spcPct val="100000"/>
-              </a:lnSpc>
-              <a:spcBef>
-                <a:spcPts val="0"/>
-              </a:spcBef>
-              <a:spcAft>
-                <a:spcPts val="0"/>
-              </a:spcAft>
-              <a:buNone/>
-            </a:pPr>
-            <a:r>
-              <a:rPr cap="none" sz="900" i="0" b="1" u="none" strike="noStrike">
-                <a:solidFill>
-                  <a:srgbClr val="D62728">
-                    <a:alpha val="100000"/>
-                  </a:srgbClr>
-                </a:solidFill>
-                <a:latin typeface="Malgun Gothic"/>
-                <a:cs typeface="Malgun Gothic"/>
-                <a:ea typeface="Malgun Gothic"/>
-                <a:sym typeface="Malgun Gothic"/>
-              </a:rPr>
-              <a:t>⬤</a:t>
-            </a:r>
-            <a:r>
-              <a:rPr cap="none" sz="900" i="0" b="0" u="none" strike="noStrike">
-                <a:solidFill>
-                  <a:srgbClr val="333333">
-                    <a:alpha val="100000"/>
-                  </a:srgbClr>
-                </a:solidFill>
-                <a:latin typeface="Malgun Gothic"/>
-                <a:cs typeface="Malgun Gothic"/>
-                <a:ea typeface="Malgun Gothic"/>
-                <a:sym typeface="Malgun Gothic"/>
-              </a:rPr>
-              <a:t> (ML_MSR_034) Peri_PB_034</a:t>
-            </a:r>
-          </a:p>
-        </p:txBody>
-      </p:sp>
-      <p:pic>
-        <p:nvPicPr>
-          <p:cNvPr id="19" name="" descr=""/>
-          <p:cNvPicPr>
-            <a:picLocks noGrp="1"/>
-          </p:cNvPicPr>
-          <p:nvPr>
-            <p:ph/>
-          </p:nvPr>
-        </p:nvPicPr>
-        <p:blipFill>
-          <a:blip r:embed="rId7"/>
-          <a:stretch>
-            <a:fillRect/>
-          </a:stretch>
-        </p:blipFill>
-        <p:spPr>
-          <a:xfrm>
-            <a:off x="3230118" y="4398264"/>
-            <a:ext cx="2827782" cy="1965960"/>
-          </a:xfrm>
-          <a:prstGeom prst="rect">
-            <a:avLst/>
-          </a:prstGeom>
-        </p:spPr>
-      </p:pic>
-      <p:sp>
-        <p:nvSpPr>
-          <p:cNvPr id="20" name=""/>
-          <p:cNvSpPr>
-            <a:spLocks noGrp="1"/>
-          </p:cNvSpPr>
-          <p:nvPr>
-            <p:ph/>
-          </p:nvPr>
-        </p:nvSpPr>
-        <p:spPr>
-          <a:xfrm>
-            <a:off x="5463540" y="4425696"/>
-            <a:ext cx="566928" cy="164592"/>
-          </a:xfrm>
-          <a:solidFill>
-            <a:srgbClr val="FFFFFF">
-              <a:alpha val="0"/>
-            </a:srgbClr>
-          </a:solidFill>
-        </p:spPr>
-        <p:txBody>
-          <a:bodyPr/>
-          <a:lstStyle/>
-          <a:p>
-            <a:pPr algn="r" marL="0" marR="0">
-              <a:lnSpc>
-                <a:spcPct val="100000"/>
-              </a:lnSpc>
-              <a:spcBef>
-                <a:spcPts val="0"/>
-              </a:spcBef>
-              <a:spcAft>
-                <a:spcPts val="0"/>
-              </a:spcAft>
-              <a:buNone/>
-            </a:pPr>
-            <a:r>
-              <a:rPr cap="none" sz="800" i="0" b="0" u="none" strike="noStrike">
-                <a:solidFill>
-                  <a:srgbClr val="808080">
-                    <a:alpha val="100000"/>
-                  </a:srgbClr>
-                </a:solidFill>
-                <a:latin typeface="Malgun Gothic"/>
-                <a:cs typeface="Malgun Gothic"/>
-                <a:ea typeface="Malgun Gothic"/>
-                <a:sym typeface="Malgun Gothic"/>
-              </a:rPr>
-              <a:t>+0.5sig</a:t>
-            </a:r>
-          </a:p>
-        </p:txBody>
-      </p:sp>
-      <p:sp>
-        <p:nvSpPr>
-          <p:cNvPr id="21" name=""/>
-          <p:cNvSpPr>
-            <a:spLocks noGrp="1"/>
-          </p:cNvSpPr>
-          <p:nvPr>
-            <p:ph/>
-          </p:nvPr>
-        </p:nvSpPr>
-        <p:spPr>
-          <a:xfrm>
             <a:off x="4642866" y="6446520"/>
             <a:ext cx="2903220" cy="219456"/>
           </a:xfrm>
@@ -20293,7 +19996,7 @@
       </p:sp>
       <p:sp>
         <p:nvSpPr>
-          <p:cNvPr id="22" name="DRB_Title_Placeholder"/>
+          <p:cNvPr id="16" name="DRB_Title_Placeholder"/>
           <p:cNvSpPr>
             <a:spLocks noGrp="1"/>
           </p:cNvSpPr>
@@ -20342,7 +20045,7 @@
       </p:sp>
       <p:sp>
         <p:nvSpPr>
-          <p:cNvPr id="23" name="DRB_Body_Placeholder"/>
+          <p:cNvPr id="17" name="DRB_Body_Placeholder"/>
           <p:cNvSpPr>
             <a:spLocks noGrp="1"/>
           </p:cNvSpPr>
@@ -20398,7 +20101,7 @@
                 <a:ea typeface="Malgun Gothic"/>
                 <a:sym typeface="Malgun Gothic"/>
               </a:rPr>
-              <a:t> Category: Category2: PB | Showing MSR 1-6 of 6</a:t>
+              <a:t> Category: Category2: PB | Showing MSR 1-4 of 4</a:t>
             </a:r>
           </a:p>
           <a:p>
@@ -20447,7 +20150,7 @@
       </p:sp>
       <p:sp>
         <p:nvSpPr>
-          <p:cNvPr id="24" name=""/>
+          <p:cNvPr id="18" name=""/>
           <p:cNvSpPr>
             <a:spLocks noGrp="1"/>
           </p:cNvSpPr>
@@ -20576,7 +20279,7 @@
                           <a:ea typeface="Malgun Gothic"/>
                           <a:sym typeface="Malgun Gothic"/>
                         </a:rPr>
-                        <a:t>Category2: WLS - MSR 1-3 of 3</a:t>
+                        <a:t>Category2: WLS - MSR 1 of 1</a:t>
                       </a:r>
                     </a:p>
                   </a:txBody>
@@ -22180,302 +21883,6 @@
         </p:nvSpPr>
         <p:spPr>
           <a:xfrm>
-            <a:off x="3230118" y="1842516"/>
-            <a:ext cx="2827782" cy="228600"/>
-          </a:xfrm>
-          <a:solidFill>
-            <a:srgbClr val="FFFFFF">
-              <a:alpha val="0"/>
-            </a:srgbClr>
-          </a:solidFill>
-        </p:spPr>
-        <p:txBody>
-          <a:bodyPr/>
-          <a:lstStyle/>
-          <a:p>
-            <a:pPr algn="ctr" marL="0" marR="0">
-              <a:lnSpc>
-                <a:spcPct val="100000"/>
-              </a:lnSpc>
-              <a:spcBef>
-                <a:spcPts val="0"/>
-              </a:spcBef>
-              <a:spcAft>
-                <a:spcPts val="0"/>
-              </a:spcAft>
-              <a:buNone/>
-            </a:pPr>
-            <a:r>
-              <a:rPr cap="none" sz="900" i="0" b="1" u="none" strike="noStrike">
-                <a:solidFill>
-                  <a:srgbClr val="D62728">
-                    <a:alpha val="100000"/>
-                  </a:srgbClr>
-                </a:solidFill>
-                <a:latin typeface="Malgun Gothic"/>
-                <a:cs typeface="Malgun Gothic"/>
-                <a:ea typeface="Malgun Gothic"/>
-                <a:sym typeface="Malgun Gothic"/>
-              </a:rPr>
-              <a:t>⬤</a:t>
-            </a:r>
-            <a:r>
-              <a:rPr cap="none" sz="900" i="0" b="0" u="none" strike="noStrike">
-                <a:solidFill>
-                  <a:srgbClr val="333333">
-                    <a:alpha val="100000"/>
-                  </a:srgbClr>
-                </a:solidFill>
-                <a:latin typeface="Malgun Gothic"/>
-                <a:cs typeface="Malgun Gothic"/>
-                <a:ea typeface="Malgun Gothic"/>
-                <a:sym typeface="Malgun Gothic"/>
-              </a:rPr>
-              <a:t> (ML_MSR_196) Cell_WLS_196</a:t>
-            </a:r>
-          </a:p>
-        </p:txBody>
-      </p:sp>
-      <p:pic>
-        <p:nvPicPr>
-          <p:cNvPr id="7" name="" descr=""/>
-          <p:cNvPicPr>
-            <a:picLocks noGrp="1"/>
-          </p:cNvPicPr>
-          <p:nvPr>
-            <p:ph/>
-          </p:nvPr>
-        </p:nvPicPr>
-        <p:blipFill>
-          <a:blip r:embed="rId3"/>
-          <a:stretch>
-            <a:fillRect/>
-          </a:stretch>
-        </p:blipFill>
-        <p:spPr>
-          <a:xfrm>
-            <a:off x="3230118" y="2112264"/>
-            <a:ext cx="2827782" cy="1965960"/>
-          </a:xfrm>
-          <a:prstGeom prst="rect">
-            <a:avLst/>
-          </a:prstGeom>
-        </p:spPr>
-      </p:pic>
-      <p:sp>
-        <p:nvSpPr>
-          <p:cNvPr id="8" name=""/>
-          <p:cNvSpPr>
-            <a:spLocks noGrp="1"/>
-          </p:cNvSpPr>
-          <p:nvPr>
-            <p:ph/>
-          </p:nvPr>
-        </p:nvSpPr>
-        <p:spPr>
-          <a:xfrm>
-            <a:off x="5463540" y="2139696"/>
-            <a:ext cx="566928" cy="164592"/>
-          </a:xfrm>
-          <a:solidFill>
-            <a:srgbClr val="FFFFFF">
-              <a:alpha val="0"/>
-            </a:srgbClr>
-          </a:solidFill>
-        </p:spPr>
-        <p:txBody>
-          <a:bodyPr/>
-          <a:lstStyle/>
-          <a:p>
-            <a:pPr algn="r" marL="0" marR="0">
-              <a:lnSpc>
-                <a:spcPct val="100000"/>
-              </a:lnSpc>
-              <a:spcBef>
-                <a:spcPts val="0"/>
-              </a:spcBef>
-              <a:spcAft>
-                <a:spcPts val="0"/>
-              </a:spcAft>
-              <a:buNone/>
-            </a:pPr>
-            <a:r>
-              <a:rPr cap="none" sz="800" i="0" b="0" u="none" strike="noStrike">
-                <a:solidFill>
-                  <a:srgbClr val="808080">
-                    <a:alpha val="100000"/>
-                  </a:srgbClr>
-                </a:solidFill>
-                <a:latin typeface="Malgun Gothic"/>
-                <a:cs typeface="Malgun Gothic"/>
-                <a:ea typeface="Malgun Gothic"/>
-                <a:sym typeface="Malgun Gothic"/>
-              </a:rPr>
-              <a:t>+0.5sig</a:t>
-            </a:r>
-          </a:p>
-        </p:txBody>
-      </p:sp>
-      <p:sp>
-        <p:nvSpPr>
-          <p:cNvPr id="9" name=""/>
-          <p:cNvSpPr>
-            <a:spLocks noGrp="1"/>
-          </p:cNvSpPr>
-          <p:nvPr>
-            <p:ph/>
-          </p:nvPr>
-        </p:nvSpPr>
-        <p:spPr>
-          <a:xfrm>
-            <a:off x="6131052" y="1842516"/>
-            <a:ext cx="2827782" cy="228600"/>
-          </a:xfrm>
-          <a:solidFill>
-            <a:srgbClr val="FFFFFF">
-              <a:alpha val="0"/>
-            </a:srgbClr>
-          </a:solidFill>
-        </p:spPr>
-        <p:txBody>
-          <a:bodyPr/>
-          <a:lstStyle/>
-          <a:p>
-            <a:pPr algn="ctr" marL="0" marR="0">
-              <a:lnSpc>
-                <a:spcPct val="100000"/>
-              </a:lnSpc>
-              <a:spcBef>
-                <a:spcPts val="0"/>
-              </a:spcBef>
-              <a:spcAft>
-                <a:spcPts val="0"/>
-              </a:spcAft>
-              <a:buNone/>
-            </a:pPr>
-            <a:r>
-              <a:rPr cap="none" sz="900" i="0" b="1" u="none" strike="noStrike">
-                <a:solidFill>
-                  <a:srgbClr val="D62728">
-                    <a:alpha val="100000"/>
-                  </a:srgbClr>
-                </a:solidFill>
-                <a:latin typeface="Malgun Gothic"/>
-                <a:cs typeface="Malgun Gothic"/>
-                <a:ea typeface="Malgun Gothic"/>
-                <a:sym typeface="Malgun Gothic"/>
-              </a:rPr>
-              <a:t>⬤</a:t>
-            </a:r>
-            <a:r>
-              <a:rPr cap="none" sz="900" i="0" b="0" u="none" strike="noStrike">
-                <a:solidFill>
-                  <a:srgbClr val="333333">
-                    <a:alpha val="100000"/>
-                  </a:srgbClr>
-                </a:solidFill>
-                <a:latin typeface="Malgun Gothic"/>
-                <a:cs typeface="Malgun Gothic"/>
-                <a:ea typeface="Malgun Gothic"/>
-                <a:sym typeface="Malgun Gothic"/>
-              </a:rPr>
-              <a:t> (ML_MSR_193) Cell_WLS_193</a:t>
-            </a:r>
-          </a:p>
-        </p:txBody>
-      </p:sp>
-      <p:pic>
-        <p:nvPicPr>
-          <p:cNvPr id="10" name="" descr=""/>
-          <p:cNvPicPr>
-            <a:picLocks noGrp="1"/>
-          </p:cNvPicPr>
-          <p:nvPr>
-            <p:ph/>
-          </p:nvPr>
-        </p:nvPicPr>
-        <p:blipFill>
-          <a:blip r:embed="rId4"/>
-          <a:stretch>
-            <a:fillRect/>
-          </a:stretch>
-        </p:blipFill>
-        <p:spPr>
-          <a:xfrm>
-            <a:off x="6131052" y="2112264"/>
-            <a:ext cx="2827782" cy="1965960"/>
-          </a:xfrm>
-          <a:prstGeom prst="rect">
-            <a:avLst/>
-          </a:prstGeom>
-        </p:spPr>
-      </p:pic>
-      <p:sp>
-        <p:nvSpPr>
-          <p:cNvPr id="11" name=""/>
-          <p:cNvSpPr>
-            <a:spLocks noGrp="1"/>
-          </p:cNvSpPr>
-          <p:nvPr>
-            <p:ph/>
-          </p:nvPr>
-        </p:nvSpPr>
-        <p:spPr>
-          <a:xfrm>
-            <a:off x="8364474" y="2139696"/>
-            <a:ext cx="566928" cy="164592"/>
-          </a:xfrm>
-          <a:solidFill>
-            <a:srgbClr val="FFFFFF">
-              <a:alpha val="0"/>
-            </a:srgbClr>
-          </a:solidFill>
-        </p:spPr>
-        <p:txBody>
-          <a:bodyPr/>
-          <a:lstStyle/>
-          <a:p>
-            <a:pPr algn="r" marL="0" marR="0">
-              <a:lnSpc>
-                <a:spcPct val="100000"/>
-              </a:lnSpc>
-              <a:spcBef>
-                <a:spcPts val="0"/>
-              </a:spcBef>
-              <a:spcAft>
-                <a:spcPts val="0"/>
-              </a:spcAft>
-              <a:buNone/>
-            </a:pPr>
-            <a:r>
-              <a:rPr cap="none" sz="800" i="0" b="0" u="none" strike="noStrike">
-                <a:solidFill>
-                  <a:srgbClr val="808080">
-                    <a:alpha val="100000"/>
-                  </a:srgbClr>
-                </a:solidFill>
-                <a:latin typeface="Malgun Gothic"/>
-                <a:cs typeface="Malgun Gothic"/>
-                <a:ea typeface="Malgun Gothic"/>
-                <a:sym typeface="Malgun Gothic"/>
-              </a:rPr>
-              <a:t>+0.5sig</a:t>
-            </a:r>
-          </a:p>
-        </p:txBody>
-      </p:sp>
-      <p:sp>
-        <p:nvSpPr>
-          <p:cNvPr id="12" name=""/>
-          <p:cNvSpPr>
-            <a:spLocks noGrp="1"/>
-          </p:cNvSpPr>
-          <p:nvPr>
-            <p:ph/>
-          </p:nvPr>
-        </p:nvSpPr>
-        <p:spPr>
-          <a:xfrm>
             <a:off x="4642866" y="6446520"/>
             <a:ext cx="2903220" cy="219456"/>
           </a:xfrm>
@@ -22548,7 +21955,7 @@
       </p:sp>
       <p:sp>
         <p:nvSpPr>
-          <p:cNvPr id="13" name="DRB_Title_Placeholder"/>
+          <p:cNvPr id="7" name="DRB_Title_Placeholder"/>
           <p:cNvSpPr>
             <a:spLocks noGrp="1"/>
           </p:cNvSpPr>
@@ -22597,7 +22004,7 @@
       </p:sp>
       <p:sp>
         <p:nvSpPr>
-          <p:cNvPr id="14" name="DRB_Body_Placeholder"/>
+          <p:cNvPr id="8" name="DRB_Body_Placeholder"/>
           <p:cNvSpPr>
             <a:spLocks noGrp="1"/>
           </p:cNvSpPr>
@@ -22653,7 +22060,7 @@
                 <a:ea typeface="Malgun Gothic"/>
                 <a:sym typeface="Malgun Gothic"/>
               </a:rPr>
-              <a:t> Category: Category2: WLS | Showing MSR 1-3 of 3</a:t>
+              <a:t> Category: Category2: WLS | Showing MSR 1-1 of 1</a:t>
             </a:r>
           </a:p>
           <a:p>
@@ -22702,7 +22109,7 @@
       </p:sp>
       <p:sp>
         <p:nvSpPr>
-          <p:cNvPr id="15" name=""/>
+          <p:cNvPr id="9" name=""/>
           <p:cNvSpPr>
             <a:spLocks noGrp="1"/>
           </p:cNvSpPr>
@@ -22831,7 +22238,7 @@
                           <a:ea typeface="Malgun Gothic"/>
                           <a:sym typeface="Malgun Gothic"/>
                         </a:rPr>
-                        <a:t>Category2: BL - MSR 1-6 of 6</a:t>
+                        <a:t>Category2: BL - MSR 1 of 1</a:t>
                       </a:r>
                     </a:p>
                   </a:txBody>
@@ -24435,746 +23842,6 @@
         </p:nvSpPr>
         <p:spPr>
           <a:xfrm>
-            <a:off x="3230118" y="1842516"/>
-            <a:ext cx="2827782" cy="228600"/>
-          </a:xfrm>
-          <a:solidFill>
-            <a:srgbClr val="FFFFFF">
-              <a:alpha val="0"/>
-            </a:srgbClr>
-          </a:solidFill>
-        </p:spPr>
-        <p:txBody>
-          <a:bodyPr/>
-          <a:lstStyle/>
-          <a:p>
-            <a:pPr algn="ctr" marL="0" marR="0">
-              <a:lnSpc>
-                <a:spcPct val="100000"/>
-              </a:lnSpc>
-              <a:spcBef>
-                <a:spcPts val="0"/>
-              </a:spcBef>
-              <a:spcAft>
-                <a:spcPts val="0"/>
-              </a:spcAft>
-              <a:buNone/>
-            </a:pPr>
-            <a:r>
-              <a:rPr cap="none" sz="900" i="0" b="1" u="none" strike="noStrike">
-                <a:solidFill>
-                  <a:srgbClr val="D62728">
-                    <a:alpha val="100000"/>
-                  </a:srgbClr>
-                </a:solidFill>
-                <a:latin typeface="Malgun Gothic"/>
-                <a:cs typeface="Malgun Gothic"/>
-                <a:ea typeface="Malgun Gothic"/>
-                <a:sym typeface="Malgun Gothic"/>
-              </a:rPr>
-              <a:t>⬤</a:t>
-            </a:r>
-            <a:r>
-              <a:rPr cap="none" sz="900" i="0" b="0" u="none" strike="noStrike">
-                <a:solidFill>
-                  <a:srgbClr val="333333">
-                    <a:alpha val="100000"/>
-                  </a:srgbClr>
-                </a:solidFill>
-                <a:latin typeface="Malgun Gothic"/>
-                <a:cs typeface="Malgun Gothic"/>
-                <a:ea typeface="Malgun Gothic"/>
-                <a:sym typeface="Malgun Gothic"/>
-              </a:rPr>
-              <a:t> (ML_MSR_122) Peri_BL_122</a:t>
-            </a:r>
-          </a:p>
-        </p:txBody>
-      </p:sp>
-      <p:pic>
-        <p:nvPicPr>
-          <p:cNvPr id="7" name="" descr=""/>
-          <p:cNvPicPr>
-            <a:picLocks noGrp="1"/>
-          </p:cNvPicPr>
-          <p:nvPr>
-            <p:ph/>
-          </p:nvPr>
-        </p:nvPicPr>
-        <p:blipFill>
-          <a:blip r:embed="rId3"/>
-          <a:stretch>
-            <a:fillRect/>
-          </a:stretch>
-        </p:blipFill>
-        <p:spPr>
-          <a:xfrm>
-            <a:off x="3230118" y="2112264"/>
-            <a:ext cx="2827782" cy="1965960"/>
-          </a:xfrm>
-          <a:prstGeom prst="rect">
-            <a:avLst/>
-          </a:prstGeom>
-        </p:spPr>
-      </p:pic>
-      <p:sp>
-        <p:nvSpPr>
-          <p:cNvPr id="8" name=""/>
-          <p:cNvSpPr>
-            <a:spLocks noGrp="1"/>
-          </p:cNvSpPr>
-          <p:nvPr>
-            <p:ph/>
-          </p:nvPr>
-        </p:nvSpPr>
-        <p:spPr>
-          <a:xfrm>
-            <a:off x="5463540" y="2139696"/>
-            <a:ext cx="566928" cy="164592"/>
-          </a:xfrm>
-          <a:solidFill>
-            <a:srgbClr val="FFFFFF">
-              <a:alpha val="0"/>
-            </a:srgbClr>
-          </a:solidFill>
-        </p:spPr>
-        <p:txBody>
-          <a:bodyPr/>
-          <a:lstStyle/>
-          <a:p>
-            <a:pPr algn="r" marL="0" marR="0">
-              <a:lnSpc>
-                <a:spcPct val="100000"/>
-              </a:lnSpc>
-              <a:spcBef>
-                <a:spcPts val="0"/>
-              </a:spcBef>
-              <a:spcAft>
-                <a:spcPts val="0"/>
-              </a:spcAft>
-              <a:buNone/>
-            </a:pPr>
-            <a:r>
-              <a:rPr cap="none" sz="800" i="0" b="0" u="none" strike="noStrike">
-                <a:solidFill>
-                  <a:srgbClr val="808080">
-                    <a:alpha val="100000"/>
-                  </a:srgbClr>
-                </a:solidFill>
-                <a:latin typeface="Malgun Gothic"/>
-                <a:cs typeface="Malgun Gothic"/>
-                <a:ea typeface="Malgun Gothic"/>
-                <a:sym typeface="Malgun Gothic"/>
-              </a:rPr>
-              <a:t>+0.7sig</a:t>
-            </a:r>
-          </a:p>
-        </p:txBody>
-      </p:sp>
-      <p:sp>
-        <p:nvSpPr>
-          <p:cNvPr id="9" name=""/>
-          <p:cNvSpPr>
-            <a:spLocks noGrp="1"/>
-          </p:cNvSpPr>
-          <p:nvPr>
-            <p:ph/>
-          </p:nvPr>
-        </p:nvSpPr>
-        <p:spPr>
-          <a:xfrm>
-            <a:off x="6131052" y="1842516"/>
-            <a:ext cx="2827782" cy="228600"/>
-          </a:xfrm>
-          <a:solidFill>
-            <a:srgbClr val="FFFFFF">
-              <a:alpha val="0"/>
-            </a:srgbClr>
-          </a:solidFill>
-        </p:spPr>
-        <p:txBody>
-          <a:bodyPr/>
-          <a:lstStyle/>
-          <a:p>
-            <a:pPr algn="ctr" marL="0" marR="0">
-              <a:lnSpc>
-                <a:spcPct val="100000"/>
-              </a:lnSpc>
-              <a:spcBef>
-                <a:spcPts val="0"/>
-              </a:spcBef>
-              <a:spcAft>
-                <a:spcPts val="0"/>
-              </a:spcAft>
-              <a:buNone/>
-            </a:pPr>
-            <a:r>
-              <a:rPr cap="none" sz="900" i="0" b="1" u="none" strike="noStrike">
-                <a:solidFill>
-                  <a:srgbClr val="D62728">
-                    <a:alpha val="100000"/>
-                  </a:srgbClr>
-                </a:solidFill>
-                <a:latin typeface="Malgun Gothic"/>
-                <a:cs typeface="Malgun Gothic"/>
-                <a:ea typeface="Malgun Gothic"/>
-                <a:sym typeface="Malgun Gothic"/>
-              </a:rPr>
-              <a:t>⬤</a:t>
-            </a:r>
-            <a:r>
-              <a:rPr cap="none" sz="900" i="0" b="0" u="none" strike="noStrike">
-                <a:solidFill>
-                  <a:srgbClr val="333333">
-                    <a:alpha val="100000"/>
-                  </a:srgbClr>
-                </a:solidFill>
-                <a:latin typeface="Malgun Gothic"/>
-                <a:cs typeface="Malgun Gothic"/>
-                <a:ea typeface="Malgun Gothic"/>
-                <a:sym typeface="Malgun Gothic"/>
-              </a:rPr>
-              <a:t> (ML_MSR_139) Peri_BL_139</a:t>
-            </a:r>
-          </a:p>
-        </p:txBody>
-      </p:sp>
-      <p:pic>
-        <p:nvPicPr>
-          <p:cNvPr id="10" name="" descr=""/>
-          <p:cNvPicPr>
-            <a:picLocks noGrp="1"/>
-          </p:cNvPicPr>
-          <p:nvPr>
-            <p:ph/>
-          </p:nvPr>
-        </p:nvPicPr>
-        <p:blipFill>
-          <a:blip r:embed="rId4"/>
-          <a:stretch>
-            <a:fillRect/>
-          </a:stretch>
-        </p:blipFill>
-        <p:spPr>
-          <a:xfrm>
-            <a:off x="6131052" y="2112264"/>
-            <a:ext cx="2827782" cy="1965960"/>
-          </a:xfrm>
-          <a:prstGeom prst="rect">
-            <a:avLst/>
-          </a:prstGeom>
-        </p:spPr>
-      </p:pic>
-      <p:sp>
-        <p:nvSpPr>
-          <p:cNvPr id="11" name=""/>
-          <p:cNvSpPr>
-            <a:spLocks noGrp="1"/>
-          </p:cNvSpPr>
-          <p:nvPr>
-            <p:ph/>
-          </p:nvPr>
-        </p:nvSpPr>
-        <p:spPr>
-          <a:xfrm>
-            <a:off x="8364474" y="2139696"/>
-            <a:ext cx="566928" cy="164592"/>
-          </a:xfrm>
-          <a:solidFill>
-            <a:srgbClr val="FFFFFF">
-              <a:alpha val="0"/>
-            </a:srgbClr>
-          </a:solidFill>
-        </p:spPr>
-        <p:txBody>
-          <a:bodyPr/>
-          <a:lstStyle/>
-          <a:p>
-            <a:pPr algn="r" marL="0" marR="0">
-              <a:lnSpc>
-                <a:spcPct val="100000"/>
-              </a:lnSpc>
-              <a:spcBef>
-                <a:spcPts val="0"/>
-              </a:spcBef>
-              <a:spcAft>
-                <a:spcPts val="0"/>
-              </a:spcAft>
-              <a:buNone/>
-            </a:pPr>
-            <a:r>
-              <a:rPr cap="none" sz="800" i="0" b="0" u="none" strike="noStrike">
-                <a:solidFill>
-                  <a:srgbClr val="808080">
-                    <a:alpha val="100000"/>
-                  </a:srgbClr>
-                </a:solidFill>
-                <a:latin typeface="Malgun Gothic"/>
-                <a:cs typeface="Malgun Gothic"/>
-                <a:ea typeface="Malgun Gothic"/>
-                <a:sym typeface="Malgun Gothic"/>
-              </a:rPr>
-              <a:t>+0.5sig</a:t>
-            </a:r>
-          </a:p>
-        </p:txBody>
-      </p:sp>
-      <p:sp>
-        <p:nvSpPr>
-          <p:cNvPr id="12" name=""/>
-          <p:cNvSpPr>
-            <a:spLocks noGrp="1"/>
-          </p:cNvSpPr>
-          <p:nvPr>
-            <p:ph/>
-          </p:nvPr>
-        </p:nvSpPr>
-        <p:spPr>
-          <a:xfrm>
-            <a:off x="9031986" y="1842516"/>
-            <a:ext cx="2827782" cy="228600"/>
-          </a:xfrm>
-          <a:solidFill>
-            <a:srgbClr val="FFFFFF">
-              <a:alpha val="0"/>
-            </a:srgbClr>
-          </a:solidFill>
-        </p:spPr>
-        <p:txBody>
-          <a:bodyPr/>
-          <a:lstStyle/>
-          <a:p>
-            <a:pPr algn="ctr" marL="0" marR="0">
-              <a:lnSpc>
-                <a:spcPct val="100000"/>
-              </a:lnSpc>
-              <a:spcBef>
-                <a:spcPts val="0"/>
-              </a:spcBef>
-              <a:spcAft>
-                <a:spcPts val="0"/>
-              </a:spcAft>
-              <a:buNone/>
-            </a:pPr>
-            <a:r>
-              <a:rPr cap="none" sz="900" i="0" b="1" u="none" strike="noStrike">
-                <a:solidFill>
-                  <a:srgbClr val="D62728">
-                    <a:alpha val="100000"/>
-                  </a:srgbClr>
-                </a:solidFill>
-                <a:latin typeface="Malgun Gothic"/>
-                <a:cs typeface="Malgun Gothic"/>
-                <a:ea typeface="Malgun Gothic"/>
-                <a:sym typeface="Malgun Gothic"/>
-              </a:rPr>
-              <a:t>⬤</a:t>
-            </a:r>
-            <a:r>
-              <a:rPr cap="none" sz="900" i="0" b="0" u="none" strike="noStrike">
-                <a:solidFill>
-                  <a:srgbClr val="333333">
-                    <a:alpha val="100000"/>
-                  </a:srgbClr>
-                </a:solidFill>
-                <a:latin typeface="Malgun Gothic"/>
-                <a:cs typeface="Malgun Gothic"/>
-                <a:ea typeface="Malgun Gothic"/>
-                <a:sym typeface="Malgun Gothic"/>
-              </a:rPr>
-              <a:t> (ML_MSR_141) Peri_BL_141</a:t>
-            </a:r>
-          </a:p>
-        </p:txBody>
-      </p:sp>
-      <p:pic>
-        <p:nvPicPr>
-          <p:cNvPr id="13" name="" descr=""/>
-          <p:cNvPicPr>
-            <a:picLocks noGrp="1"/>
-          </p:cNvPicPr>
-          <p:nvPr>
-            <p:ph/>
-          </p:nvPr>
-        </p:nvPicPr>
-        <p:blipFill>
-          <a:blip r:embed="rId5"/>
-          <a:stretch>
-            <a:fillRect/>
-          </a:stretch>
-        </p:blipFill>
-        <p:spPr>
-          <a:xfrm>
-            <a:off x="9031986" y="2112264"/>
-            <a:ext cx="2827782" cy="1965960"/>
-          </a:xfrm>
-          <a:prstGeom prst="rect">
-            <a:avLst/>
-          </a:prstGeom>
-        </p:spPr>
-      </p:pic>
-      <p:sp>
-        <p:nvSpPr>
-          <p:cNvPr id="14" name=""/>
-          <p:cNvSpPr>
-            <a:spLocks noGrp="1"/>
-          </p:cNvSpPr>
-          <p:nvPr>
-            <p:ph/>
-          </p:nvPr>
-        </p:nvSpPr>
-        <p:spPr>
-          <a:xfrm>
-            <a:off x="11265408" y="2139696"/>
-            <a:ext cx="566928" cy="164592"/>
-          </a:xfrm>
-          <a:solidFill>
-            <a:srgbClr val="FFFFFF">
-              <a:alpha val="0"/>
-            </a:srgbClr>
-          </a:solidFill>
-        </p:spPr>
-        <p:txBody>
-          <a:bodyPr/>
-          <a:lstStyle/>
-          <a:p>
-            <a:pPr algn="r" marL="0" marR="0">
-              <a:lnSpc>
-                <a:spcPct val="100000"/>
-              </a:lnSpc>
-              <a:spcBef>
-                <a:spcPts val="0"/>
-              </a:spcBef>
-              <a:spcAft>
-                <a:spcPts val="0"/>
-              </a:spcAft>
-              <a:buNone/>
-            </a:pPr>
-            <a:r>
-              <a:rPr cap="none" sz="800" i="0" b="0" u="none" strike="noStrike">
-                <a:solidFill>
-                  <a:srgbClr val="808080">
-                    <a:alpha val="100000"/>
-                  </a:srgbClr>
-                </a:solidFill>
-                <a:latin typeface="Malgun Gothic"/>
-                <a:cs typeface="Malgun Gothic"/>
-                <a:ea typeface="Malgun Gothic"/>
-                <a:sym typeface="Malgun Gothic"/>
-              </a:rPr>
-              <a:t>+0.5sig</a:t>
-            </a:r>
-          </a:p>
-        </p:txBody>
-      </p:sp>
-      <p:sp>
-        <p:nvSpPr>
-          <p:cNvPr id="15" name=""/>
-          <p:cNvSpPr>
-            <a:spLocks noGrp="1"/>
-          </p:cNvSpPr>
-          <p:nvPr>
-            <p:ph/>
-          </p:nvPr>
-        </p:nvSpPr>
-        <p:spPr>
-          <a:xfrm>
-            <a:off x="329184" y="4128516"/>
-            <a:ext cx="2827782" cy="228600"/>
-          </a:xfrm>
-          <a:solidFill>
-            <a:srgbClr val="FFFFFF">
-              <a:alpha val="0"/>
-            </a:srgbClr>
-          </a:solidFill>
-        </p:spPr>
-        <p:txBody>
-          <a:bodyPr/>
-          <a:lstStyle/>
-          <a:p>
-            <a:pPr algn="ctr" marL="0" marR="0">
-              <a:lnSpc>
-                <a:spcPct val="100000"/>
-              </a:lnSpc>
-              <a:spcBef>
-                <a:spcPts val="0"/>
-              </a:spcBef>
-              <a:spcAft>
-                <a:spcPts val="0"/>
-              </a:spcAft>
-              <a:buNone/>
-            </a:pPr>
-            <a:r>
-              <a:rPr cap="none" sz="900" i="0" b="1" u="none" strike="noStrike">
-                <a:solidFill>
-                  <a:srgbClr val="D62728">
-                    <a:alpha val="100000"/>
-                  </a:srgbClr>
-                </a:solidFill>
-                <a:latin typeface="Malgun Gothic"/>
-                <a:cs typeface="Malgun Gothic"/>
-                <a:ea typeface="Malgun Gothic"/>
-                <a:sym typeface="Malgun Gothic"/>
-              </a:rPr>
-              <a:t>⬤</a:t>
-            </a:r>
-            <a:r>
-              <a:rPr cap="none" sz="900" i="0" b="0" u="none" strike="noStrike">
-                <a:solidFill>
-                  <a:srgbClr val="333333">
-                    <a:alpha val="100000"/>
-                  </a:srgbClr>
-                </a:solidFill>
-                <a:latin typeface="Malgun Gothic"/>
-                <a:cs typeface="Malgun Gothic"/>
-                <a:ea typeface="Malgun Gothic"/>
-                <a:sym typeface="Malgun Gothic"/>
-              </a:rPr>
-              <a:t> (ML_MSR_121) Peri_BL_121</a:t>
-            </a:r>
-          </a:p>
-        </p:txBody>
-      </p:sp>
-      <p:pic>
-        <p:nvPicPr>
-          <p:cNvPr id="16" name="" descr=""/>
-          <p:cNvPicPr>
-            <a:picLocks noGrp="1"/>
-          </p:cNvPicPr>
-          <p:nvPr>
-            <p:ph/>
-          </p:nvPr>
-        </p:nvPicPr>
-        <p:blipFill>
-          <a:blip r:embed="rId6"/>
-          <a:stretch>
-            <a:fillRect/>
-          </a:stretch>
-        </p:blipFill>
-        <p:spPr>
-          <a:xfrm>
-            <a:off x="329184" y="4398264"/>
-            <a:ext cx="2827782" cy="1965960"/>
-          </a:xfrm>
-          <a:prstGeom prst="rect">
-            <a:avLst/>
-          </a:prstGeom>
-        </p:spPr>
-      </p:pic>
-      <p:sp>
-        <p:nvSpPr>
-          <p:cNvPr id="17" name=""/>
-          <p:cNvSpPr>
-            <a:spLocks noGrp="1"/>
-          </p:cNvSpPr>
-          <p:nvPr>
-            <p:ph/>
-          </p:nvPr>
-        </p:nvSpPr>
-        <p:spPr>
-          <a:xfrm>
-            <a:off x="2562606" y="4425696"/>
-            <a:ext cx="566928" cy="164592"/>
-          </a:xfrm>
-          <a:solidFill>
-            <a:srgbClr val="FFFFFF">
-              <a:alpha val="0"/>
-            </a:srgbClr>
-          </a:solidFill>
-        </p:spPr>
-        <p:txBody>
-          <a:bodyPr/>
-          <a:lstStyle/>
-          <a:p>
-            <a:pPr algn="r" marL="0" marR="0">
-              <a:lnSpc>
-                <a:spcPct val="100000"/>
-              </a:lnSpc>
-              <a:spcBef>
-                <a:spcPts val="0"/>
-              </a:spcBef>
-              <a:spcAft>
-                <a:spcPts val="0"/>
-              </a:spcAft>
-              <a:buNone/>
-            </a:pPr>
-            <a:r>
-              <a:rPr cap="none" sz="800" i="0" b="0" u="none" strike="noStrike">
-                <a:solidFill>
-                  <a:srgbClr val="808080">
-                    <a:alpha val="100000"/>
-                  </a:srgbClr>
-                </a:solidFill>
-                <a:latin typeface="Malgun Gothic"/>
-                <a:cs typeface="Malgun Gothic"/>
-                <a:ea typeface="Malgun Gothic"/>
-                <a:sym typeface="Malgun Gothic"/>
-              </a:rPr>
-              <a:t>+0.5sig</a:t>
-            </a:r>
-          </a:p>
-        </p:txBody>
-      </p:sp>
-      <p:sp>
-        <p:nvSpPr>
-          <p:cNvPr id="18" name=""/>
-          <p:cNvSpPr>
-            <a:spLocks noGrp="1"/>
-          </p:cNvSpPr>
-          <p:nvPr>
-            <p:ph/>
-          </p:nvPr>
-        </p:nvSpPr>
-        <p:spPr>
-          <a:xfrm>
-            <a:off x="3230118" y="4128516"/>
-            <a:ext cx="2827782" cy="228600"/>
-          </a:xfrm>
-          <a:solidFill>
-            <a:srgbClr val="FFFFFF">
-              <a:alpha val="0"/>
-            </a:srgbClr>
-          </a:solidFill>
-        </p:spPr>
-        <p:txBody>
-          <a:bodyPr/>
-          <a:lstStyle/>
-          <a:p>
-            <a:pPr algn="ctr" marL="0" marR="0">
-              <a:lnSpc>
-                <a:spcPct val="100000"/>
-              </a:lnSpc>
-              <a:spcBef>
-                <a:spcPts val="0"/>
-              </a:spcBef>
-              <a:spcAft>
-                <a:spcPts val="0"/>
-              </a:spcAft>
-              <a:buNone/>
-            </a:pPr>
-            <a:r>
-              <a:rPr cap="none" sz="900" i="0" b="1" u="none" strike="noStrike">
-                <a:solidFill>
-                  <a:srgbClr val="D62728">
-                    <a:alpha val="100000"/>
-                  </a:srgbClr>
-                </a:solidFill>
-                <a:latin typeface="Malgun Gothic"/>
-                <a:cs typeface="Malgun Gothic"/>
-                <a:ea typeface="Malgun Gothic"/>
-                <a:sym typeface="Malgun Gothic"/>
-              </a:rPr>
-              <a:t>⬤</a:t>
-            </a:r>
-            <a:r>
-              <a:rPr cap="none" sz="900" i="0" b="0" u="none" strike="noStrike">
-                <a:solidFill>
-                  <a:srgbClr val="333333">
-                    <a:alpha val="100000"/>
-                  </a:srgbClr>
-                </a:solidFill>
-                <a:latin typeface="Malgun Gothic"/>
-                <a:cs typeface="Malgun Gothic"/>
-                <a:ea typeface="Malgun Gothic"/>
-                <a:sym typeface="Malgun Gothic"/>
-              </a:rPr>
-              <a:t> (ML_MSR_101) Peri_BL_101</a:t>
-            </a:r>
-          </a:p>
-        </p:txBody>
-      </p:sp>
-      <p:pic>
-        <p:nvPicPr>
-          <p:cNvPr id="19" name="" descr=""/>
-          <p:cNvPicPr>
-            <a:picLocks noGrp="1"/>
-          </p:cNvPicPr>
-          <p:nvPr>
-            <p:ph/>
-          </p:nvPr>
-        </p:nvPicPr>
-        <p:blipFill>
-          <a:blip r:embed="rId7"/>
-          <a:stretch>
-            <a:fillRect/>
-          </a:stretch>
-        </p:blipFill>
-        <p:spPr>
-          <a:xfrm>
-            <a:off x="3230118" y="4398264"/>
-            <a:ext cx="2827782" cy="1965960"/>
-          </a:xfrm>
-          <a:prstGeom prst="rect">
-            <a:avLst/>
-          </a:prstGeom>
-        </p:spPr>
-      </p:pic>
-      <p:sp>
-        <p:nvSpPr>
-          <p:cNvPr id="20" name=""/>
-          <p:cNvSpPr>
-            <a:spLocks noGrp="1"/>
-          </p:cNvSpPr>
-          <p:nvPr>
-            <p:ph/>
-          </p:nvPr>
-        </p:nvSpPr>
-        <p:spPr>
-          <a:xfrm>
-            <a:off x="5463540" y="4425696"/>
-            <a:ext cx="566928" cy="164592"/>
-          </a:xfrm>
-          <a:solidFill>
-            <a:srgbClr val="FFFFFF">
-              <a:alpha val="0"/>
-            </a:srgbClr>
-          </a:solidFill>
-        </p:spPr>
-        <p:txBody>
-          <a:bodyPr/>
-          <a:lstStyle/>
-          <a:p>
-            <a:pPr algn="r" marL="0" marR="0">
-              <a:lnSpc>
-                <a:spcPct val="100000"/>
-              </a:lnSpc>
-              <a:spcBef>
-                <a:spcPts val="0"/>
-              </a:spcBef>
-              <a:spcAft>
-                <a:spcPts val="0"/>
-              </a:spcAft>
-              <a:buNone/>
-            </a:pPr>
-            <a:r>
-              <a:rPr cap="none" sz="800" i="0" b="0" u="none" strike="noStrike">
-                <a:solidFill>
-                  <a:srgbClr val="808080">
-                    <a:alpha val="100000"/>
-                  </a:srgbClr>
-                </a:solidFill>
-                <a:latin typeface="Malgun Gothic"/>
-                <a:cs typeface="Malgun Gothic"/>
-                <a:ea typeface="Malgun Gothic"/>
-                <a:sym typeface="Malgun Gothic"/>
-              </a:rPr>
-              <a:t>+0.5sig</a:t>
-            </a:r>
-          </a:p>
-        </p:txBody>
-      </p:sp>
-      <p:sp>
-        <p:nvSpPr>
-          <p:cNvPr id="21" name=""/>
-          <p:cNvSpPr>
-            <a:spLocks noGrp="1"/>
-          </p:cNvSpPr>
-          <p:nvPr>
-            <p:ph/>
-          </p:nvPr>
-        </p:nvSpPr>
-        <p:spPr>
-          <a:xfrm>
             <a:off x="4642866" y="6446520"/>
             <a:ext cx="2903220" cy="219456"/>
           </a:xfrm>
@@ -25247,7 +23914,7 @@
       </p:sp>
       <p:sp>
         <p:nvSpPr>
-          <p:cNvPr id="22" name="DRB_Title_Placeholder"/>
+          <p:cNvPr id="7" name="DRB_Title_Placeholder"/>
           <p:cNvSpPr>
             <a:spLocks noGrp="1"/>
           </p:cNvSpPr>
@@ -25296,7 +23963,7 @@
       </p:sp>
       <p:sp>
         <p:nvSpPr>
-          <p:cNvPr id="23" name="DRB_Body_Placeholder"/>
+          <p:cNvPr id="8" name="DRB_Body_Placeholder"/>
           <p:cNvSpPr>
             <a:spLocks noGrp="1"/>
           </p:cNvSpPr>
@@ -25352,7 +24019,7 @@
                 <a:ea typeface="Malgun Gothic"/>
                 <a:sym typeface="Malgun Gothic"/>
               </a:rPr>
-              <a:t> Category: Category2: BL | Showing MSR 1-6 of 6</a:t>
+              <a:t> Category: Category2: BL | Showing MSR 1-1 of 1</a:t>
             </a:r>
           </a:p>
           <a:p>
@@ -25401,7 +24068,7 @@
       </p:sp>
       <p:sp>
         <p:nvSpPr>
-          <p:cNvPr id="24" name=""/>
+          <p:cNvPr id="9" name=""/>
           <p:cNvSpPr>
             <a:spLocks noGrp="1"/>
           </p:cNvSpPr>
@@ -25530,7 +24197,7 @@
                           <a:ea typeface="Malgun Gothic"/>
                           <a:sym typeface="Malgun Gothic"/>
                         </a:rPr>
-                        <a:t>Category2: WTC - MSR 1-4 of 4</a:t>
+                        <a:t>Category2: WTC - MSR 1-2 of 2</a:t>
                       </a:r>
                     </a:p>
                   </a:txBody>
@@ -27282,302 +25949,6 @@
         </p:nvSpPr>
         <p:spPr>
           <a:xfrm>
-            <a:off x="6131052" y="1842516"/>
-            <a:ext cx="2827782" cy="228600"/>
-          </a:xfrm>
-          <a:solidFill>
-            <a:srgbClr val="FFFFFF">
-              <a:alpha val="0"/>
-            </a:srgbClr>
-          </a:solidFill>
-        </p:spPr>
-        <p:txBody>
-          <a:bodyPr/>
-          <a:lstStyle/>
-          <a:p>
-            <a:pPr algn="ctr" marL="0" marR="0">
-              <a:lnSpc>
-                <a:spcPct val="100000"/>
-              </a:lnSpc>
-              <a:spcBef>
-                <a:spcPts val="0"/>
-              </a:spcBef>
-              <a:spcAft>
-                <a:spcPts val="0"/>
-              </a:spcAft>
-              <a:buNone/>
-            </a:pPr>
-            <a:r>
-              <a:rPr cap="none" sz="900" i="0" b="1" u="none" strike="noStrike">
-                <a:solidFill>
-                  <a:srgbClr val="D62728">
-                    <a:alpha val="100000"/>
-                  </a:srgbClr>
-                </a:solidFill>
-                <a:latin typeface="Malgun Gothic"/>
-                <a:cs typeface="Malgun Gothic"/>
-                <a:ea typeface="Malgun Gothic"/>
-                <a:sym typeface="Malgun Gothic"/>
-              </a:rPr>
-              <a:t>⬤</a:t>
-            </a:r>
-            <a:r>
-              <a:rPr cap="none" sz="900" i="0" b="0" u="none" strike="noStrike">
-                <a:solidFill>
-                  <a:srgbClr val="333333">
-                    <a:alpha val="100000"/>
-                  </a:srgbClr>
-                </a:solidFill>
-                <a:latin typeface="Malgun Gothic"/>
-                <a:cs typeface="Malgun Gothic"/>
-                <a:ea typeface="Malgun Gothic"/>
-                <a:sym typeface="Malgun Gothic"/>
-              </a:rPr>
-              <a:t> (ML_MSR_290) Cell_WTC_290</a:t>
-            </a:r>
-          </a:p>
-        </p:txBody>
-      </p:sp>
-      <p:pic>
-        <p:nvPicPr>
-          <p:cNvPr id="10" name="" descr=""/>
-          <p:cNvPicPr>
-            <a:picLocks noGrp="1"/>
-          </p:cNvPicPr>
-          <p:nvPr>
-            <p:ph/>
-          </p:nvPr>
-        </p:nvPicPr>
-        <p:blipFill>
-          <a:blip r:embed="rId4"/>
-          <a:stretch>
-            <a:fillRect/>
-          </a:stretch>
-        </p:blipFill>
-        <p:spPr>
-          <a:xfrm>
-            <a:off x="6131052" y="2112264"/>
-            <a:ext cx="2827782" cy="1965960"/>
-          </a:xfrm>
-          <a:prstGeom prst="rect">
-            <a:avLst/>
-          </a:prstGeom>
-        </p:spPr>
-      </p:pic>
-      <p:sp>
-        <p:nvSpPr>
-          <p:cNvPr id="11" name=""/>
-          <p:cNvSpPr>
-            <a:spLocks noGrp="1"/>
-          </p:cNvSpPr>
-          <p:nvPr>
-            <p:ph/>
-          </p:nvPr>
-        </p:nvSpPr>
-        <p:spPr>
-          <a:xfrm>
-            <a:off x="8364474" y="2139696"/>
-            <a:ext cx="566928" cy="164592"/>
-          </a:xfrm>
-          <a:solidFill>
-            <a:srgbClr val="FFFFFF">
-              <a:alpha val="0"/>
-            </a:srgbClr>
-          </a:solidFill>
-        </p:spPr>
-        <p:txBody>
-          <a:bodyPr/>
-          <a:lstStyle/>
-          <a:p>
-            <a:pPr algn="r" marL="0" marR="0">
-              <a:lnSpc>
-                <a:spcPct val="100000"/>
-              </a:lnSpc>
-              <a:spcBef>
-                <a:spcPts val="0"/>
-              </a:spcBef>
-              <a:spcAft>
-                <a:spcPts val="0"/>
-              </a:spcAft>
-              <a:buNone/>
-            </a:pPr>
-            <a:r>
-              <a:rPr cap="none" sz="800" i="0" b="0" u="none" strike="noStrike">
-                <a:solidFill>
-                  <a:srgbClr val="808080">
-                    <a:alpha val="100000"/>
-                  </a:srgbClr>
-                </a:solidFill>
-                <a:latin typeface="Malgun Gothic"/>
-                <a:cs typeface="Malgun Gothic"/>
-                <a:ea typeface="Malgun Gothic"/>
-                <a:sym typeface="Malgun Gothic"/>
-              </a:rPr>
-              <a:t>+0.5sig</a:t>
-            </a:r>
-          </a:p>
-        </p:txBody>
-      </p:sp>
-      <p:sp>
-        <p:nvSpPr>
-          <p:cNvPr id="12" name=""/>
-          <p:cNvSpPr>
-            <a:spLocks noGrp="1"/>
-          </p:cNvSpPr>
-          <p:nvPr>
-            <p:ph/>
-          </p:nvPr>
-        </p:nvSpPr>
-        <p:spPr>
-          <a:xfrm>
-            <a:off x="9031986" y="1842516"/>
-            <a:ext cx="2827782" cy="228600"/>
-          </a:xfrm>
-          <a:solidFill>
-            <a:srgbClr val="FFFFFF">
-              <a:alpha val="0"/>
-            </a:srgbClr>
-          </a:solidFill>
-        </p:spPr>
-        <p:txBody>
-          <a:bodyPr/>
-          <a:lstStyle/>
-          <a:p>
-            <a:pPr algn="ctr" marL="0" marR="0">
-              <a:lnSpc>
-                <a:spcPct val="100000"/>
-              </a:lnSpc>
-              <a:spcBef>
-                <a:spcPts val="0"/>
-              </a:spcBef>
-              <a:spcAft>
-                <a:spcPts val="0"/>
-              </a:spcAft>
-              <a:buNone/>
-            </a:pPr>
-            <a:r>
-              <a:rPr cap="none" sz="900" i="0" b="1" u="none" strike="noStrike">
-                <a:solidFill>
-                  <a:srgbClr val="D62728">
-                    <a:alpha val="100000"/>
-                  </a:srgbClr>
-                </a:solidFill>
-                <a:latin typeface="Malgun Gothic"/>
-                <a:cs typeface="Malgun Gothic"/>
-                <a:ea typeface="Malgun Gothic"/>
-                <a:sym typeface="Malgun Gothic"/>
-              </a:rPr>
-              <a:t>⬤</a:t>
-            </a:r>
-            <a:r>
-              <a:rPr cap="none" sz="900" i="0" b="0" u="none" strike="noStrike">
-                <a:solidFill>
-                  <a:srgbClr val="333333">
-                    <a:alpha val="100000"/>
-                  </a:srgbClr>
-                </a:solidFill>
-                <a:latin typeface="Malgun Gothic"/>
-                <a:cs typeface="Malgun Gothic"/>
-                <a:ea typeface="Malgun Gothic"/>
-                <a:sym typeface="Malgun Gothic"/>
-              </a:rPr>
-              <a:t> (ML_MSR_271) Cell_WTC_271</a:t>
-            </a:r>
-          </a:p>
-        </p:txBody>
-      </p:sp>
-      <p:pic>
-        <p:nvPicPr>
-          <p:cNvPr id="13" name="" descr=""/>
-          <p:cNvPicPr>
-            <a:picLocks noGrp="1"/>
-          </p:cNvPicPr>
-          <p:nvPr>
-            <p:ph/>
-          </p:nvPr>
-        </p:nvPicPr>
-        <p:blipFill>
-          <a:blip r:embed="rId5"/>
-          <a:stretch>
-            <a:fillRect/>
-          </a:stretch>
-        </p:blipFill>
-        <p:spPr>
-          <a:xfrm>
-            <a:off x="9031986" y="2112264"/>
-            <a:ext cx="2827782" cy="1965960"/>
-          </a:xfrm>
-          <a:prstGeom prst="rect">
-            <a:avLst/>
-          </a:prstGeom>
-        </p:spPr>
-      </p:pic>
-      <p:sp>
-        <p:nvSpPr>
-          <p:cNvPr id="14" name=""/>
-          <p:cNvSpPr>
-            <a:spLocks noGrp="1"/>
-          </p:cNvSpPr>
-          <p:nvPr>
-            <p:ph/>
-          </p:nvPr>
-        </p:nvSpPr>
-        <p:spPr>
-          <a:xfrm>
-            <a:off x="11265408" y="2139696"/>
-            <a:ext cx="566928" cy="164592"/>
-          </a:xfrm>
-          <a:solidFill>
-            <a:srgbClr val="FFFFFF">
-              <a:alpha val="0"/>
-            </a:srgbClr>
-          </a:solidFill>
-        </p:spPr>
-        <p:txBody>
-          <a:bodyPr/>
-          <a:lstStyle/>
-          <a:p>
-            <a:pPr algn="r" marL="0" marR="0">
-              <a:lnSpc>
-                <a:spcPct val="100000"/>
-              </a:lnSpc>
-              <a:spcBef>
-                <a:spcPts val="0"/>
-              </a:spcBef>
-              <a:spcAft>
-                <a:spcPts val="0"/>
-              </a:spcAft>
-              <a:buNone/>
-            </a:pPr>
-            <a:r>
-              <a:rPr cap="none" sz="800" i="0" b="0" u="none" strike="noStrike">
-                <a:solidFill>
-                  <a:srgbClr val="808080">
-                    <a:alpha val="100000"/>
-                  </a:srgbClr>
-                </a:solidFill>
-                <a:latin typeface="Malgun Gothic"/>
-                <a:cs typeface="Malgun Gothic"/>
-                <a:ea typeface="Malgun Gothic"/>
-                <a:sym typeface="Malgun Gothic"/>
-              </a:rPr>
-              <a:t>+0.5sig</a:t>
-            </a:r>
-          </a:p>
-        </p:txBody>
-      </p:sp>
-      <p:sp>
-        <p:nvSpPr>
-          <p:cNvPr id="15" name=""/>
-          <p:cNvSpPr>
-            <a:spLocks noGrp="1"/>
-          </p:cNvSpPr>
-          <p:nvPr>
-            <p:ph/>
-          </p:nvPr>
-        </p:nvSpPr>
-        <p:spPr>
-          <a:xfrm>
             <a:off x="4642866" y="6446520"/>
             <a:ext cx="2903220" cy="219456"/>
           </a:xfrm>
@@ -27650,7 +26021,7 @@
       </p:sp>
       <p:sp>
         <p:nvSpPr>
-          <p:cNvPr id="16" name="DRB_Title_Placeholder"/>
+          <p:cNvPr id="10" name="DRB_Title_Placeholder"/>
           <p:cNvSpPr>
             <a:spLocks noGrp="1"/>
           </p:cNvSpPr>
@@ -27699,7 +26070,7 @@
       </p:sp>
       <p:sp>
         <p:nvSpPr>
-          <p:cNvPr id="17" name="DRB_Body_Placeholder"/>
+          <p:cNvPr id="11" name="DRB_Body_Placeholder"/>
           <p:cNvSpPr>
             <a:spLocks noGrp="1"/>
           </p:cNvSpPr>
@@ -27755,7 +26126,7 @@
                 <a:ea typeface="Malgun Gothic"/>
                 <a:sym typeface="Malgun Gothic"/>
               </a:rPr>
-              <a:t> Category: Category2: WTC | Showing MSR 1-4 of 4</a:t>
+              <a:t> Category: Category2: WTC | Showing MSR 1-2 of 2</a:t>
             </a:r>
           </a:p>
           <a:p>
@@ -27804,2706 +26175,7 @@
       </p:sp>
       <p:sp>
         <p:nvSpPr>
-          <p:cNvPr id="18" name=""/>
-          <p:cNvSpPr>
-            <a:spLocks noGrp="1"/>
-          </p:cNvSpPr>
-          <p:nvPr>
-            <p:ph/>
-          </p:nvPr>
-        </p:nvSpPr>
-        <p:spPr>
-          <a:xfrm>
-            <a:off x="8268012" y="6451200"/>
-            <a:ext cx="2520000" cy="237600"/>
-          </a:xfrm>
-          <a:solidFill>
-            <a:srgbClr val="FFFFFF">
-              <a:alpha val="0"/>
-            </a:srgbClr>
-          </a:solidFill>
-        </p:spPr>
-        <p:txBody>
-          <a:bodyPr/>
-          <a:lstStyle/>
-          <a:p>
-            <a:pPr algn="r" marL="0" marR="0">
-              <a:lnSpc>
-                <a:spcPct val="100000"/>
-              </a:lnSpc>
-              <a:spcBef>
-                <a:spcPts val="0"/>
-              </a:spcBef>
-              <a:spcAft>
-                <a:spcPts val="0"/>
-              </a:spcAft>
-              <a:buNone/>
-            </a:pPr>
-            <a:r>
-              <a:rPr cap="none" sz="1200" i="0" b="0" u="none" strike="noStrike">
-                <a:solidFill>
-                  <a:srgbClr val="7F7F7F">
-                    <a:alpha val="100000"/>
-                  </a:srgbClr>
-                </a:solidFill>
-                <a:latin typeface="Malgun Gothic"/>
-                <a:cs typeface="Malgun Gothic"/>
-                <a:ea typeface="Malgun Gothic"/>
-                <a:sym typeface="Malgun Gothic"/>
-              </a:rPr>
-              <a:t>Flash PE / 홍길동</a:t>
-            </a:r>
-          </a:p>
-        </p:txBody>
-      </p:sp>
-    </p:spTree>
-  </p:cSld>
-  <p:clrMapOvr>
-    <a:masterClrMapping/>
-  </p:clrMapOvr>
-</p:sld>
-</file>
-
-<file path=ppt/slides/slide7.xml><?xml version="1.0" encoding="utf-8"?>
-<p:sld xmlns:a="http://schemas.openxmlformats.org/drawingml/2006/main" xmlns:r="http://schemas.openxmlformats.org/officeDocument/2006/relationships" xmlns:p="http://schemas.openxmlformats.org/presentationml/2006/main">
-  <p:cSld>
-    <p:spTree>
-      <p:nvGrpSpPr>
-        <p:cNvPr id="1" name=""/>
-        <p:cNvGrpSpPr/>
-        <p:nvPr/>
-      </p:nvGrpSpPr>
-      <p:grpSpPr>
-        <a:xfrm>
-          <a:off x="0" y="0"/>
-          <a:ext cx="0" cy="0"/>
-          <a:chOff x="0" y="0"/>
-          <a:chExt cx="0" cy="0"/>
-        </a:xfrm>
-      </p:grpSpPr>
-      <p:graphicFrame>
-        <p:nvGraphicFramePr>
-          <p:cNvPr id="2" name=""/>
-          <p:cNvGraphicFramePr>
-            <a:graphicFrameLocks noGrp="true"/>
-          </p:cNvGraphicFramePr>
-          <p:nvPr/>
-        </p:nvGraphicFramePr>
-        <p:xfrm rot="0">
-          <a:off x="292608" y="1536192"/>
-          <a:ext cx="11603736" cy="4864608"/>
-        </p:xfrm>
-        <a:graphic>
-          <a:graphicData uri="http://schemas.openxmlformats.org/drawingml/2006/table">
-            <a:tbl>
-              <a:tblPr/>
-              <a:tblGrid>
-                <a:gridCol w="2900934"/>
-                <a:gridCol w="2900934"/>
-                <a:gridCol w="2900934"/>
-                <a:gridCol w="2900934"/>
-              </a:tblGrid>
-              <a:tr h="292608">
-                <a:tc gridSpan="4">
-                  <a:txBody>
-                    <a:bodyPr/>
-                    <a:lstStyle/>
-                    <a:p>
-                      <a:pPr algn="ctr" marL="0" marR="0">
-                        <a:lnSpc>
-                          <a:spcPct val="100000"/>
-                        </a:lnSpc>
-                        <a:spcBef>
-                          <a:spcPts val="0"/>
-                        </a:spcBef>
-                        <a:spcAft>
-                          <a:spcPts val="0"/>
-                        </a:spcAft>
-                        <a:buNone/>
-                      </a:pPr>
-                      <a:r>
-                        <a:rPr cap="none" sz="1000" i="0" b="1" u="none" strike="noStrike">
-                          <a:solidFill>
-                            <a:srgbClr val="333333">
-                              <a:alpha val="100000"/>
-                            </a:srgbClr>
-                          </a:solidFill>
-                          <a:latin typeface="Malgun Gothic"/>
-                          <a:cs typeface="Malgun Gothic"/>
-                          <a:ea typeface="Malgun Gothic"/>
-                          <a:sym typeface="Malgun Gothic"/>
-                        </a:rPr>
-                        <a:t>Category2: TCMC - MSR 1-6 of 6</a:t>
-                      </a:r>
-                    </a:p>
-                  </a:txBody>
-                  <a:tcPr anchor="ctr" marB="0" marT="0" marR="0" marL="0">
-                    <a:lnL algn="ctr" cmpd="sng" cap="flat" w="6350">
-                      <a:solidFill>
-                        <a:srgbClr val="D9D9D9">
-                          <a:alpha val="100000"/>
-                        </a:srgbClr>
-                      </a:solidFill>
-                      <a:prstDash val="solid"/>
-                    </a:lnL>
-                    <a:lnR algn="ctr" cmpd="sng" cap="flat" w="6350">
-                      <a:solidFill>
-                        <a:srgbClr val="D9D9D9">
-                          <a:alpha val="100000"/>
-                        </a:srgbClr>
-                      </a:solidFill>
-                      <a:prstDash val="solid"/>
-                    </a:lnR>
-                    <a:lnT algn="ctr" cmpd="sng" cap="flat" w="6350">
-                      <a:solidFill>
-                        <a:srgbClr val="D9D9D9">
-                          <a:alpha val="100000"/>
-                        </a:srgbClr>
-                      </a:solidFill>
-                      <a:prstDash val="solid"/>
-                    </a:lnT>
-                    <a:lnB algn="ctr" cmpd="sng" cap="flat" w="6350">
-                      <a:solidFill>
-                        <a:srgbClr val="D9D9D9">
-                          <a:alpha val="100000"/>
-                        </a:srgbClr>
-                      </a:solidFill>
-                      <a:prstDash val="solid"/>
-                    </a:lnB>
-                    <a:solidFill>
-                      <a:srgbClr val="E0E0E0">
-                        <a:alpha val="100000"/>
-                      </a:srgbClr>
-                    </a:solidFill>
-                  </a:tcPr>
-                </a:tc>
-                <a:tc hMerge="true">
-                  <a:txBody>
-                    <a:bodyPr/>
-                    <a:lstStyle/>
-                    <a:p>
-                      <a:pPr algn="ctr" marL="0" marR="0">
-                        <a:lnSpc>
-                          <a:spcPct val="100000"/>
-                        </a:lnSpc>
-                        <a:spcBef>
-                          <a:spcPts val="0"/>
-                        </a:spcBef>
-                        <a:spcAft>
-                          <a:spcPts val="0"/>
-                        </a:spcAft>
-                        <a:buNone/>
-                      </a:pPr>
-                      <a:r>
-                        <a:rPr cap="none" sz="1000" i="0" b="1" u="none" strike="noStrike">
-                          <a:solidFill>
-                            <a:srgbClr val="333333">
-                              <a:alpha val="100000"/>
-                            </a:srgbClr>
-                          </a:solidFill>
-                          <a:latin typeface="Malgun Gothic"/>
-                          <a:cs typeface="Malgun Gothic"/>
-                          <a:ea typeface="Malgun Gothic"/>
-                          <a:sym typeface="Malgun Gothic"/>
-                        </a:rPr>
-                        <a:t> </a:t>
-                      </a:r>
-                    </a:p>
-                  </a:txBody>
-                  <a:tcPr anchor="ctr" marB="0" marT="0" marR="0" marL="0">
-                    <a:lnL algn="ctr" cmpd="sng" cap="flat" w="6350">
-                      <a:solidFill>
-                        <a:srgbClr val="D9D9D9">
-                          <a:alpha val="100000"/>
-                        </a:srgbClr>
-                      </a:solidFill>
-                      <a:prstDash val="solid"/>
-                    </a:lnL>
-                    <a:lnR algn="ctr" cmpd="sng" cap="flat" w="6350">
-                      <a:solidFill>
-                        <a:srgbClr val="D9D9D9">
-                          <a:alpha val="100000"/>
-                        </a:srgbClr>
-                      </a:solidFill>
-                      <a:prstDash val="solid"/>
-                    </a:lnR>
-                    <a:lnT algn="ctr" cmpd="sng" cap="flat" w="6350">
-                      <a:solidFill>
-                        <a:srgbClr val="D9D9D9">
-                          <a:alpha val="100000"/>
-                        </a:srgbClr>
-                      </a:solidFill>
-                      <a:prstDash val="solid"/>
-                    </a:lnT>
-                    <a:lnB algn="ctr" cmpd="sng" cap="flat" w="6350">
-                      <a:solidFill>
-                        <a:srgbClr val="D9D9D9">
-                          <a:alpha val="100000"/>
-                        </a:srgbClr>
-                      </a:solidFill>
-                      <a:prstDash val="solid"/>
-                    </a:lnB>
-                    <a:solidFill>
-                      <a:srgbClr val="E0E0E0">
-                        <a:alpha val="100000"/>
-                      </a:srgbClr>
-                    </a:solidFill>
-                  </a:tcPr>
-                </a:tc>
-                <a:tc hMerge="true">
-                  <a:txBody>
-                    <a:bodyPr/>
-                    <a:lstStyle/>
-                    <a:p>
-                      <a:pPr algn="ctr" marL="0" marR="0">
-                        <a:lnSpc>
-                          <a:spcPct val="100000"/>
-                        </a:lnSpc>
-                        <a:spcBef>
-                          <a:spcPts val="0"/>
-                        </a:spcBef>
-                        <a:spcAft>
-                          <a:spcPts val="0"/>
-                        </a:spcAft>
-                        <a:buNone/>
-                      </a:pPr>
-                      <a:r>
-                        <a:rPr cap="none" sz="1000" i="0" b="1" u="none" strike="noStrike">
-                          <a:solidFill>
-                            <a:srgbClr val="333333">
-                              <a:alpha val="100000"/>
-                            </a:srgbClr>
-                          </a:solidFill>
-                          <a:latin typeface="Malgun Gothic"/>
-                          <a:cs typeface="Malgun Gothic"/>
-                          <a:ea typeface="Malgun Gothic"/>
-                          <a:sym typeface="Malgun Gothic"/>
-                        </a:rPr>
-                        <a:t> </a:t>
-                      </a:r>
-                    </a:p>
-                  </a:txBody>
-                  <a:tcPr anchor="ctr" marB="0" marT="0" marR="0" marL="0">
-                    <a:lnL algn="ctr" cmpd="sng" cap="flat" w="6350">
-                      <a:solidFill>
-                        <a:srgbClr val="D9D9D9">
-                          <a:alpha val="100000"/>
-                        </a:srgbClr>
-                      </a:solidFill>
-                      <a:prstDash val="solid"/>
-                    </a:lnL>
-                    <a:lnR algn="ctr" cmpd="sng" cap="flat" w="6350">
-                      <a:solidFill>
-                        <a:srgbClr val="D9D9D9">
-                          <a:alpha val="100000"/>
-                        </a:srgbClr>
-                      </a:solidFill>
-                      <a:prstDash val="solid"/>
-                    </a:lnR>
-                    <a:lnT algn="ctr" cmpd="sng" cap="flat" w="6350">
-                      <a:solidFill>
-                        <a:srgbClr val="D9D9D9">
-                          <a:alpha val="100000"/>
-                        </a:srgbClr>
-                      </a:solidFill>
-                      <a:prstDash val="solid"/>
-                    </a:lnT>
-                    <a:lnB algn="ctr" cmpd="sng" cap="flat" w="6350">
-                      <a:solidFill>
-                        <a:srgbClr val="D9D9D9">
-                          <a:alpha val="100000"/>
-                        </a:srgbClr>
-                      </a:solidFill>
-                      <a:prstDash val="solid"/>
-                    </a:lnB>
-                    <a:solidFill>
-                      <a:srgbClr val="E0E0E0">
-                        <a:alpha val="100000"/>
-                      </a:srgbClr>
-                    </a:solidFill>
-                  </a:tcPr>
-                </a:tc>
-                <a:tc hMerge="true">
-                  <a:txBody>
-                    <a:bodyPr/>
-                    <a:lstStyle/>
-                    <a:p>
-                      <a:pPr algn="ctr" marL="0" marR="0">
-                        <a:lnSpc>
-                          <a:spcPct val="100000"/>
-                        </a:lnSpc>
-                        <a:spcBef>
-                          <a:spcPts val="0"/>
-                        </a:spcBef>
-                        <a:spcAft>
-                          <a:spcPts val="0"/>
-                        </a:spcAft>
-                        <a:buNone/>
-                      </a:pPr>
-                      <a:r>
-                        <a:rPr cap="none" sz="1000" i="0" b="1" u="none" strike="noStrike">
-                          <a:solidFill>
-                            <a:srgbClr val="333333">
-                              <a:alpha val="100000"/>
-                            </a:srgbClr>
-                          </a:solidFill>
-                          <a:latin typeface="Malgun Gothic"/>
-                          <a:cs typeface="Malgun Gothic"/>
-                          <a:ea typeface="Malgun Gothic"/>
-                          <a:sym typeface="Malgun Gothic"/>
-                        </a:rPr>
-                        <a:t> </a:t>
-                      </a:r>
-                    </a:p>
-                  </a:txBody>
-                  <a:tcPr anchor="ctr" marB="0" marT="0" marR="0" marL="0">
-                    <a:lnL algn="ctr" cmpd="sng" cap="flat" w="6350">
-                      <a:solidFill>
-                        <a:srgbClr val="D9D9D9">
-                          <a:alpha val="100000"/>
-                        </a:srgbClr>
-                      </a:solidFill>
-                      <a:prstDash val="solid"/>
-                    </a:lnL>
-                    <a:lnR algn="ctr" cmpd="sng" cap="flat" w="6350">
-                      <a:solidFill>
-                        <a:srgbClr val="D9D9D9">
-                          <a:alpha val="100000"/>
-                        </a:srgbClr>
-                      </a:solidFill>
-                      <a:prstDash val="solid"/>
-                    </a:lnR>
-                    <a:lnT algn="ctr" cmpd="sng" cap="flat" w="6350">
-                      <a:solidFill>
-                        <a:srgbClr val="D9D9D9">
-                          <a:alpha val="100000"/>
-                        </a:srgbClr>
-                      </a:solidFill>
-                      <a:prstDash val="solid"/>
-                    </a:lnT>
-                    <a:lnB algn="ctr" cmpd="sng" cap="flat" w="6350">
-                      <a:solidFill>
-                        <a:srgbClr val="D9D9D9">
-                          <a:alpha val="100000"/>
-                        </a:srgbClr>
-                      </a:solidFill>
-                      <a:prstDash val="solid"/>
-                    </a:lnB>
-                    <a:solidFill>
-                      <a:srgbClr val="E0E0E0">
-                        <a:alpha val="100000"/>
-                      </a:srgbClr>
-                    </a:solidFill>
-                  </a:tcPr>
-                </a:tc>
-              </a:tr>
-              <a:tr h="256032">
-                <a:tc>
-                  <a:txBody>
-                    <a:bodyPr/>
-                    <a:lstStyle/>
-                    <a:p>
-                      <a:pPr algn="ctr" marL="0" marR="0">
-                        <a:lnSpc>
-                          <a:spcPct val="100000"/>
-                        </a:lnSpc>
-                        <a:spcBef>
-                          <a:spcPts val="0"/>
-                        </a:spcBef>
-                        <a:spcAft>
-                          <a:spcPts val="0"/>
-                        </a:spcAft>
-                        <a:buNone/>
-                      </a:pPr>
-                      <a:r>
-                        <a:rPr cap="none" sz="800" i="0" b="0" u="none" strike="noStrike">
-                          <a:solidFill>
-                            <a:srgbClr val="000000">
-                              <a:alpha val="100000"/>
-                            </a:srgbClr>
-                          </a:solidFill>
-                          <a:latin typeface="Malgun Gothic"/>
-                          <a:cs typeface="Malgun Gothic"/>
-                          <a:ea typeface="Malgun Gothic"/>
-                          <a:sym typeface="Malgun Gothic"/>
-                        </a:rPr>
-                        <a:t> </a:t>
-                      </a:r>
-                    </a:p>
-                  </a:txBody>
-                  <a:tcPr anchor="ctr" marB="0" marT="0" marR="0" marL="0">
-                    <a:lnL algn="ctr" cmpd="sng" cap="flat" w="6350">
-                      <a:solidFill>
-                        <a:srgbClr val="D9D9D9">
-                          <a:alpha val="100000"/>
-                        </a:srgbClr>
-                      </a:solidFill>
-                      <a:prstDash val="solid"/>
-                    </a:lnL>
-                    <a:lnR algn="ctr" cmpd="sng" cap="flat" w="6350">
-                      <a:solidFill>
-                        <a:srgbClr val="D9D9D9">
-                          <a:alpha val="100000"/>
-                        </a:srgbClr>
-                      </a:solidFill>
-                      <a:prstDash val="solid"/>
-                    </a:lnR>
-                    <a:lnT algn="ctr" cmpd="sng" cap="flat" w="6350">
-                      <a:solidFill>
-                        <a:srgbClr val="D9D9D9">
-                          <a:alpha val="100000"/>
-                        </a:srgbClr>
-                      </a:solidFill>
-                      <a:prstDash val="solid"/>
-                    </a:lnT>
-                    <a:lnB algn="ctr" cmpd="sng" cap="flat" w="6350">
-                      <a:solidFill>
-                        <a:srgbClr val="D9D9D9">
-                          <a:alpha val="100000"/>
-                        </a:srgbClr>
-                      </a:solidFill>
-                      <a:prstDash val="solid"/>
-                    </a:lnB>
-                    <a:solidFill>
-                      <a:srgbClr val="F2F2F2">
-                        <a:alpha val="100000"/>
-                      </a:srgbClr>
-                    </a:solidFill>
-                  </a:tcPr>
-                </a:tc>
-                <a:tc>
-                  <a:txBody>
-                    <a:bodyPr/>
-                    <a:lstStyle/>
-                    <a:p>
-                      <a:pPr algn="ctr" marL="0" marR="0">
-                        <a:lnSpc>
-                          <a:spcPct val="100000"/>
-                        </a:lnSpc>
-                        <a:spcBef>
-                          <a:spcPts val="0"/>
-                        </a:spcBef>
-                        <a:spcAft>
-                          <a:spcPts val="0"/>
-                        </a:spcAft>
-                        <a:buNone/>
-                      </a:pPr>
-                      <a:r>
-                        <a:rPr cap="none" sz="800" i="0" b="0" u="none" strike="noStrike">
-                          <a:solidFill>
-                            <a:srgbClr val="000000">
-                              <a:alpha val="100000"/>
-                            </a:srgbClr>
-                          </a:solidFill>
-                          <a:latin typeface="Malgun Gothic"/>
-                          <a:cs typeface="Malgun Gothic"/>
-                          <a:ea typeface="Malgun Gothic"/>
-                          <a:sym typeface="Malgun Gothic"/>
-                        </a:rPr>
-                        <a:t> </a:t>
-                      </a:r>
-                    </a:p>
-                  </a:txBody>
-                  <a:tcPr anchor="ctr" marB="0" marT="0" marR="0" marL="0">
-                    <a:lnL algn="ctr" cmpd="sng" cap="flat" w="6350">
-                      <a:solidFill>
-                        <a:srgbClr val="D9D9D9">
-                          <a:alpha val="100000"/>
-                        </a:srgbClr>
-                      </a:solidFill>
-                      <a:prstDash val="solid"/>
-                    </a:lnL>
-                    <a:lnR algn="ctr" cmpd="sng" cap="flat" w="6350">
-                      <a:solidFill>
-                        <a:srgbClr val="D9D9D9">
-                          <a:alpha val="100000"/>
-                        </a:srgbClr>
-                      </a:solidFill>
-                      <a:prstDash val="solid"/>
-                    </a:lnR>
-                    <a:lnT algn="ctr" cmpd="sng" cap="flat" w="6350">
-                      <a:solidFill>
-                        <a:srgbClr val="D9D9D9">
-                          <a:alpha val="100000"/>
-                        </a:srgbClr>
-                      </a:solidFill>
-                      <a:prstDash val="solid"/>
-                    </a:lnT>
-                    <a:lnB algn="ctr" cmpd="sng" cap="flat" w="6350">
-                      <a:solidFill>
-                        <a:srgbClr val="D9D9D9">
-                          <a:alpha val="100000"/>
-                        </a:srgbClr>
-                      </a:solidFill>
-                      <a:prstDash val="solid"/>
-                    </a:lnB>
-                    <a:solidFill>
-                      <a:srgbClr val="F2F2F2">
-                        <a:alpha val="100000"/>
-                      </a:srgbClr>
-                    </a:solidFill>
-                  </a:tcPr>
-                </a:tc>
-                <a:tc>
-                  <a:txBody>
-                    <a:bodyPr/>
-                    <a:lstStyle/>
-                    <a:p>
-                      <a:pPr algn="ctr" marL="0" marR="0">
-                        <a:lnSpc>
-                          <a:spcPct val="100000"/>
-                        </a:lnSpc>
-                        <a:spcBef>
-                          <a:spcPts val="0"/>
-                        </a:spcBef>
-                        <a:spcAft>
-                          <a:spcPts val="0"/>
-                        </a:spcAft>
-                        <a:buNone/>
-                      </a:pPr>
-                      <a:r>
-                        <a:rPr cap="none" sz="800" i="0" b="0" u="none" strike="noStrike">
-                          <a:solidFill>
-                            <a:srgbClr val="000000">
-                              <a:alpha val="100000"/>
-                            </a:srgbClr>
-                          </a:solidFill>
-                          <a:latin typeface="Malgun Gothic"/>
-                          <a:cs typeface="Malgun Gothic"/>
-                          <a:ea typeface="Malgun Gothic"/>
-                          <a:sym typeface="Malgun Gothic"/>
-                        </a:rPr>
-                        <a:t> </a:t>
-                      </a:r>
-                    </a:p>
-                  </a:txBody>
-                  <a:tcPr anchor="ctr" marB="0" marT="0" marR="0" marL="0">
-                    <a:lnL algn="ctr" cmpd="sng" cap="flat" w="6350">
-                      <a:solidFill>
-                        <a:srgbClr val="D9D9D9">
-                          <a:alpha val="100000"/>
-                        </a:srgbClr>
-                      </a:solidFill>
-                      <a:prstDash val="solid"/>
-                    </a:lnL>
-                    <a:lnR algn="ctr" cmpd="sng" cap="flat" w="6350">
-                      <a:solidFill>
-                        <a:srgbClr val="D9D9D9">
-                          <a:alpha val="100000"/>
-                        </a:srgbClr>
-                      </a:solidFill>
-                      <a:prstDash val="solid"/>
-                    </a:lnR>
-                    <a:lnT algn="ctr" cmpd="sng" cap="flat" w="6350">
-                      <a:solidFill>
-                        <a:srgbClr val="D9D9D9">
-                          <a:alpha val="100000"/>
-                        </a:srgbClr>
-                      </a:solidFill>
-                      <a:prstDash val="solid"/>
-                    </a:lnT>
-                    <a:lnB algn="ctr" cmpd="sng" cap="flat" w="6350">
-                      <a:solidFill>
-                        <a:srgbClr val="D9D9D9">
-                          <a:alpha val="100000"/>
-                        </a:srgbClr>
-                      </a:solidFill>
-                      <a:prstDash val="solid"/>
-                    </a:lnB>
-                    <a:solidFill>
-                      <a:srgbClr val="F2F2F2">
-                        <a:alpha val="100000"/>
-                      </a:srgbClr>
-                    </a:solidFill>
-                  </a:tcPr>
-                </a:tc>
-                <a:tc>
-                  <a:txBody>
-                    <a:bodyPr/>
-                    <a:lstStyle/>
-                    <a:p>
-                      <a:pPr algn="ctr" marL="0" marR="0">
-                        <a:lnSpc>
-                          <a:spcPct val="100000"/>
-                        </a:lnSpc>
-                        <a:spcBef>
-                          <a:spcPts val="0"/>
-                        </a:spcBef>
-                        <a:spcAft>
-                          <a:spcPts val="0"/>
-                        </a:spcAft>
-                        <a:buNone/>
-                      </a:pPr>
-                      <a:r>
-                        <a:rPr cap="none" sz="800" i="0" b="0" u="none" strike="noStrike">
-                          <a:solidFill>
-                            <a:srgbClr val="000000">
-                              <a:alpha val="100000"/>
-                            </a:srgbClr>
-                          </a:solidFill>
-                          <a:latin typeface="Malgun Gothic"/>
-                          <a:cs typeface="Malgun Gothic"/>
-                          <a:ea typeface="Malgun Gothic"/>
-                          <a:sym typeface="Malgun Gothic"/>
-                        </a:rPr>
-                        <a:t> </a:t>
-                      </a:r>
-                    </a:p>
-                  </a:txBody>
-                  <a:tcPr anchor="ctr" marB="0" marT="0" marR="0" marL="0">
-                    <a:lnL algn="ctr" cmpd="sng" cap="flat" w="6350">
-                      <a:solidFill>
-                        <a:srgbClr val="D9D9D9">
-                          <a:alpha val="100000"/>
-                        </a:srgbClr>
-                      </a:solidFill>
-                      <a:prstDash val="solid"/>
-                    </a:lnL>
-                    <a:lnR algn="ctr" cmpd="sng" cap="flat" w="6350">
-                      <a:solidFill>
-                        <a:srgbClr val="D9D9D9">
-                          <a:alpha val="100000"/>
-                        </a:srgbClr>
-                      </a:solidFill>
-                      <a:prstDash val="solid"/>
-                    </a:lnR>
-                    <a:lnT algn="ctr" cmpd="sng" cap="flat" w="6350">
-                      <a:solidFill>
-                        <a:srgbClr val="D9D9D9">
-                          <a:alpha val="100000"/>
-                        </a:srgbClr>
-                      </a:solidFill>
-                      <a:prstDash val="solid"/>
-                    </a:lnT>
-                    <a:lnB algn="ctr" cmpd="sng" cap="flat" w="6350">
-                      <a:solidFill>
-                        <a:srgbClr val="D9D9D9">
-                          <a:alpha val="100000"/>
-                        </a:srgbClr>
-                      </a:solidFill>
-                      <a:prstDash val="solid"/>
-                    </a:lnB>
-                    <a:solidFill>
-                      <a:srgbClr val="F2F2F2">
-                        <a:alpha val="100000"/>
-                      </a:srgbClr>
-                    </a:solidFill>
-                  </a:tcPr>
-                </a:tc>
-              </a:tr>
-              <a:tr h="2029968">
-                <a:tc>
-                  <a:txBody>
-                    <a:bodyPr/>
-                    <a:lstStyle/>
-                    <a:p>
-                      <a:pPr algn="ctr" marL="0" marR="0">
-                        <a:lnSpc>
-                          <a:spcPct val="100000"/>
-                        </a:lnSpc>
-                        <a:spcBef>
-                          <a:spcPts val="0"/>
-                        </a:spcBef>
-                        <a:spcAft>
-                          <a:spcPts val="0"/>
-                        </a:spcAft>
-                        <a:buNone/>
-                      </a:pPr>
-                      <a:r>
-                        <a:rPr cap="none" sz="800" i="0" b="0" u="none" strike="noStrike">
-                          <a:solidFill>
-                            <a:srgbClr val="000000">
-                              <a:alpha val="100000"/>
-                            </a:srgbClr>
-                          </a:solidFill>
-                          <a:latin typeface="Malgun Gothic"/>
-                          <a:cs typeface="Malgun Gothic"/>
-                          <a:ea typeface="Malgun Gothic"/>
-                          <a:sym typeface="Malgun Gothic"/>
-                        </a:rPr>
-                        <a:t> </a:t>
-                      </a:r>
-                    </a:p>
-                  </a:txBody>
-                  <a:tcPr anchor="ctr" marB="0" marT="0" marR="0" marL="0">
-                    <a:lnL algn="ctr" cmpd="sng" cap="flat" w="6350">
-                      <a:solidFill>
-                        <a:srgbClr val="D9D9D9">
-                          <a:alpha val="100000"/>
-                        </a:srgbClr>
-                      </a:solidFill>
-                      <a:prstDash val="solid"/>
-                    </a:lnL>
-                    <a:lnR algn="ctr" cmpd="sng" cap="flat" w="6350">
-                      <a:solidFill>
-                        <a:srgbClr val="D9D9D9">
-                          <a:alpha val="100000"/>
-                        </a:srgbClr>
-                      </a:solidFill>
-                      <a:prstDash val="solid"/>
-                    </a:lnR>
-                    <a:lnT algn="ctr" cmpd="sng" cap="flat" w="6350">
-                      <a:solidFill>
-                        <a:srgbClr val="D9D9D9">
-                          <a:alpha val="100000"/>
-                        </a:srgbClr>
-                      </a:solidFill>
-                      <a:prstDash val="solid"/>
-                    </a:lnT>
-                    <a:lnB algn="ctr" cmpd="sng" cap="flat" w="6350">
-                      <a:solidFill>
-                        <a:srgbClr val="D9D9D9">
-                          <a:alpha val="100000"/>
-                        </a:srgbClr>
-                      </a:solidFill>
-                      <a:prstDash val="solid"/>
-                    </a:lnB>
-                    <a:solidFill>
-                      <a:srgbClr val="FFFFFF">
-                        <a:alpha val="0"/>
-                      </a:srgbClr>
-                    </a:solidFill>
-                  </a:tcPr>
-                </a:tc>
-                <a:tc>
-                  <a:txBody>
-                    <a:bodyPr/>
-                    <a:lstStyle/>
-                    <a:p>
-                      <a:pPr algn="ctr" marL="0" marR="0">
-                        <a:lnSpc>
-                          <a:spcPct val="100000"/>
-                        </a:lnSpc>
-                        <a:spcBef>
-                          <a:spcPts val="0"/>
-                        </a:spcBef>
-                        <a:spcAft>
-                          <a:spcPts val="0"/>
-                        </a:spcAft>
-                        <a:buNone/>
-                      </a:pPr>
-                      <a:r>
-                        <a:rPr cap="none" sz="800" i="0" b="0" u="none" strike="noStrike">
-                          <a:solidFill>
-                            <a:srgbClr val="000000">
-                              <a:alpha val="100000"/>
-                            </a:srgbClr>
-                          </a:solidFill>
-                          <a:latin typeface="Malgun Gothic"/>
-                          <a:cs typeface="Malgun Gothic"/>
-                          <a:ea typeface="Malgun Gothic"/>
-                          <a:sym typeface="Malgun Gothic"/>
-                        </a:rPr>
-                        <a:t> </a:t>
-                      </a:r>
-                    </a:p>
-                  </a:txBody>
-                  <a:tcPr anchor="ctr" marB="0" marT="0" marR="0" marL="0">
-                    <a:lnL algn="ctr" cmpd="sng" cap="flat" w="6350">
-                      <a:solidFill>
-                        <a:srgbClr val="D9D9D9">
-                          <a:alpha val="100000"/>
-                        </a:srgbClr>
-                      </a:solidFill>
-                      <a:prstDash val="solid"/>
-                    </a:lnL>
-                    <a:lnR algn="ctr" cmpd="sng" cap="flat" w="6350">
-                      <a:solidFill>
-                        <a:srgbClr val="D9D9D9">
-                          <a:alpha val="100000"/>
-                        </a:srgbClr>
-                      </a:solidFill>
-                      <a:prstDash val="solid"/>
-                    </a:lnR>
-                    <a:lnT algn="ctr" cmpd="sng" cap="flat" w="6350">
-                      <a:solidFill>
-                        <a:srgbClr val="D9D9D9">
-                          <a:alpha val="100000"/>
-                        </a:srgbClr>
-                      </a:solidFill>
-                      <a:prstDash val="solid"/>
-                    </a:lnT>
-                    <a:lnB algn="ctr" cmpd="sng" cap="flat" w="6350">
-                      <a:solidFill>
-                        <a:srgbClr val="D9D9D9">
-                          <a:alpha val="100000"/>
-                        </a:srgbClr>
-                      </a:solidFill>
-                      <a:prstDash val="solid"/>
-                    </a:lnB>
-                    <a:solidFill>
-                      <a:srgbClr val="FFFFFF">
-                        <a:alpha val="0"/>
-                      </a:srgbClr>
-                    </a:solidFill>
-                  </a:tcPr>
-                </a:tc>
-                <a:tc>
-                  <a:txBody>
-                    <a:bodyPr/>
-                    <a:lstStyle/>
-                    <a:p>
-                      <a:pPr algn="ctr" marL="0" marR="0">
-                        <a:lnSpc>
-                          <a:spcPct val="100000"/>
-                        </a:lnSpc>
-                        <a:spcBef>
-                          <a:spcPts val="0"/>
-                        </a:spcBef>
-                        <a:spcAft>
-                          <a:spcPts val="0"/>
-                        </a:spcAft>
-                        <a:buNone/>
-                      </a:pPr>
-                      <a:r>
-                        <a:rPr cap="none" sz="800" i="0" b="0" u="none" strike="noStrike">
-                          <a:solidFill>
-                            <a:srgbClr val="000000">
-                              <a:alpha val="100000"/>
-                            </a:srgbClr>
-                          </a:solidFill>
-                          <a:latin typeface="Malgun Gothic"/>
-                          <a:cs typeface="Malgun Gothic"/>
-                          <a:ea typeface="Malgun Gothic"/>
-                          <a:sym typeface="Malgun Gothic"/>
-                        </a:rPr>
-                        <a:t> </a:t>
-                      </a:r>
-                    </a:p>
-                  </a:txBody>
-                  <a:tcPr anchor="ctr" marB="0" marT="0" marR="0" marL="0">
-                    <a:lnL algn="ctr" cmpd="sng" cap="flat" w="6350">
-                      <a:solidFill>
-                        <a:srgbClr val="D9D9D9">
-                          <a:alpha val="100000"/>
-                        </a:srgbClr>
-                      </a:solidFill>
-                      <a:prstDash val="solid"/>
-                    </a:lnL>
-                    <a:lnR algn="ctr" cmpd="sng" cap="flat" w="6350">
-                      <a:solidFill>
-                        <a:srgbClr val="D9D9D9">
-                          <a:alpha val="100000"/>
-                        </a:srgbClr>
-                      </a:solidFill>
-                      <a:prstDash val="solid"/>
-                    </a:lnR>
-                    <a:lnT algn="ctr" cmpd="sng" cap="flat" w="6350">
-                      <a:solidFill>
-                        <a:srgbClr val="D9D9D9">
-                          <a:alpha val="100000"/>
-                        </a:srgbClr>
-                      </a:solidFill>
-                      <a:prstDash val="solid"/>
-                    </a:lnT>
-                    <a:lnB algn="ctr" cmpd="sng" cap="flat" w="6350">
-                      <a:solidFill>
-                        <a:srgbClr val="D9D9D9">
-                          <a:alpha val="100000"/>
-                        </a:srgbClr>
-                      </a:solidFill>
-                      <a:prstDash val="solid"/>
-                    </a:lnB>
-                    <a:solidFill>
-                      <a:srgbClr val="FFFFFF">
-                        <a:alpha val="0"/>
-                      </a:srgbClr>
-                    </a:solidFill>
-                  </a:tcPr>
-                </a:tc>
-                <a:tc>
-                  <a:txBody>
-                    <a:bodyPr/>
-                    <a:lstStyle/>
-                    <a:p>
-                      <a:pPr algn="ctr" marL="0" marR="0">
-                        <a:lnSpc>
-                          <a:spcPct val="100000"/>
-                        </a:lnSpc>
-                        <a:spcBef>
-                          <a:spcPts val="0"/>
-                        </a:spcBef>
-                        <a:spcAft>
-                          <a:spcPts val="0"/>
-                        </a:spcAft>
-                        <a:buNone/>
-                      </a:pPr>
-                      <a:r>
-                        <a:rPr cap="none" sz="800" i="0" b="0" u="none" strike="noStrike">
-                          <a:solidFill>
-                            <a:srgbClr val="000000">
-                              <a:alpha val="100000"/>
-                            </a:srgbClr>
-                          </a:solidFill>
-                          <a:latin typeface="Malgun Gothic"/>
-                          <a:cs typeface="Malgun Gothic"/>
-                          <a:ea typeface="Malgun Gothic"/>
-                          <a:sym typeface="Malgun Gothic"/>
-                        </a:rPr>
-                        <a:t> </a:t>
-                      </a:r>
-                    </a:p>
-                  </a:txBody>
-                  <a:tcPr anchor="ctr" marB="0" marT="0" marR="0" marL="0">
-                    <a:lnL algn="ctr" cmpd="sng" cap="flat" w="6350">
-                      <a:solidFill>
-                        <a:srgbClr val="D9D9D9">
-                          <a:alpha val="100000"/>
-                        </a:srgbClr>
-                      </a:solidFill>
-                      <a:prstDash val="solid"/>
-                    </a:lnL>
-                    <a:lnR algn="ctr" cmpd="sng" cap="flat" w="6350">
-                      <a:solidFill>
-                        <a:srgbClr val="D9D9D9">
-                          <a:alpha val="100000"/>
-                        </a:srgbClr>
-                      </a:solidFill>
-                      <a:prstDash val="solid"/>
-                    </a:lnR>
-                    <a:lnT algn="ctr" cmpd="sng" cap="flat" w="6350">
-                      <a:solidFill>
-                        <a:srgbClr val="D9D9D9">
-                          <a:alpha val="100000"/>
-                        </a:srgbClr>
-                      </a:solidFill>
-                      <a:prstDash val="solid"/>
-                    </a:lnT>
-                    <a:lnB algn="ctr" cmpd="sng" cap="flat" w="6350">
-                      <a:solidFill>
-                        <a:srgbClr val="D9D9D9">
-                          <a:alpha val="100000"/>
-                        </a:srgbClr>
-                      </a:solidFill>
-                      <a:prstDash val="solid"/>
-                    </a:lnB>
-                    <a:solidFill>
-                      <a:srgbClr val="FFFFFF">
-                        <a:alpha val="0"/>
-                      </a:srgbClr>
-                    </a:solidFill>
-                  </a:tcPr>
-                </a:tc>
-              </a:tr>
-              <a:tr h="256032">
-                <a:tc>
-                  <a:txBody>
-                    <a:bodyPr/>
-                    <a:lstStyle/>
-                    <a:p>
-                      <a:pPr algn="ctr" marL="0" marR="0">
-                        <a:lnSpc>
-                          <a:spcPct val="100000"/>
-                        </a:lnSpc>
-                        <a:spcBef>
-                          <a:spcPts val="0"/>
-                        </a:spcBef>
-                        <a:spcAft>
-                          <a:spcPts val="0"/>
-                        </a:spcAft>
-                        <a:buNone/>
-                      </a:pPr>
-                      <a:r>
-                        <a:rPr cap="none" sz="800" i="0" b="0" u="none" strike="noStrike">
-                          <a:solidFill>
-                            <a:srgbClr val="000000">
-                              <a:alpha val="100000"/>
-                            </a:srgbClr>
-                          </a:solidFill>
-                          <a:latin typeface="Malgun Gothic"/>
-                          <a:cs typeface="Malgun Gothic"/>
-                          <a:ea typeface="Malgun Gothic"/>
-                          <a:sym typeface="Malgun Gothic"/>
-                        </a:rPr>
-                        <a:t> </a:t>
-                      </a:r>
-                    </a:p>
-                  </a:txBody>
-                  <a:tcPr anchor="ctr" marB="0" marT="0" marR="0" marL="0">
-                    <a:lnL algn="ctr" cmpd="sng" cap="flat" w="6350">
-                      <a:solidFill>
-                        <a:srgbClr val="D9D9D9">
-                          <a:alpha val="100000"/>
-                        </a:srgbClr>
-                      </a:solidFill>
-                      <a:prstDash val="solid"/>
-                    </a:lnL>
-                    <a:lnR algn="ctr" cmpd="sng" cap="flat" w="6350">
-                      <a:solidFill>
-                        <a:srgbClr val="D9D9D9">
-                          <a:alpha val="100000"/>
-                        </a:srgbClr>
-                      </a:solidFill>
-                      <a:prstDash val="solid"/>
-                    </a:lnR>
-                    <a:lnT algn="ctr" cmpd="sng" cap="flat" w="6350">
-                      <a:solidFill>
-                        <a:srgbClr val="D9D9D9">
-                          <a:alpha val="100000"/>
-                        </a:srgbClr>
-                      </a:solidFill>
-                      <a:prstDash val="solid"/>
-                    </a:lnT>
-                    <a:lnB algn="ctr" cmpd="sng" cap="flat" w="6350">
-                      <a:solidFill>
-                        <a:srgbClr val="D9D9D9">
-                          <a:alpha val="100000"/>
-                        </a:srgbClr>
-                      </a:solidFill>
-                      <a:prstDash val="solid"/>
-                    </a:lnB>
-                    <a:solidFill>
-                      <a:srgbClr val="F2F2F2">
-                        <a:alpha val="100000"/>
-                      </a:srgbClr>
-                    </a:solidFill>
-                  </a:tcPr>
-                </a:tc>
-                <a:tc>
-                  <a:txBody>
-                    <a:bodyPr/>
-                    <a:lstStyle/>
-                    <a:p>
-                      <a:pPr algn="ctr" marL="0" marR="0">
-                        <a:lnSpc>
-                          <a:spcPct val="100000"/>
-                        </a:lnSpc>
-                        <a:spcBef>
-                          <a:spcPts val="0"/>
-                        </a:spcBef>
-                        <a:spcAft>
-                          <a:spcPts val="0"/>
-                        </a:spcAft>
-                        <a:buNone/>
-                      </a:pPr>
-                      <a:r>
-                        <a:rPr cap="none" sz="800" i="0" b="0" u="none" strike="noStrike">
-                          <a:solidFill>
-                            <a:srgbClr val="000000">
-                              <a:alpha val="100000"/>
-                            </a:srgbClr>
-                          </a:solidFill>
-                          <a:latin typeface="Malgun Gothic"/>
-                          <a:cs typeface="Malgun Gothic"/>
-                          <a:ea typeface="Malgun Gothic"/>
-                          <a:sym typeface="Malgun Gothic"/>
-                        </a:rPr>
-                        <a:t> </a:t>
-                      </a:r>
-                    </a:p>
-                  </a:txBody>
-                  <a:tcPr anchor="ctr" marB="0" marT="0" marR="0" marL="0">
-                    <a:lnL algn="ctr" cmpd="sng" cap="flat" w="6350">
-                      <a:solidFill>
-                        <a:srgbClr val="D9D9D9">
-                          <a:alpha val="100000"/>
-                        </a:srgbClr>
-                      </a:solidFill>
-                      <a:prstDash val="solid"/>
-                    </a:lnL>
-                    <a:lnR algn="ctr" cmpd="sng" cap="flat" w="6350">
-                      <a:solidFill>
-                        <a:srgbClr val="D9D9D9">
-                          <a:alpha val="100000"/>
-                        </a:srgbClr>
-                      </a:solidFill>
-                      <a:prstDash val="solid"/>
-                    </a:lnR>
-                    <a:lnT algn="ctr" cmpd="sng" cap="flat" w="6350">
-                      <a:solidFill>
-                        <a:srgbClr val="D9D9D9">
-                          <a:alpha val="100000"/>
-                        </a:srgbClr>
-                      </a:solidFill>
-                      <a:prstDash val="solid"/>
-                    </a:lnT>
-                    <a:lnB algn="ctr" cmpd="sng" cap="flat" w="6350">
-                      <a:solidFill>
-                        <a:srgbClr val="D9D9D9">
-                          <a:alpha val="100000"/>
-                        </a:srgbClr>
-                      </a:solidFill>
-                      <a:prstDash val="solid"/>
-                    </a:lnB>
-                    <a:solidFill>
-                      <a:srgbClr val="F2F2F2">
-                        <a:alpha val="100000"/>
-                      </a:srgbClr>
-                    </a:solidFill>
-                  </a:tcPr>
-                </a:tc>
-                <a:tc>
-                  <a:txBody>
-                    <a:bodyPr/>
-                    <a:lstStyle/>
-                    <a:p>
-                      <a:pPr algn="ctr" marL="0" marR="0">
-                        <a:lnSpc>
-                          <a:spcPct val="100000"/>
-                        </a:lnSpc>
-                        <a:spcBef>
-                          <a:spcPts val="0"/>
-                        </a:spcBef>
-                        <a:spcAft>
-                          <a:spcPts val="0"/>
-                        </a:spcAft>
-                        <a:buNone/>
-                      </a:pPr>
-                      <a:r>
-                        <a:rPr cap="none" sz="800" i="0" b="0" u="none" strike="noStrike">
-                          <a:solidFill>
-                            <a:srgbClr val="000000">
-                              <a:alpha val="100000"/>
-                            </a:srgbClr>
-                          </a:solidFill>
-                          <a:latin typeface="Malgun Gothic"/>
-                          <a:cs typeface="Malgun Gothic"/>
-                          <a:ea typeface="Malgun Gothic"/>
-                          <a:sym typeface="Malgun Gothic"/>
-                        </a:rPr>
-                        <a:t> </a:t>
-                      </a:r>
-                    </a:p>
-                  </a:txBody>
-                  <a:tcPr anchor="ctr" marB="0" marT="0" marR="0" marL="0">
-                    <a:lnL algn="ctr" cmpd="sng" cap="flat" w="6350">
-                      <a:solidFill>
-                        <a:srgbClr val="D9D9D9">
-                          <a:alpha val="100000"/>
-                        </a:srgbClr>
-                      </a:solidFill>
-                      <a:prstDash val="solid"/>
-                    </a:lnL>
-                    <a:lnR algn="ctr" cmpd="sng" cap="flat" w="6350">
-                      <a:solidFill>
-                        <a:srgbClr val="D9D9D9">
-                          <a:alpha val="100000"/>
-                        </a:srgbClr>
-                      </a:solidFill>
-                      <a:prstDash val="solid"/>
-                    </a:lnR>
-                    <a:lnT algn="ctr" cmpd="sng" cap="flat" w="6350">
-                      <a:solidFill>
-                        <a:srgbClr val="D9D9D9">
-                          <a:alpha val="100000"/>
-                        </a:srgbClr>
-                      </a:solidFill>
-                      <a:prstDash val="solid"/>
-                    </a:lnT>
-                    <a:lnB algn="ctr" cmpd="sng" cap="flat" w="6350">
-                      <a:solidFill>
-                        <a:srgbClr val="D9D9D9">
-                          <a:alpha val="100000"/>
-                        </a:srgbClr>
-                      </a:solidFill>
-                      <a:prstDash val="solid"/>
-                    </a:lnB>
-                    <a:solidFill>
-                      <a:srgbClr val="F2F2F2">
-                        <a:alpha val="100000"/>
-                      </a:srgbClr>
-                    </a:solidFill>
-                  </a:tcPr>
-                </a:tc>
-                <a:tc>
-                  <a:txBody>
-                    <a:bodyPr/>
-                    <a:lstStyle/>
-                    <a:p>
-                      <a:pPr algn="ctr" marL="0" marR="0">
-                        <a:lnSpc>
-                          <a:spcPct val="100000"/>
-                        </a:lnSpc>
-                        <a:spcBef>
-                          <a:spcPts val="0"/>
-                        </a:spcBef>
-                        <a:spcAft>
-                          <a:spcPts val="0"/>
-                        </a:spcAft>
-                        <a:buNone/>
-                      </a:pPr>
-                      <a:r>
-                        <a:rPr cap="none" sz="800" i="0" b="0" u="none" strike="noStrike">
-                          <a:solidFill>
-                            <a:srgbClr val="000000">
-                              <a:alpha val="100000"/>
-                            </a:srgbClr>
-                          </a:solidFill>
-                          <a:latin typeface="Malgun Gothic"/>
-                          <a:cs typeface="Malgun Gothic"/>
-                          <a:ea typeface="Malgun Gothic"/>
-                          <a:sym typeface="Malgun Gothic"/>
-                        </a:rPr>
-                        <a:t> </a:t>
-                      </a:r>
-                    </a:p>
-                  </a:txBody>
-                  <a:tcPr anchor="ctr" marB="0" marT="0" marR="0" marL="0">
-                    <a:lnL algn="ctr" cmpd="sng" cap="flat" w="6350">
-                      <a:solidFill>
-                        <a:srgbClr val="D9D9D9">
-                          <a:alpha val="100000"/>
-                        </a:srgbClr>
-                      </a:solidFill>
-                      <a:prstDash val="solid"/>
-                    </a:lnL>
-                    <a:lnR algn="ctr" cmpd="sng" cap="flat" w="6350">
-                      <a:solidFill>
-                        <a:srgbClr val="D9D9D9">
-                          <a:alpha val="100000"/>
-                        </a:srgbClr>
-                      </a:solidFill>
-                      <a:prstDash val="solid"/>
-                    </a:lnR>
-                    <a:lnT algn="ctr" cmpd="sng" cap="flat" w="6350">
-                      <a:solidFill>
-                        <a:srgbClr val="D9D9D9">
-                          <a:alpha val="100000"/>
-                        </a:srgbClr>
-                      </a:solidFill>
-                      <a:prstDash val="solid"/>
-                    </a:lnT>
-                    <a:lnB algn="ctr" cmpd="sng" cap="flat" w="6350">
-                      <a:solidFill>
-                        <a:srgbClr val="D9D9D9">
-                          <a:alpha val="100000"/>
-                        </a:srgbClr>
-                      </a:solidFill>
-                      <a:prstDash val="solid"/>
-                    </a:lnB>
-                    <a:solidFill>
-                      <a:srgbClr val="F2F2F2">
-                        <a:alpha val="100000"/>
-                      </a:srgbClr>
-                    </a:solidFill>
-                  </a:tcPr>
-                </a:tc>
-              </a:tr>
-              <a:tr h="2029968">
-                <a:tc>
-                  <a:txBody>
-                    <a:bodyPr/>
-                    <a:lstStyle/>
-                    <a:p>
-                      <a:pPr algn="ctr" marL="0" marR="0">
-                        <a:lnSpc>
-                          <a:spcPct val="100000"/>
-                        </a:lnSpc>
-                        <a:spcBef>
-                          <a:spcPts val="0"/>
-                        </a:spcBef>
-                        <a:spcAft>
-                          <a:spcPts val="0"/>
-                        </a:spcAft>
-                        <a:buNone/>
-                      </a:pPr>
-                      <a:r>
-                        <a:rPr cap="none" sz="800" i="0" b="0" u="none" strike="noStrike">
-                          <a:solidFill>
-                            <a:srgbClr val="000000">
-                              <a:alpha val="100000"/>
-                            </a:srgbClr>
-                          </a:solidFill>
-                          <a:latin typeface="Malgun Gothic"/>
-                          <a:cs typeface="Malgun Gothic"/>
-                          <a:ea typeface="Malgun Gothic"/>
-                          <a:sym typeface="Malgun Gothic"/>
-                        </a:rPr>
-                        <a:t> </a:t>
-                      </a:r>
-                    </a:p>
-                  </a:txBody>
-                  <a:tcPr anchor="ctr" marB="0" marT="0" marR="0" marL="0">
-                    <a:lnL algn="ctr" cmpd="sng" cap="flat" w="6350">
-                      <a:solidFill>
-                        <a:srgbClr val="D9D9D9">
-                          <a:alpha val="100000"/>
-                        </a:srgbClr>
-                      </a:solidFill>
-                      <a:prstDash val="solid"/>
-                    </a:lnL>
-                    <a:lnR algn="ctr" cmpd="sng" cap="flat" w="6350">
-                      <a:solidFill>
-                        <a:srgbClr val="D9D9D9">
-                          <a:alpha val="100000"/>
-                        </a:srgbClr>
-                      </a:solidFill>
-                      <a:prstDash val="solid"/>
-                    </a:lnR>
-                    <a:lnT algn="ctr" cmpd="sng" cap="flat" w="6350">
-                      <a:solidFill>
-                        <a:srgbClr val="D9D9D9">
-                          <a:alpha val="100000"/>
-                        </a:srgbClr>
-                      </a:solidFill>
-                      <a:prstDash val="solid"/>
-                    </a:lnT>
-                    <a:lnB algn="ctr" cmpd="sng" cap="flat" w="6350">
-                      <a:solidFill>
-                        <a:srgbClr val="D9D9D9">
-                          <a:alpha val="100000"/>
-                        </a:srgbClr>
-                      </a:solidFill>
-                      <a:prstDash val="solid"/>
-                    </a:lnB>
-                    <a:solidFill>
-                      <a:srgbClr val="FFFFFF">
-                        <a:alpha val="0"/>
-                      </a:srgbClr>
-                    </a:solidFill>
-                  </a:tcPr>
-                </a:tc>
-                <a:tc>
-                  <a:txBody>
-                    <a:bodyPr/>
-                    <a:lstStyle/>
-                    <a:p>
-                      <a:pPr algn="ctr" marL="0" marR="0">
-                        <a:lnSpc>
-                          <a:spcPct val="100000"/>
-                        </a:lnSpc>
-                        <a:spcBef>
-                          <a:spcPts val="0"/>
-                        </a:spcBef>
-                        <a:spcAft>
-                          <a:spcPts val="0"/>
-                        </a:spcAft>
-                        <a:buNone/>
-                      </a:pPr>
-                      <a:r>
-                        <a:rPr cap="none" sz="800" i="0" b="0" u="none" strike="noStrike">
-                          <a:solidFill>
-                            <a:srgbClr val="000000">
-                              <a:alpha val="100000"/>
-                            </a:srgbClr>
-                          </a:solidFill>
-                          <a:latin typeface="Malgun Gothic"/>
-                          <a:cs typeface="Malgun Gothic"/>
-                          <a:ea typeface="Malgun Gothic"/>
-                          <a:sym typeface="Malgun Gothic"/>
-                        </a:rPr>
-                        <a:t> </a:t>
-                      </a:r>
-                    </a:p>
-                  </a:txBody>
-                  <a:tcPr anchor="ctr" marB="0" marT="0" marR="0" marL="0">
-                    <a:lnL algn="ctr" cmpd="sng" cap="flat" w="6350">
-                      <a:solidFill>
-                        <a:srgbClr val="D9D9D9">
-                          <a:alpha val="100000"/>
-                        </a:srgbClr>
-                      </a:solidFill>
-                      <a:prstDash val="solid"/>
-                    </a:lnL>
-                    <a:lnR algn="ctr" cmpd="sng" cap="flat" w="6350">
-                      <a:solidFill>
-                        <a:srgbClr val="D9D9D9">
-                          <a:alpha val="100000"/>
-                        </a:srgbClr>
-                      </a:solidFill>
-                      <a:prstDash val="solid"/>
-                    </a:lnR>
-                    <a:lnT algn="ctr" cmpd="sng" cap="flat" w="6350">
-                      <a:solidFill>
-                        <a:srgbClr val="D9D9D9">
-                          <a:alpha val="100000"/>
-                        </a:srgbClr>
-                      </a:solidFill>
-                      <a:prstDash val="solid"/>
-                    </a:lnT>
-                    <a:lnB algn="ctr" cmpd="sng" cap="flat" w="6350">
-                      <a:solidFill>
-                        <a:srgbClr val="D9D9D9">
-                          <a:alpha val="100000"/>
-                        </a:srgbClr>
-                      </a:solidFill>
-                      <a:prstDash val="solid"/>
-                    </a:lnB>
-                    <a:solidFill>
-                      <a:srgbClr val="FFFFFF">
-                        <a:alpha val="0"/>
-                      </a:srgbClr>
-                    </a:solidFill>
-                  </a:tcPr>
-                </a:tc>
-                <a:tc>
-                  <a:txBody>
-                    <a:bodyPr/>
-                    <a:lstStyle/>
-                    <a:p>
-                      <a:pPr algn="ctr" marL="0" marR="0">
-                        <a:lnSpc>
-                          <a:spcPct val="100000"/>
-                        </a:lnSpc>
-                        <a:spcBef>
-                          <a:spcPts val="0"/>
-                        </a:spcBef>
-                        <a:spcAft>
-                          <a:spcPts val="0"/>
-                        </a:spcAft>
-                        <a:buNone/>
-                      </a:pPr>
-                      <a:r>
-                        <a:rPr cap="none" sz="800" i="0" b="0" u="none" strike="noStrike">
-                          <a:solidFill>
-                            <a:srgbClr val="000000">
-                              <a:alpha val="100000"/>
-                            </a:srgbClr>
-                          </a:solidFill>
-                          <a:latin typeface="Malgun Gothic"/>
-                          <a:cs typeface="Malgun Gothic"/>
-                          <a:ea typeface="Malgun Gothic"/>
-                          <a:sym typeface="Malgun Gothic"/>
-                        </a:rPr>
-                        <a:t> </a:t>
-                      </a:r>
-                    </a:p>
-                  </a:txBody>
-                  <a:tcPr anchor="ctr" marB="0" marT="0" marR="0" marL="0">
-                    <a:lnL algn="ctr" cmpd="sng" cap="flat" w="6350">
-                      <a:solidFill>
-                        <a:srgbClr val="D9D9D9">
-                          <a:alpha val="100000"/>
-                        </a:srgbClr>
-                      </a:solidFill>
-                      <a:prstDash val="solid"/>
-                    </a:lnL>
-                    <a:lnR algn="ctr" cmpd="sng" cap="flat" w="6350">
-                      <a:solidFill>
-                        <a:srgbClr val="D9D9D9">
-                          <a:alpha val="100000"/>
-                        </a:srgbClr>
-                      </a:solidFill>
-                      <a:prstDash val="solid"/>
-                    </a:lnR>
-                    <a:lnT algn="ctr" cmpd="sng" cap="flat" w="6350">
-                      <a:solidFill>
-                        <a:srgbClr val="D9D9D9">
-                          <a:alpha val="100000"/>
-                        </a:srgbClr>
-                      </a:solidFill>
-                      <a:prstDash val="solid"/>
-                    </a:lnT>
-                    <a:lnB algn="ctr" cmpd="sng" cap="flat" w="6350">
-                      <a:solidFill>
-                        <a:srgbClr val="D9D9D9">
-                          <a:alpha val="100000"/>
-                        </a:srgbClr>
-                      </a:solidFill>
-                      <a:prstDash val="solid"/>
-                    </a:lnB>
-                    <a:solidFill>
-                      <a:srgbClr val="FFFFFF">
-                        <a:alpha val="0"/>
-                      </a:srgbClr>
-                    </a:solidFill>
-                  </a:tcPr>
-                </a:tc>
-                <a:tc>
-                  <a:txBody>
-                    <a:bodyPr/>
-                    <a:lstStyle/>
-                    <a:p>
-                      <a:pPr algn="ctr" marL="0" marR="0">
-                        <a:lnSpc>
-                          <a:spcPct val="100000"/>
-                        </a:lnSpc>
-                        <a:spcBef>
-                          <a:spcPts val="0"/>
-                        </a:spcBef>
-                        <a:spcAft>
-                          <a:spcPts val="0"/>
-                        </a:spcAft>
-                        <a:buNone/>
-                      </a:pPr>
-                      <a:r>
-                        <a:rPr cap="none" sz="800" i="0" b="0" u="none" strike="noStrike">
-                          <a:solidFill>
-                            <a:srgbClr val="000000">
-                              <a:alpha val="100000"/>
-                            </a:srgbClr>
-                          </a:solidFill>
-                          <a:latin typeface="Malgun Gothic"/>
-                          <a:cs typeface="Malgun Gothic"/>
-                          <a:ea typeface="Malgun Gothic"/>
-                          <a:sym typeface="Malgun Gothic"/>
-                        </a:rPr>
-                        <a:t> </a:t>
-                      </a:r>
-                    </a:p>
-                  </a:txBody>
-                  <a:tcPr anchor="ctr" marB="0" marT="0" marR="0" marL="0">
-                    <a:lnL algn="ctr" cmpd="sng" cap="flat" w="6350">
-                      <a:solidFill>
-                        <a:srgbClr val="D9D9D9">
-                          <a:alpha val="100000"/>
-                        </a:srgbClr>
-                      </a:solidFill>
-                      <a:prstDash val="solid"/>
-                    </a:lnL>
-                    <a:lnR algn="ctr" cmpd="sng" cap="flat" w="6350">
-                      <a:solidFill>
-                        <a:srgbClr val="D9D9D9">
-                          <a:alpha val="100000"/>
-                        </a:srgbClr>
-                      </a:solidFill>
-                      <a:prstDash val="solid"/>
-                    </a:lnR>
-                    <a:lnT algn="ctr" cmpd="sng" cap="flat" w="6350">
-                      <a:solidFill>
-                        <a:srgbClr val="D9D9D9">
-                          <a:alpha val="100000"/>
-                        </a:srgbClr>
-                      </a:solidFill>
-                      <a:prstDash val="solid"/>
-                    </a:lnT>
-                    <a:lnB algn="ctr" cmpd="sng" cap="flat" w="6350">
-                      <a:solidFill>
-                        <a:srgbClr val="D9D9D9">
-                          <a:alpha val="100000"/>
-                        </a:srgbClr>
-                      </a:solidFill>
-                      <a:prstDash val="solid"/>
-                    </a:lnB>
-                    <a:solidFill>
-                      <a:srgbClr val="FFFFFF">
-                        <a:alpha val="0"/>
-                      </a:srgbClr>
-                    </a:solidFill>
-                  </a:tcPr>
-                </a:tc>
-              </a:tr>
-            </a:tbl>
-          </a:graphicData>
-        </a:graphic>
-      </p:graphicFrame>
-      <p:sp>
-        <p:nvSpPr>
-          <p:cNvPr id="3" name=""/>
-          <p:cNvSpPr>
-            <a:spLocks noGrp="1"/>
-          </p:cNvSpPr>
-          <p:nvPr>
-            <p:ph/>
-          </p:nvPr>
-        </p:nvSpPr>
-        <p:spPr>
-          <a:xfrm>
-            <a:off x="329184" y="1842516"/>
-            <a:ext cx="2827782" cy="228600"/>
-          </a:xfrm>
-          <a:solidFill>
-            <a:srgbClr val="FFFFFF">
-              <a:alpha val="0"/>
-            </a:srgbClr>
-          </a:solidFill>
-        </p:spPr>
-        <p:txBody>
-          <a:bodyPr/>
-          <a:lstStyle/>
-          <a:p>
-            <a:pPr algn="ctr" marL="0" marR="0">
-              <a:lnSpc>
-                <a:spcPct val="100000"/>
-              </a:lnSpc>
-              <a:spcBef>
-                <a:spcPts val="0"/>
-              </a:spcBef>
-              <a:spcAft>
-                <a:spcPts val="0"/>
-              </a:spcAft>
-              <a:buNone/>
-            </a:pPr>
-            <a:r>
-              <a:rPr cap="none" sz="900" i="0" b="1" u="none" strike="noStrike">
-                <a:solidFill>
-                  <a:srgbClr val="D62728">
-                    <a:alpha val="100000"/>
-                  </a:srgbClr>
-                </a:solidFill>
-                <a:latin typeface="Malgun Gothic"/>
-                <a:cs typeface="Malgun Gothic"/>
-                <a:ea typeface="Malgun Gothic"/>
-                <a:sym typeface="Malgun Gothic"/>
-              </a:rPr>
-              <a:t>⬤</a:t>
-            </a:r>
-            <a:r>
-              <a:rPr cap="none" sz="900" i="0" b="0" u="none" strike="noStrike">
-                <a:solidFill>
-                  <a:srgbClr val="333333">
-                    <a:alpha val="100000"/>
-                  </a:srgbClr>
-                </a:solidFill>
-                <a:latin typeface="Malgun Gothic"/>
-                <a:cs typeface="Malgun Gothic"/>
-                <a:ea typeface="Malgun Gothic"/>
-                <a:sym typeface="Malgun Gothic"/>
-              </a:rPr>
-              <a:t> (ML_MSR_207) Cell_TCMC_207</a:t>
-            </a:r>
-          </a:p>
-        </p:txBody>
-      </p:sp>
-      <p:pic>
-        <p:nvPicPr>
-          <p:cNvPr id="4" name="" descr=""/>
-          <p:cNvPicPr>
-            <a:picLocks noGrp="1"/>
-          </p:cNvPicPr>
-          <p:nvPr>
-            <p:ph/>
-          </p:nvPr>
-        </p:nvPicPr>
-        <p:blipFill>
-          <a:blip r:embed="rId2"/>
-          <a:stretch>
-            <a:fillRect/>
-          </a:stretch>
-        </p:blipFill>
-        <p:spPr>
-          <a:xfrm>
-            <a:off x="329184" y="2112264"/>
-            <a:ext cx="2827782" cy="1965960"/>
-          </a:xfrm>
-          <a:prstGeom prst="rect">
-            <a:avLst/>
-          </a:prstGeom>
-        </p:spPr>
-      </p:pic>
-      <p:sp>
-        <p:nvSpPr>
-          <p:cNvPr id="5" name=""/>
-          <p:cNvSpPr>
-            <a:spLocks noGrp="1"/>
-          </p:cNvSpPr>
-          <p:nvPr>
-            <p:ph/>
-          </p:nvPr>
-        </p:nvSpPr>
-        <p:spPr>
-          <a:xfrm>
-            <a:off x="2562606" y="2139696"/>
-            <a:ext cx="566928" cy="164592"/>
-          </a:xfrm>
-          <a:solidFill>
-            <a:srgbClr val="FFFFFF">
-              <a:alpha val="0"/>
-            </a:srgbClr>
-          </a:solidFill>
-        </p:spPr>
-        <p:txBody>
-          <a:bodyPr/>
-          <a:lstStyle/>
-          <a:p>
-            <a:pPr algn="r" marL="0" marR="0">
-              <a:lnSpc>
-                <a:spcPct val="100000"/>
-              </a:lnSpc>
-              <a:spcBef>
-                <a:spcPts val="0"/>
-              </a:spcBef>
-              <a:spcAft>
-                <a:spcPts val="0"/>
-              </a:spcAft>
-              <a:buNone/>
-            </a:pPr>
-            <a:r>
-              <a:rPr cap="none" sz="800" i="0" b="0" u="none" strike="noStrike">
-                <a:solidFill>
-                  <a:srgbClr val="808080">
-                    <a:alpha val="100000"/>
-                  </a:srgbClr>
-                </a:solidFill>
-                <a:latin typeface="Malgun Gothic"/>
-                <a:cs typeface="Malgun Gothic"/>
-                <a:ea typeface="Malgun Gothic"/>
-                <a:sym typeface="Malgun Gothic"/>
-              </a:rPr>
-              <a:t>+0.7sig</a:t>
-            </a:r>
-          </a:p>
-        </p:txBody>
-      </p:sp>
-      <p:sp>
-        <p:nvSpPr>
-          <p:cNvPr id="6" name=""/>
-          <p:cNvSpPr>
-            <a:spLocks noGrp="1"/>
-          </p:cNvSpPr>
-          <p:nvPr>
-            <p:ph/>
-          </p:nvPr>
-        </p:nvSpPr>
-        <p:spPr>
-          <a:xfrm>
-            <a:off x="3230118" y="1842516"/>
-            <a:ext cx="2827782" cy="228600"/>
-          </a:xfrm>
-          <a:solidFill>
-            <a:srgbClr val="FFFFFF">
-              <a:alpha val="0"/>
-            </a:srgbClr>
-          </a:solidFill>
-        </p:spPr>
-        <p:txBody>
-          <a:bodyPr/>
-          <a:lstStyle/>
-          <a:p>
-            <a:pPr algn="ctr" marL="0" marR="0">
-              <a:lnSpc>
-                <a:spcPct val="100000"/>
-              </a:lnSpc>
-              <a:spcBef>
-                <a:spcPts val="0"/>
-              </a:spcBef>
-              <a:spcAft>
-                <a:spcPts val="0"/>
-              </a:spcAft>
-              <a:buNone/>
-            </a:pPr>
-            <a:r>
-              <a:rPr cap="none" sz="900" i="0" b="1" u="none" strike="noStrike">
-                <a:solidFill>
-                  <a:srgbClr val="D62728">
-                    <a:alpha val="100000"/>
-                  </a:srgbClr>
-                </a:solidFill>
-                <a:latin typeface="Malgun Gothic"/>
-                <a:cs typeface="Malgun Gothic"/>
-                <a:ea typeface="Malgun Gothic"/>
-                <a:sym typeface="Malgun Gothic"/>
-              </a:rPr>
-              <a:t>⬤</a:t>
-            </a:r>
-            <a:r>
-              <a:rPr cap="none" sz="900" i="0" b="0" u="none" strike="noStrike">
-                <a:solidFill>
-                  <a:srgbClr val="333333">
-                    <a:alpha val="100000"/>
-                  </a:srgbClr>
-                </a:solidFill>
-                <a:latin typeface="Malgun Gothic"/>
-                <a:cs typeface="Malgun Gothic"/>
-                <a:ea typeface="Malgun Gothic"/>
-                <a:sym typeface="Malgun Gothic"/>
-              </a:rPr>
-              <a:t> (ML_MSR_212) Cell_TCMC_212</a:t>
-            </a:r>
-          </a:p>
-        </p:txBody>
-      </p:sp>
-      <p:pic>
-        <p:nvPicPr>
-          <p:cNvPr id="7" name="" descr=""/>
-          <p:cNvPicPr>
-            <a:picLocks noGrp="1"/>
-          </p:cNvPicPr>
-          <p:nvPr>
-            <p:ph/>
-          </p:nvPr>
-        </p:nvPicPr>
-        <p:blipFill>
-          <a:blip r:embed="rId3"/>
-          <a:stretch>
-            <a:fillRect/>
-          </a:stretch>
-        </p:blipFill>
-        <p:spPr>
-          <a:xfrm>
-            <a:off x="3230118" y="2112264"/>
-            <a:ext cx="2827782" cy="1965960"/>
-          </a:xfrm>
-          <a:prstGeom prst="rect">
-            <a:avLst/>
-          </a:prstGeom>
-        </p:spPr>
-      </p:pic>
-      <p:sp>
-        <p:nvSpPr>
-          <p:cNvPr id="8" name=""/>
-          <p:cNvSpPr>
-            <a:spLocks noGrp="1"/>
-          </p:cNvSpPr>
-          <p:nvPr>
-            <p:ph/>
-          </p:nvPr>
-        </p:nvSpPr>
-        <p:spPr>
-          <a:xfrm>
-            <a:off x="5463540" y="2139696"/>
-            <a:ext cx="566928" cy="164592"/>
-          </a:xfrm>
-          <a:solidFill>
-            <a:srgbClr val="FFFFFF">
-              <a:alpha val="0"/>
-            </a:srgbClr>
-          </a:solidFill>
-        </p:spPr>
-        <p:txBody>
-          <a:bodyPr/>
-          <a:lstStyle/>
-          <a:p>
-            <a:pPr algn="r" marL="0" marR="0">
-              <a:lnSpc>
-                <a:spcPct val="100000"/>
-              </a:lnSpc>
-              <a:spcBef>
-                <a:spcPts val="0"/>
-              </a:spcBef>
-              <a:spcAft>
-                <a:spcPts val="0"/>
-              </a:spcAft>
-              <a:buNone/>
-            </a:pPr>
-            <a:r>
-              <a:rPr cap="none" sz="800" i="0" b="0" u="none" strike="noStrike">
-                <a:solidFill>
-                  <a:srgbClr val="808080">
-                    <a:alpha val="100000"/>
-                  </a:srgbClr>
-                </a:solidFill>
-                <a:latin typeface="Malgun Gothic"/>
-                <a:cs typeface="Malgun Gothic"/>
-                <a:ea typeface="Malgun Gothic"/>
-                <a:sym typeface="Malgun Gothic"/>
-              </a:rPr>
-              <a:t>+0.7sig</a:t>
-            </a:r>
-          </a:p>
-        </p:txBody>
-      </p:sp>
-      <p:sp>
-        <p:nvSpPr>
-          <p:cNvPr id="9" name=""/>
-          <p:cNvSpPr>
-            <a:spLocks noGrp="1"/>
-          </p:cNvSpPr>
-          <p:nvPr>
-            <p:ph/>
-          </p:nvPr>
-        </p:nvSpPr>
-        <p:spPr>
-          <a:xfrm>
-            <a:off x="6131052" y="1842516"/>
-            <a:ext cx="2827782" cy="228600"/>
-          </a:xfrm>
-          <a:solidFill>
-            <a:srgbClr val="FFFFFF">
-              <a:alpha val="0"/>
-            </a:srgbClr>
-          </a:solidFill>
-        </p:spPr>
-        <p:txBody>
-          <a:bodyPr/>
-          <a:lstStyle/>
-          <a:p>
-            <a:pPr algn="ctr" marL="0" marR="0">
-              <a:lnSpc>
-                <a:spcPct val="100000"/>
-              </a:lnSpc>
-              <a:spcBef>
-                <a:spcPts val="0"/>
-              </a:spcBef>
-              <a:spcAft>
-                <a:spcPts val="0"/>
-              </a:spcAft>
-              <a:buNone/>
-            </a:pPr>
-            <a:r>
-              <a:rPr cap="none" sz="900" i="0" b="1" u="none" strike="noStrike">
-                <a:solidFill>
-                  <a:srgbClr val="D62728">
-                    <a:alpha val="100000"/>
-                  </a:srgbClr>
-                </a:solidFill>
-                <a:latin typeface="Malgun Gothic"/>
-                <a:cs typeface="Malgun Gothic"/>
-                <a:ea typeface="Malgun Gothic"/>
-                <a:sym typeface="Malgun Gothic"/>
-              </a:rPr>
-              <a:t>⬤</a:t>
-            </a:r>
-            <a:r>
-              <a:rPr cap="none" sz="900" i="0" b="0" u="none" strike="noStrike">
-                <a:solidFill>
-                  <a:srgbClr val="333333">
-                    <a:alpha val="100000"/>
-                  </a:srgbClr>
-                </a:solidFill>
-                <a:latin typeface="Malgun Gothic"/>
-                <a:cs typeface="Malgun Gothic"/>
-                <a:ea typeface="Malgun Gothic"/>
-                <a:sym typeface="Malgun Gothic"/>
-              </a:rPr>
-              <a:t> (ML_MSR_234) Cell_TCMC_234</a:t>
-            </a:r>
-          </a:p>
-        </p:txBody>
-      </p:sp>
-      <p:pic>
-        <p:nvPicPr>
-          <p:cNvPr id="10" name="" descr=""/>
-          <p:cNvPicPr>
-            <a:picLocks noGrp="1"/>
-          </p:cNvPicPr>
-          <p:nvPr>
-            <p:ph/>
-          </p:nvPr>
-        </p:nvPicPr>
-        <p:blipFill>
-          <a:blip r:embed="rId4"/>
-          <a:stretch>
-            <a:fillRect/>
-          </a:stretch>
-        </p:blipFill>
-        <p:spPr>
-          <a:xfrm>
-            <a:off x="6131052" y="2112264"/>
-            <a:ext cx="2827782" cy="1965960"/>
-          </a:xfrm>
-          <a:prstGeom prst="rect">
-            <a:avLst/>
-          </a:prstGeom>
-        </p:spPr>
-      </p:pic>
-      <p:sp>
-        <p:nvSpPr>
-          <p:cNvPr id="11" name=""/>
-          <p:cNvSpPr>
-            <a:spLocks noGrp="1"/>
-          </p:cNvSpPr>
-          <p:nvPr>
-            <p:ph/>
-          </p:nvPr>
-        </p:nvSpPr>
-        <p:spPr>
-          <a:xfrm>
-            <a:off x="8364474" y="2139696"/>
-            <a:ext cx="566928" cy="164592"/>
-          </a:xfrm>
-          <a:solidFill>
-            <a:srgbClr val="FFFFFF">
-              <a:alpha val="0"/>
-            </a:srgbClr>
-          </a:solidFill>
-        </p:spPr>
-        <p:txBody>
-          <a:bodyPr/>
-          <a:lstStyle/>
-          <a:p>
-            <a:pPr algn="r" marL="0" marR="0">
-              <a:lnSpc>
-                <a:spcPct val="100000"/>
-              </a:lnSpc>
-              <a:spcBef>
-                <a:spcPts val="0"/>
-              </a:spcBef>
-              <a:spcAft>
-                <a:spcPts val="0"/>
-              </a:spcAft>
-              <a:buNone/>
-            </a:pPr>
-            <a:r>
-              <a:rPr cap="none" sz="800" i="0" b="0" u="none" strike="noStrike">
-                <a:solidFill>
-                  <a:srgbClr val="808080">
-                    <a:alpha val="100000"/>
-                  </a:srgbClr>
-                </a:solidFill>
-                <a:latin typeface="Malgun Gothic"/>
-                <a:cs typeface="Malgun Gothic"/>
-                <a:ea typeface="Malgun Gothic"/>
-                <a:sym typeface="Malgun Gothic"/>
-              </a:rPr>
-              <a:t>+0.7sig</a:t>
-            </a:r>
-          </a:p>
-        </p:txBody>
-      </p:sp>
-      <p:sp>
-        <p:nvSpPr>
           <p:cNvPr id="12" name=""/>
-          <p:cNvSpPr>
-            <a:spLocks noGrp="1"/>
-          </p:cNvSpPr>
-          <p:nvPr>
-            <p:ph/>
-          </p:nvPr>
-        </p:nvSpPr>
-        <p:spPr>
-          <a:xfrm>
-            <a:off x="9031986" y="1842516"/>
-            <a:ext cx="2827782" cy="228600"/>
-          </a:xfrm>
-          <a:solidFill>
-            <a:srgbClr val="FFFFFF">
-              <a:alpha val="0"/>
-            </a:srgbClr>
-          </a:solidFill>
-        </p:spPr>
-        <p:txBody>
-          <a:bodyPr/>
-          <a:lstStyle/>
-          <a:p>
-            <a:pPr algn="ctr" marL="0" marR="0">
-              <a:lnSpc>
-                <a:spcPct val="100000"/>
-              </a:lnSpc>
-              <a:spcBef>
-                <a:spcPts val="0"/>
-              </a:spcBef>
-              <a:spcAft>
-                <a:spcPts val="0"/>
-              </a:spcAft>
-              <a:buNone/>
-            </a:pPr>
-            <a:r>
-              <a:rPr cap="none" sz="900" i="0" b="1" u="none" strike="noStrike">
-                <a:solidFill>
-                  <a:srgbClr val="D62728">
-                    <a:alpha val="100000"/>
-                  </a:srgbClr>
-                </a:solidFill>
-                <a:latin typeface="Malgun Gothic"/>
-                <a:cs typeface="Malgun Gothic"/>
-                <a:ea typeface="Malgun Gothic"/>
-                <a:sym typeface="Malgun Gothic"/>
-              </a:rPr>
-              <a:t>⬤</a:t>
-            </a:r>
-            <a:r>
-              <a:rPr cap="none" sz="900" i="0" b="0" u="none" strike="noStrike">
-                <a:solidFill>
-                  <a:srgbClr val="333333">
-                    <a:alpha val="100000"/>
-                  </a:srgbClr>
-                </a:solidFill>
-                <a:latin typeface="Malgun Gothic"/>
-                <a:cs typeface="Malgun Gothic"/>
-                <a:ea typeface="Malgun Gothic"/>
-                <a:sym typeface="Malgun Gothic"/>
-              </a:rPr>
-              <a:t> (ML_MSR_235) Cell_TCMC_235</a:t>
-            </a:r>
-          </a:p>
-        </p:txBody>
-      </p:sp>
-      <p:pic>
-        <p:nvPicPr>
-          <p:cNvPr id="13" name="" descr=""/>
-          <p:cNvPicPr>
-            <a:picLocks noGrp="1"/>
-          </p:cNvPicPr>
-          <p:nvPr>
-            <p:ph/>
-          </p:nvPr>
-        </p:nvPicPr>
-        <p:blipFill>
-          <a:blip r:embed="rId5"/>
-          <a:stretch>
-            <a:fillRect/>
-          </a:stretch>
-        </p:blipFill>
-        <p:spPr>
-          <a:xfrm>
-            <a:off x="9031986" y="2112264"/>
-            <a:ext cx="2827782" cy="1965960"/>
-          </a:xfrm>
-          <a:prstGeom prst="rect">
-            <a:avLst/>
-          </a:prstGeom>
-        </p:spPr>
-      </p:pic>
-      <p:sp>
-        <p:nvSpPr>
-          <p:cNvPr id="14" name=""/>
-          <p:cNvSpPr>
-            <a:spLocks noGrp="1"/>
-          </p:cNvSpPr>
-          <p:nvPr>
-            <p:ph/>
-          </p:nvPr>
-        </p:nvSpPr>
-        <p:spPr>
-          <a:xfrm>
-            <a:off x="11265408" y="2139696"/>
-            <a:ext cx="566928" cy="164592"/>
-          </a:xfrm>
-          <a:solidFill>
-            <a:srgbClr val="FFFFFF">
-              <a:alpha val="0"/>
-            </a:srgbClr>
-          </a:solidFill>
-        </p:spPr>
-        <p:txBody>
-          <a:bodyPr/>
-          <a:lstStyle/>
-          <a:p>
-            <a:pPr algn="r" marL="0" marR="0">
-              <a:lnSpc>
-                <a:spcPct val="100000"/>
-              </a:lnSpc>
-              <a:spcBef>
-                <a:spcPts val="0"/>
-              </a:spcBef>
-              <a:spcAft>
-                <a:spcPts val="0"/>
-              </a:spcAft>
-              <a:buNone/>
-            </a:pPr>
-            <a:r>
-              <a:rPr cap="none" sz="800" i="0" b="0" u="none" strike="noStrike">
-                <a:solidFill>
-                  <a:srgbClr val="808080">
-                    <a:alpha val="100000"/>
-                  </a:srgbClr>
-                </a:solidFill>
-                <a:latin typeface="Malgun Gothic"/>
-                <a:cs typeface="Malgun Gothic"/>
-                <a:ea typeface="Malgun Gothic"/>
-                <a:sym typeface="Malgun Gothic"/>
-              </a:rPr>
-              <a:t>+0.7sig</a:t>
-            </a:r>
-          </a:p>
-        </p:txBody>
-      </p:sp>
-      <p:sp>
-        <p:nvSpPr>
-          <p:cNvPr id="15" name=""/>
-          <p:cNvSpPr>
-            <a:spLocks noGrp="1"/>
-          </p:cNvSpPr>
-          <p:nvPr>
-            <p:ph/>
-          </p:nvPr>
-        </p:nvSpPr>
-        <p:spPr>
-          <a:xfrm>
-            <a:off x="329184" y="4128516"/>
-            <a:ext cx="2827782" cy="228600"/>
-          </a:xfrm>
-          <a:solidFill>
-            <a:srgbClr val="FFFFFF">
-              <a:alpha val="0"/>
-            </a:srgbClr>
-          </a:solidFill>
-        </p:spPr>
-        <p:txBody>
-          <a:bodyPr/>
-          <a:lstStyle/>
-          <a:p>
-            <a:pPr algn="ctr" marL="0" marR="0">
-              <a:lnSpc>
-                <a:spcPct val="100000"/>
-              </a:lnSpc>
-              <a:spcBef>
-                <a:spcPts val="0"/>
-              </a:spcBef>
-              <a:spcAft>
-                <a:spcPts val="0"/>
-              </a:spcAft>
-              <a:buNone/>
-            </a:pPr>
-            <a:r>
-              <a:rPr cap="none" sz="900" i="0" b="1" u="none" strike="noStrike">
-                <a:solidFill>
-                  <a:srgbClr val="D62728">
-                    <a:alpha val="100000"/>
-                  </a:srgbClr>
-                </a:solidFill>
-                <a:latin typeface="Malgun Gothic"/>
-                <a:cs typeface="Malgun Gothic"/>
-                <a:ea typeface="Malgun Gothic"/>
-                <a:sym typeface="Malgun Gothic"/>
-              </a:rPr>
-              <a:t>⬤</a:t>
-            </a:r>
-            <a:r>
-              <a:rPr cap="none" sz="900" i="0" b="0" u="none" strike="noStrike">
-                <a:solidFill>
-                  <a:srgbClr val="333333">
-                    <a:alpha val="100000"/>
-                  </a:srgbClr>
-                </a:solidFill>
-                <a:latin typeface="Malgun Gothic"/>
-                <a:cs typeface="Malgun Gothic"/>
-                <a:ea typeface="Malgun Gothic"/>
-                <a:sym typeface="Malgun Gothic"/>
-              </a:rPr>
-              <a:t> (ML_MSR_203) Cell_TCMC_203</a:t>
-            </a:r>
-          </a:p>
-        </p:txBody>
-      </p:sp>
-      <p:pic>
-        <p:nvPicPr>
-          <p:cNvPr id="16" name="" descr=""/>
-          <p:cNvPicPr>
-            <a:picLocks noGrp="1"/>
-          </p:cNvPicPr>
-          <p:nvPr>
-            <p:ph/>
-          </p:nvPr>
-        </p:nvPicPr>
-        <p:blipFill>
-          <a:blip r:embed="rId6"/>
-          <a:stretch>
-            <a:fillRect/>
-          </a:stretch>
-        </p:blipFill>
-        <p:spPr>
-          <a:xfrm>
-            <a:off x="329184" y="4398264"/>
-            <a:ext cx="2827782" cy="1965960"/>
-          </a:xfrm>
-          <a:prstGeom prst="rect">
-            <a:avLst/>
-          </a:prstGeom>
-        </p:spPr>
-      </p:pic>
-      <p:sp>
-        <p:nvSpPr>
-          <p:cNvPr id="17" name=""/>
-          <p:cNvSpPr>
-            <a:spLocks noGrp="1"/>
-          </p:cNvSpPr>
-          <p:nvPr>
-            <p:ph/>
-          </p:nvPr>
-        </p:nvSpPr>
-        <p:spPr>
-          <a:xfrm>
-            <a:off x="2562606" y="4425696"/>
-            <a:ext cx="566928" cy="164592"/>
-          </a:xfrm>
-          <a:solidFill>
-            <a:srgbClr val="FFFFFF">
-              <a:alpha val="0"/>
-            </a:srgbClr>
-          </a:solidFill>
-        </p:spPr>
-        <p:txBody>
-          <a:bodyPr/>
-          <a:lstStyle/>
-          <a:p>
-            <a:pPr algn="r" marL="0" marR="0">
-              <a:lnSpc>
-                <a:spcPct val="100000"/>
-              </a:lnSpc>
-              <a:spcBef>
-                <a:spcPts val="0"/>
-              </a:spcBef>
-              <a:spcAft>
-                <a:spcPts val="0"/>
-              </a:spcAft>
-              <a:buNone/>
-            </a:pPr>
-            <a:r>
-              <a:rPr cap="none" sz="800" i="0" b="0" u="none" strike="noStrike">
-                <a:solidFill>
-                  <a:srgbClr val="808080">
-                    <a:alpha val="100000"/>
-                  </a:srgbClr>
-                </a:solidFill>
-                <a:latin typeface="Malgun Gothic"/>
-                <a:cs typeface="Malgun Gothic"/>
-                <a:ea typeface="Malgun Gothic"/>
-                <a:sym typeface="Malgun Gothic"/>
-              </a:rPr>
-              <a:t>+0.6sig</a:t>
-            </a:r>
-          </a:p>
-        </p:txBody>
-      </p:sp>
-      <p:sp>
-        <p:nvSpPr>
-          <p:cNvPr id="18" name=""/>
-          <p:cNvSpPr>
-            <a:spLocks noGrp="1"/>
-          </p:cNvSpPr>
-          <p:nvPr>
-            <p:ph/>
-          </p:nvPr>
-        </p:nvSpPr>
-        <p:spPr>
-          <a:xfrm>
-            <a:off x="3230118" y="4128516"/>
-            <a:ext cx="2827782" cy="228600"/>
-          </a:xfrm>
-          <a:solidFill>
-            <a:srgbClr val="FFFFFF">
-              <a:alpha val="0"/>
-            </a:srgbClr>
-          </a:solidFill>
-        </p:spPr>
-        <p:txBody>
-          <a:bodyPr/>
-          <a:lstStyle/>
-          <a:p>
-            <a:pPr algn="ctr" marL="0" marR="0">
-              <a:lnSpc>
-                <a:spcPct val="100000"/>
-              </a:lnSpc>
-              <a:spcBef>
-                <a:spcPts val="0"/>
-              </a:spcBef>
-              <a:spcAft>
-                <a:spcPts val="0"/>
-              </a:spcAft>
-              <a:buNone/>
-            </a:pPr>
-            <a:r>
-              <a:rPr cap="none" sz="900" i="0" b="1" u="none" strike="noStrike">
-                <a:solidFill>
-                  <a:srgbClr val="D62728">
-                    <a:alpha val="100000"/>
-                  </a:srgbClr>
-                </a:solidFill>
-                <a:latin typeface="Malgun Gothic"/>
-                <a:cs typeface="Malgun Gothic"/>
-                <a:ea typeface="Malgun Gothic"/>
-                <a:sym typeface="Malgun Gothic"/>
-              </a:rPr>
-              <a:t>⬤</a:t>
-            </a:r>
-            <a:r>
-              <a:rPr cap="none" sz="900" i="0" b="0" u="none" strike="noStrike">
-                <a:solidFill>
-                  <a:srgbClr val="333333">
-                    <a:alpha val="100000"/>
-                  </a:srgbClr>
-                </a:solidFill>
-                <a:latin typeface="Malgun Gothic"/>
-                <a:cs typeface="Malgun Gothic"/>
-                <a:ea typeface="Malgun Gothic"/>
-                <a:sym typeface="Malgun Gothic"/>
-              </a:rPr>
-              <a:t> (ML_MSR_219) Cell_TCMC_219</a:t>
-            </a:r>
-          </a:p>
-        </p:txBody>
-      </p:sp>
-      <p:pic>
-        <p:nvPicPr>
-          <p:cNvPr id="19" name="" descr=""/>
-          <p:cNvPicPr>
-            <a:picLocks noGrp="1"/>
-          </p:cNvPicPr>
-          <p:nvPr>
-            <p:ph/>
-          </p:nvPr>
-        </p:nvPicPr>
-        <p:blipFill>
-          <a:blip r:embed="rId7"/>
-          <a:stretch>
-            <a:fillRect/>
-          </a:stretch>
-        </p:blipFill>
-        <p:spPr>
-          <a:xfrm>
-            <a:off x="3230118" y="4398264"/>
-            <a:ext cx="2827782" cy="1965960"/>
-          </a:xfrm>
-          <a:prstGeom prst="rect">
-            <a:avLst/>
-          </a:prstGeom>
-        </p:spPr>
-      </p:pic>
-      <p:sp>
-        <p:nvSpPr>
-          <p:cNvPr id="20" name=""/>
-          <p:cNvSpPr>
-            <a:spLocks noGrp="1"/>
-          </p:cNvSpPr>
-          <p:nvPr>
-            <p:ph/>
-          </p:nvPr>
-        </p:nvSpPr>
-        <p:spPr>
-          <a:xfrm>
-            <a:off x="5463540" y="4425696"/>
-            <a:ext cx="566928" cy="164592"/>
-          </a:xfrm>
-          <a:solidFill>
-            <a:srgbClr val="FFFFFF">
-              <a:alpha val="0"/>
-            </a:srgbClr>
-          </a:solidFill>
-        </p:spPr>
-        <p:txBody>
-          <a:bodyPr/>
-          <a:lstStyle/>
-          <a:p>
-            <a:pPr algn="r" marL="0" marR="0">
-              <a:lnSpc>
-                <a:spcPct val="100000"/>
-              </a:lnSpc>
-              <a:spcBef>
-                <a:spcPts val="0"/>
-              </a:spcBef>
-              <a:spcAft>
-                <a:spcPts val="0"/>
-              </a:spcAft>
-              <a:buNone/>
-            </a:pPr>
-            <a:r>
-              <a:rPr cap="none" sz="800" i="0" b="0" u="none" strike="noStrike">
-                <a:solidFill>
-                  <a:srgbClr val="808080">
-                    <a:alpha val="100000"/>
-                  </a:srgbClr>
-                </a:solidFill>
-                <a:latin typeface="Malgun Gothic"/>
-                <a:cs typeface="Malgun Gothic"/>
-                <a:ea typeface="Malgun Gothic"/>
-                <a:sym typeface="Malgun Gothic"/>
-              </a:rPr>
-              <a:t>+0.5sig</a:t>
-            </a:r>
-          </a:p>
-        </p:txBody>
-      </p:sp>
-      <p:sp>
-        <p:nvSpPr>
-          <p:cNvPr id="21" name=""/>
-          <p:cNvSpPr>
-            <a:spLocks noGrp="1"/>
-          </p:cNvSpPr>
-          <p:nvPr>
-            <p:ph/>
-          </p:nvPr>
-        </p:nvSpPr>
-        <p:spPr>
-          <a:xfrm>
-            <a:off x="4642866" y="6446520"/>
-            <a:ext cx="2903220" cy="219456"/>
-          </a:xfrm>
-          <a:solidFill>
-            <a:srgbClr val="FFFFFF">
-              <a:alpha val="0"/>
-            </a:srgbClr>
-          </a:solidFill>
-        </p:spPr>
-        <p:txBody>
-          <a:bodyPr/>
-          <a:lstStyle/>
-          <a:p>
-            <a:pPr algn="ctr" marL="0" marR="0">
-              <a:lnSpc>
-                <a:spcPct val="100000"/>
-              </a:lnSpc>
-              <a:spcBef>
-                <a:spcPts val="0"/>
-              </a:spcBef>
-              <a:spcAft>
-                <a:spcPts val="0"/>
-              </a:spcAft>
-              <a:buNone/>
-            </a:pPr>
-            <a:r>
-              <a:rPr cap="none" sz="1000" i="0" b="1" u="none" strike="noStrike">
-                <a:solidFill>
-                  <a:srgbClr val="6489FA">
-                    <a:alpha val="100000"/>
-                  </a:srgbClr>
-                </a:solidFill>
-                <a:latin typeface="Malgun Gothic"/>
-                <a:cs typeface="Malgun Gothic"/>
-                <a:ea typeface="Malgun Gothic"/>
-                <a:sym typeface="Malgun Gothic"/>
-              </a:rPr>
-              <a:t>● A (REF, 16매)</a:t>
-            </a:r>
-            <a:r>
-              <a:rPr cap="none" sz="1000" i="0" b="0" u="none" strike="noStrike">
-                <a:solidFill>
-                  <a:srgbClr val="333333">
-                    <a:alpha val="100000"/>
-                  </a:srgbClr>
-                </a:solidFill>
-                <a:latin typeface="Malgun Gothic"/>
-                <a:cs typeface="Malgun Gothic"/>
-                <a:ea typeface="Malgun Gothic"/>
-                <a:sym typeface="Malgun Gothic"/>
-              </a:rPr>
-              <a:t>    </a:t>
-            </a:r>
-            <a:r>
-              <a:rPr cap="none" sz="1000" i="0" b="1" u="none" strike="noStrike">
-                <a:solidFill>
-                  <a:srgbClr val="FA7864">
-                    <a:alpha val="100000"/>
-                  </a:srgbClr>
-                </a:solidFill>
-                <a:latin typeface="Malgun Gothic"/>
-                <a:cs typeface="Malgun Gothic"/>
-                <a:ea typeface="Malgun Gothic"/>
-                <a:sym typeface="Malgun Gothic"/>
-              </a:rPr>
-              <a:t>● B (TARGET, 10매)</a:t>
-            </a:r>
-          </a:p>
-        </p:txBody>
-      </p:sp>
-      <p:sp>
-        <p:nvSpPr>
-          <p:cNvPr id="22" name="DRB_Title_Placeholder"/>
-          <p:cNvSpPr>
-            <a:spLocks noGrp="1"/>
-          </p:cNvSpPr>
-          <p:nvPr>
-            <p:ph type="title" hasCustomPrompt="1"/>
-          </p:nvPr>
-        </p:nvSpPr>
-        <p:spPr>
-          <a:xfrm>
-            <a:off x="270000" y="342000"/>
-            <a:ext cx="10302000" cy="486000"/>
-          </a:xfrm>
-        </p:spPr>
-        <p:txBody>
-          <a:bodyPr/>
-          <a:lstStyle/>
-          <a:p>
-            <a:pPr algn="l" marL="0" marR="0">
-              <a:lnSpc>
-                <a:spcPct val="100000"/>
-              </a:lnSpc>
-              <a:spcBef>
-                <a:spcPts val="0"/>
-              </a:spcBef>
-              <a:spcAft>
-                <a:spcPts val="0"/>
-              </a:spcAft>
-              <a:buNone/>
-            </a:pPr>
-            <a:r>
-              <a:rPr cap="none" sz="2800" i="0" b="1" u="none" strike="noStrike">
-                <a:solidFill>
-                  <a:srgbClr val="111111">
-                    <a:alpha val="100000"/>
-                  </a:srgbClr>
-                </a:solidFill>
-                <a:latin typeface="Malgun Gothic"/>
-                <a:cs typeface="Malgun Gothic"/>
-                <a:ea typeface="Malgun Gothic"/>
-                <a:sym typeface="Malgun Gothic"/>
-              </a:rPr>
-              <a:t>[DM] Data Review Board Auto Report</a:t>
-            </a:r>
-          </a:p>
-        </p:txBody>
-      </p:sp>
-      <p:sp>
-        <p:nvSpPr>
-          <p:cNvPr id="23" name="DRB_Body_Placeholder"/>
-          <p:cNvSpPr>
-            <a:spLocks noGrp="1"/>
-          </p:cNvSpPr>
-          <p:nvPr>
-            <p:ph idx="13" hasCustomPrompt="1"/>
-          </p:nvPr>
-        </p:nvSpPr>
-        <p:spPr>
-          <a:xfrm>
-            <a:off x="270000" y="943200"/>
-            <a:ext cx="11520000" cy="583200"/>
-          </a:xfrm>
-        </p:spPr>
-        <p:txBody>
-          <a:bodyPr/>
-          <a:lstStyle/>
-          <a:p>
-            <a:pPr algn="l" marL="0" marR="0">
-              <a:lnSpc>
-                <a:spcPct val="100000"/>
-              </a:lnSpc>
-              <a:spcBef>
-                <a:spcPts val="0"/>
-              </a:spcBef>
-              <a:spcAft>
-                <a:spcPts val="0"/>
-              </a:spcAft>
-              <a:buNone/>
-            </a:pPr>
-            <a:r>
-              <a:rPr cap="none" sz="1300" i="0" b="1" u="none" strike="noStrike">
-                <a:solidFill>
-                  <a:srgbClr val="333333">
-                    <a:alpha val="100000"/>
-                  </a:srgbClr>
-                </a:solidFill>
-                <a:latin typeface="Malgun Gothic"/>
-                <a:cs typeface="Malgun Gothic"/>
-                <a:ea typeface="Malgun Gothic"/>
-                <a:sym typeface="Malgun Gothic"/>
-              </a:rPr>
-              <a:t>■</a:t>
-            </a:r>
-            <a:r>
-              <a:rPr cap="none" sz="1300" i="0" b="1" u="none" strike="noStrike">
-                <a:solidFill>
-                  <a:srgbClr val="333333">
-                    <a:alpha val="100000"/>
-                  </a:srgbClr>
-                </a:solidFill>
-                <a:latin typeface="Malgun Gothic"/>
-                <a:cs typeface="Malgun Gothic"/>
-                <a:ea typeface="Malgun Gothic"/>
-                <a:sym typeface="Malgun Gothic"/>
-              </a:rPr>
-              <a:t> Category: Category2: TCMC | Showing MSR 1-6 of 6</a:t>
-            </a:r>
-          </a:p>
-          <a:p>
-            <a:pPr algn="l" marL="0" marR="0">
-              <a:lnSpc>
-                <a:spcPct val="100000"/>
-              </a:lnSpc>
-              <a:spcBef>
-                <a:spcPts val="0"/>
-              </a:spcBef>
-              <a:spcAft>
-                <a:spcPts val="0"/>
-              </a:spcAft>
-              <a:buNone/>
-            </a:pPr>
-            <a:r>
-              <a:rPr cap="none" sz="1300" i="0" b="1" u="none" strike="noStrike">
-                <a:solidFill>
-                  <a:srgbClr val="333333">
-                    <a:alpha val="100000"/>
-                  </a:srgbClr>
-                </a:solidFill>
-                <a:latin typeface="Malgun Gothic"/>
-                <a:cs typeface="Malgun Gothic"/>
-                <a:ea typeface="Malgun Gothic"/>
-                <a:sym typeface="Malgun Gothic"/>
-              </a:rPr>
-              <a:t>■</a:t>
-            </a:r>
-            <a:r>
-              <a:rPr cap="none" sz="1300" i="0" b="1" u="none" strike="noStrike">
-                <a:solidFill>
-                  <a:srgbClr val="333333">
-                    <a:alpha val="100000"/>
-                  </a:srgbClr>
-                </a:solidFill>
-                <a:latin typeface="Malgun Gothic"/>
-                <a:cs typeface="Malgun Gothic"/>
-                <a:ea typeface="Malgun Gothic"/>
-                <a:sym typeface="Malgun Gothic"/>
-              </a:rPr>
-              <a:t> REF: A / TARGET: B | Threshold: 0.5</a:t>
-            </a:r>
-          </a:p>
-        </p:txBody>
-      </p:sp>
-      <p:sp>
-        <p:nvSpPr>
-          <p:cNvPr id="24" name=""/>
           <p:cNvSpPr>
             <a:spLocks noGrp="1"/>
           </p:cNvSpPr>

</xml_diff>